<commit_message>
Auto-scroll code slides to the line to type, and mark replaced lines
Two deck changes:

Scroll: a code slide taller than the screen now jumps to the newest line the
moment it opens, so the line to type and its note are on screen without the
teacher scrolling down. The line to type is always the last row of the block.
Re-runs after web fonts load (they change the height) and on any resize or
full-screen toggle.

Replacements: a line that is swapped out - not only one purely deleted - now
shows struck through in red with a "replace a line" slide, then the green
"type this" slide for its replacement. To avoid striking lines that only move
or lose a comment (week 5 wraps three unchanged lines in try/catch), lines are
compared by a code signature - whitespace collapsed, comments dropped - and a
line is struck only when nothing with its signature survives.

Co-Authored-By: Claude Opus 4.8 <noreply@anthropic.com>
</commit_message>
<xml_diff>
--- a/ai101/slides/week-04.pptx
+++ b/ai101/slides/week-04.pptx
@@ -46,6 +46,10 @@
     <p:sldId id="294" r:id="rId45"/>
     <p:sldId id="295" r:id="rId46"/>
     <p:sldId id="296" r:id="rId47"/>
+    <p:sldId id="297" r:id="rId48"/>
+    <p:sldId id="298" r:id="rId49"/>
+    <p:sldId id="299" r:id="rId50"/>
+    <p:sldId id="300" r:id="rId51"/>
   </p:sldIdLst>
   <p:sldSz cx="12191695" cy="6858000" type="screen4x3"/>
   <p:notesSz cx="6858000" cy="9144000"/>
@@ -11049,7 +11053,7 @@
                   <a:srgbClr val="01AEFD"/>
                 </a:solidFill>
               </a:rPr>
-              <a:t>Type this into script.js   -   line 60</a:t>
+              <a:t>In script.js   -   replace a line</a:t>
             </a:r>
           </a:p>
         </p:txBody>
@@ -11113,16 +11117,16 @@
                 </a:solidFill>
                 <a:latin typeface="Consolas"/>
               </a:rPr>
-              <a:t>  60  </a:t>
-            </a:r>
-            <a:r>
-              <a:rPr sz="1800">
-                <a:solidFill>
-                  <a:srgbClr val="7FE0A0"/>
-                </a:solidFill>
-                <a:latin typeface="Consolas"/>
-              </a:rPr>
-              <a:t>// The browser calls this when the form is submitted.</a:t>
+              <a:t>   -  </a:t>
+            </a:r>
+            <a:r>
+              <a:rPr sz="1800" strike="sngStrike">
+                <a:solidFill>
+                  <a:srgbClr val="F3928B"/>
+                </a:solidFill>
+                <a:latin typeface="Consolas"/>
+              </a:rPr>
+              <a:t>// In PixelPad your loop() checked 'was a key pressed?' every frame. Here you</a:t>
             </a:r>
           </a:p>
         </p:txBody>
@@ -11155,7 +11159,7 @@
                   <a:srgbClr val="DCECEF"/>
                 </a:solidFill>
               </a:rPr>
-              <a:t>A comment: the browser calls this when the form is submitted.</a:t>
+              <a:t>This line changes - take the old one out; the new version is next.</a:t>
             </a:r>
           </a:p>
         </p:txBody>
@@ -11214,7 +11218,7 @@
                   <a:srgbClr val="01AEFD"/>
                 </a:solidFill>
               </a:rPr>
-              <a:t>Type this into script.js   -   line 61</a:t>
+              <a:t>In script.js   -   replace a line</a:t>
             </a:r>
           </a:p>
         </p:txBody>
@@ -11278,41 +11282,16 @@
                 </a:solidFill>
                 <a:latin typeface="Consolas"/>
               </a:rPr>
-              <a:t>  60  </a:t>
-            </a:r>
-            <a:r>
-              <a:rPr sz="1800">
-                <a:solidFill>
-                  <a:srgbClr val="6D8C97"/>
-                </a:solidFill>
-                <a:latin typeface="Consolas"/>
-              </a:rPr>
-              <a:t>// The browser calls this when the form is submitted.</a:t>
-            </a:r>
-          </a:p>
-          <a:p>
-            <a:pPr>
-              <a:spcAft>
-                <a:spcPts val="0"/>
-              </a:spcAft>
-            </a:pPr>
-            <a:r>
-              <a:rPr sz="1800">
-                <a:solidFill>
-                  <a:srgbClr val="6D8C97"/>
-                </a:solidFill>
-                <a:latin typeface="Consolas"/>
-              </a:rPr>
-              <a:t>  61  </a:t>
-            </a:r>
-            <a:r>
-              <a:rPr sz="1800">
-                <a:solidFill>
-                  <a:srgbClr val="7FE0A0"/>
-                </a:solidFill>
-                <a:latin typeface="Consolas"/>
-              </a:rPr>
-              <a:t>composer.addEventListener('submit', async function (event) {</a:t>
+              <a:t>   -  </a:t>
+            </a:r>
+            <a:r>
+              <a:rPr sz="1800" strike="sngStrike">
+                <a:solidFill>
+                  <a:srgbClr val="F3928B"/>
+                </a:solidFill>
+                <a:latin typeface="Consolas"/>
+              </a:rPr>
+              <a:t>// leave a note: when this form is submitted, run this. The browser waits.</a:t>
             </a:r>
           </a:p>
         </p:txBody>
@@ -11345,7 +11324,7 @@
                   <a:srgbClr val="DCECEF"/>
                 </a:solidFill>
               </a:rPr>
-              <a:t>Add async so we are allowed to await the slow AI call inside.</a:t>
+              <a:t>This line changes - take the old one out; the new version is next.</a:t>
             </a:r>
           </a:p>
         </p:txBody>
@@ -11404,7 +11383,7 @@
                   <a:srgbClr val="01AEFD"/>
                 </a:solidFill>
               </a:rPr>
-              <a:t>Type this into script.js   -   line 67</a:t>
+              <a:t>In script.js   -   replace a line</a:t>
             </a:r>
           </a:p>
         </p:txBody>
@@ -11468,191 +11447,16 @@
                 </a:solidFill>
                 <a:latin typeface="Consolas"/>
               </a:rPr>
-              <a:t>  60  </a:t>
-            </a:r>
-            <a:r>
-              <a:rPr sz="1800">
-                <a:solidFill>
-                  <a:srgbClr val="6D8C97"/>
-                </a:solidFill>
-                <a:latin typeface="Consolas"/>
-              </a:rPr>
-              <a:t>// The browser calls this when the form is submitted.</a:t>
-            </a:r>
-          </a:p>
-          <a:p>
-            <a:pPr>
-              <a:spcAft>
-                <a:spcPts val="0"/>
-              </a:spcAft>
-            </a:pPr>
-            <a:r>
-              <a:rPr sz="1800">
-                <a:solidFill>
-                  <a:srgbClr val="6D8C97"/>
-                </a:solidFill>
-                <a:latin typeface="Consolas"/>
-              </a:rPr>
-              <a:t>  61  </a:t>
-            </a:r>
-            <a:r>
-              <a:rPr sz="1800">
-                <a:solidFill>
-                  <a:srgbClr val="6D8C97"/>
-                </a:solidFill>
-                <a:latin typeface="Consolas"/>
-              </a:rPr>
-              <a:t>composer.addEventListener('submit', async function (event) {</a:t>
-            </a:r>
-          </a:p>
-          <a:p>
-            <a:pPr>
-              <a:spcAft>
-                <a:spcPts val="0"/>
-              </a:spcAft>
-            </a:pPr>
-            <a:r>
-              <a:rPr sz="1800">
-                <a:solidFill>
-                  <a:srgbClr val="6D8C97"/>
-                </a:solidFill>
-                <a:latin typeface="Consolas"/>
-              </a:rPr>
-              <a:t>  62  </a:t>
-            </a:r>
-            <a:r>
-              <a:rPr sz="1800">
-                <a:solidFill>
-                  <a:srgbClr val="6D8C97"/>
-                </a:solidFill>
-                <a:latin typeface="Consolas"/>
-              </a:rPr>
-              <a:t>  event.preventDefault();</a:t>
-            </a:r>
-          </a:p>
-          <a:p>
-            <a:pPr>
-              <a:spcAft>
-                <a:spcPts val="0"/>
-              </a:spcAft>
-            </a:pPr>
-            <a:r>
-              <a:rPr sz="1800">
-                <a:solidFill>
-                  <a:srgbClr val="6D8C97"/>
-                </a:solidFill>
-                <a:latin typeface="Consolas"/>
-              </a:rPr>
-              <a:t>  63  </a:t>
-            </a:r>
-            <a:r>
-              <a:rPr sz="1800">
-                <a:solidFill>
-                  <a:srgbClr val="6D8C97"/>
-                </a:solidFill>
-                <a:latin typeface="Consolas"/>
-              </a:rPr>
-              <a:t>  const text = promptBox.value.trim();</a:t>
-            </a:r>
-          </a:p>
-          <a:p>
-            <a:pPr>
-              <a:spcAft>
-                <a:spcPts val="0"/>
-              </a:spcAft>
-            </a:pPr>
-            <a:r>
-              <a:rPr sz="1800">
-                <a:solidFill>
-                  <a:srgbClr val="6D8C97"/>
-                </a:solidFill>
-                <a:latin typeface="Consolas"/>
-              </a:rPr>
-              <a:t>  64  </a:t>
-            </a:r>
-            <a:r>
-              <a:rPr sz="1800">
-                <a:solidFill>
-                  <a:srgbClr val="6D8C97"/>
-                </a:solidFill>
-                <a:latin typeface="Consolas"/>
-              </a:rPr>
-              <a:t>  if (text === '') { return; }</a:t>
-            </a:r>
-          </a:p>
-          <a:p>
-            <a:pPr>
-              <a:spcAft>
-                <a:spcPts val="0"/>
-              </a:spcAft>
-            </a:pPr>
-            <a:r>
-              <a:rPr sz="1800">
-                <a:solidFill>
-                  <a:srgbClr val="6D8C97"/>
-                </a:solidFill>
-                <a:latin typeface="Consolas"/>
-              </a:rPr>
-              <a:t>  65  </a:t>
-            </a:r>
-            <a:r>
-              <a:rPr sz="1800">
-                <a:solidFill>
-                  <a:srgbClr val="6D8C97"/>
-                </a:solidFill>
-                <a:latin typeface="Consolas"/>
-              </a:rPr>
-              <a:t>  promptBox.value = '';</a:t>
-            </a:r>
-          </a:p>
-          <a:p>
-            <a:pPr>
-              <a:spcAft>
-                <a:spcPts val="0"/>
-              </a:spcAft>
-            </a:pPr>
-            <a:r>
-              <a:rPr sz="1800">
-                <a:solidFill>
-                  <a:srgbClr val="6D8C97"/>
-                </a:solidFill>
-                <a:latin typeface="Consolas"/>
-              </a:rPr>
-              <a:t>  66  </a:t>
-            </a:r>
-            <a:r>
-              <a:rPr sz="1800">
-                <a:solidFill>
-                  <a:srgbClr val="6D8C97"/>
-                </a:solidFill>
-                <a:latin typeface="Consolas"/>
-              </a:rPr>
-              <a:t>  addLine('You', text);</a:t>
-            </a:r>
-          </a:p>
-          <a:p>
-            <a:pPr>
-              <a:spcAft>
-                <a:spcPts val="0"/>
-              </a:spcAft>
-            </a:pPr>
-            <a:r>
-              <a:rPr sz="1800">
-                <a:solidFill>
-                  <a:srgbClr val="6D8C97"/>
-                </a:solidFill>
-                <a:latin typeface="Consolas"/>
-              </a:rPr>
-              <a:t>  67  </a:t>
-            </a:r>
-            <a:r>
-              <a:rPr sz="1800">
-                <a:solidFill>
-                  <a:srgbClr val="7FE0A0"/>
-                </a:solidFill>
-                <a:latin typeface="Consolas"/>
-              </a:rPr>
-              <a:t>  addLine('Companion', 'thinking...');</a:t>
+              <a:t>   -  </a:t>
+            </a:r>
+            <a:r>
+              <a:rPr sz="1800" strike="sngStrike">
+                <a:solidFill>
+                  <a:srgbClr val="F3928B"/>
+                </a:solidFill>
+                <a:latin typeface="Consolas"/>
+              </a:rPr>
+              <a:t>composer.addEventListener('submit', function (event) {</a:t>
             </a:r>
           </a:p>
         </p:txBody>
@@ -11685,7 +11489,7 @@
                   <a:srgbClr val="DCECEF"/>
                 </a:solidFill>
               </a:rPr>
-              <a:t>Change the pretend reply to a 'thinking...' line while we wait.</a:t>
+              <a:t>This line changes - take the old one out; the new version is next.</a:t>
             </a:r>
           </a:p>
         </p:txBody>
@@ -11744,7 +11548,7 @@
                   <a:srgbClr val="01AEFD"/>
                 </a:solidFill>
               </a:rPr>
-              <a:t>Type this into script.js   -   line 68</a:t>
+              <a:t>Type this into script.js   -   line 60</a:t>
             </a:r>
           </a:p>
         </p:txBody>
@@ -11813,211 +11617,11 @@
             <a:r>
               <a:rPr sz="1800">
                 <a:solidFill>
-                  <a:srgbClr val="6D8C97"/>
+                  <a:srgbClr val="7FE0A0"/>
                 </a:solidFill>
                 <a:latin typeface="Consolas"/>
               </a:rPr>
               <a:t>// The browser calls this when the form is submitted.</a:t>
-            </a:r>
-          </a:p>
-          <a:p>
-            <a:pPr>
-              <a:spcAft>
-                <a:spcPts val="0"/>
-              </a:spcAft>
-            </a:pPr>
-            <a:r>
-              <a:rPr sz="1800">
-                <a:solidFill>
-                  <a:srgbClr val="6D8C97"/>
-                </a:solidFill>
-                <a:latin typeface="Consolas"/>
-              </a:rPr>
-              <a:t>  61  </a:t>
-            </a:r>
-            <a:r>
-              <a:rPr sz="1800">
-                <a:solidFill>
-                  <a:srgbClr val="6D8C97"/>
-                </a:solidFill>
-                <a:latin typeface="Consolas"/>
-              </a:rPr>
-              <a:t>composer.addEventListener('submit', async function (event) {</a:t>
-            </a:r>
-          </a:p>
-          <a:p>
-            <a:pPr>
-              <a:spcAft>
-                <a:spcPts val="0"/>
-              </a:spcAft>
-            </a:pPr>
-            <a:r>
-              <a:rPr sz="1800">
-                <a:solidFill>
-                  <a:srgbClr val="6D8C97"/>
-                </a:solidFill>
-                <a:latin typeface="Consolas"/>
-              </a:rPr>
-              <a:t>  62  </a:t>
-            </a:r>
-            <a:r>
-              <a:rPr sz="1800">
-                <a:solidFill>
-                  <a:srgbClr val="6D8C97"/>
-                </a:solidFill>
-                <a:latin typeface="Consolas"/>
-              </a:rPr>
-              <a:t>  event.preventDefault();</a:t>
-            </a:r>
-          </a:p>
-          <a:p>
-            <a:pPr>
-              <a:spcAft>
-                <a:spcPts val="0"/>
-              </a:spcAft>
-            </a:pPr>
-            <a:r>
-              <a:rPr sz="1800">
-                <a:solidFill>
-                  <a:srgbClr val="6D8C97"/>
-                </a:solidFill>
-                <a:latin typeface="Consolas"/>
-              </a:rPr>
-              <a:t>  63  </a:t>
-            </a:r>
-            <a:r>
-              <a:rPr sz="1800">
-                <a:solidFill>
-                  <a:srgbClr val="6D8C97"/>
-                </a:solidFill>
-                <a:latin typeface="Consolas"/>
-              </a:rPr>
-              <a:t>  const text = promptBox.value.trim();</a:t>
-            </a:r>
-          </a:p>
-          <a:p>
-            <a:pPr>
-              <a:spcAft>
-                <a:spcPts val="0"/>
-              </a:spcAft>
-            </a:pPr>
-            <a:r>
-              <a:rPr sz="1800">
-                <a:solidFill>
-                  <a:srgbClr val="6D8C97"/>
-                </a:solidFill>
-                <a:latin typeface="Consolas"/>
-              </a:rPr>
-              <a:t>  64  </a:t>
-            </a:r>
-            <a:r>
-              <a:rPr sz="1800">
-                <a:solidFill>
-                  <a:srgbClr val="6D8C97"/>
-                </a:solidFill>
-                <a:latin typeface="Consolas"/>
-              </a:rPr>
-              <a:t>  if (text === '') { return; }</a:t>
-            </a:r>
-          </a:p>
-          <a:p>
-            <a:pPr>
-              <a:spcAft>
-                <a:spcPts val="0"/>
-              </a:spcAft>
-            </a:pPr>
-            <a:r>
-              <a:rPr sz="1800">
-                <a:solidFill>
-                  <a:srgbClr val="6D8C97"/>
-                </a:solidFill>
-                <a:latin typeface="Consolas"/>
-              </a:rPr>
-              <a:t>  65  </a:t>
-            </a:r>
-            <a:r>
-              <a:rPr sz="1800">
-                <a:solidFill>
-                  <a:srgbClr val="6D8C97"/>
-                </a:solidFill>
-                <a:latin typeface="Consolas"/>
-              </a:rPr>
-              <a:t>  promptBox.value = '';</a:t>
-            </a:r>
-          </a:p>
-          <a:p>
-            <a:pPr>
-              <a:spcAft>
-                <a:spcPts val="0"/>
-              </a:spcAft>
-            </a:pPr>
-            <a:r>
-              <a:rPr sz="1800">
-                <a:solidFill>
-                  <a:srgbClr val="6D8C97"/>
-                </a:solidFill>
-                <a:latin typeface="Consolas"/>
-              </a:rPr>
-              <a:t>  66  </a:t>
-            </a:r>
-            <a:r>
-              <a:rPr sz="1800">
-                <a:solidFill>
-                  <a:srgbClr val="6D8C97"/>
-                </a:solidFill>
-                <a:latin typeface="Consolas"/>
-              </a:rPr>
-              <a:t>  addLine('You', text);</a:t>
-            </a:r>
-          </a:p>
-          <a:p>
-            <a:pPr>
-              <a:spcAft>
-                <a:spcPts val="0"/>
-              </a:spcAft>
-            </a:pPr>
-            <a:r>
-              <a:rPr sz="1800">
-                <a:solidFill>
-                  <a:srgbClr val="6D8C97"/>
-                </a:solidFill>
-                <a:latin typeface="Consolas"/>
-              </a:rPr>
-              <a:t>  67  </a:t>
-            </a:r>
-            <a:r>
-              <a:rPr sz="1800">
-                <a:solidFill>
-                  <a:srgbClr val="6D8C97"/>
-                </a:solidFill>
-                <a:latin typeface="Consolas"/>
-              </a:rPr>
-              <a:t>  addLine('Companion', 'thinking...');</a:t>
-            </a:r>
-          </a:p>
-          <a:p>
-            <a:pPr>
-              <a:spcAft>
-                <a:spcPts val="0"/>
-              </a:spcAft>
-            </a:pPr>
-            <a:r>
-              <a:rPr sz="1800">
-                <a:solidFill>
-                  <a:srgbClr val="6D8C97"/>
-                </a:solidFill>
-                <a:latin typeface="Consolas"/>
-              </a:rPr>
-              <a:t>  68  </a:t>
-            </a:r>
-            <a:r>
-              <a:rPr sz="1800">
-                <a:solidFill>
-                  <a:srgbClr val="7FE0A0"/>
-                </a:solidFill>
-                <a:latin typeface="Consolas"/>
-              </a:rPr>
-              <a:t>  const reply = await askAI(text);       // this is the slow bit</a:t>
             </a:r>
           </a:p>
         </p:txBody>
@@ -12050,7 +11654,7 @@
                   <a:srgbClr val="DCECEF"/>
                 </a:solidFill>
               </a:rPr>
-              <a:t>await askAI(text): the slow bit - ask the AI and wait for the answer.</a:t>
+              <a:t>A comment: the browser calls this when the form is submitted.</a:t>
             </a:r>
           </a:p>
         </p:txBody>
@@ -12066,6 +11670,14 @@
 <file path=ppt/slides/slide34.xml><?xml version="1.0" encoding="utf-8"?>
 <p:sld xmlns:a="http://schemas.openxmlformats.org/drawingml/2006/main" xmlns:p="http://schemas.openxmlformats.org/presentationml/2006/main" xmlns:r="http://schemas.openxmlformats.org/officeDocument/2006/relationships">
   <p:cSld>
+    <p:bg>
+      <p:bgPr>
+        <a:solidFill>
+          <a:srgbClr val="102127"/>
+        </a:solidFill>
+        <a:effectLst/>
+      </p:bgPr>
+    </p:bg>
     <p:spTree>
       <p:nvGrpSpPr>
         <p:cNvPr id="1" name=""/>
@@ -12075,40 +11687,14 @@
       <p:grpSpPr/>
       <p:sp>
         <p:nvSpPr>
-          <p:cNvPr id="2" name="Title 1"/>
-          <p:cNvSpPr>
-            <a:spLocks noGrp="1"/>
-          </p:cNvSpPr>
-          <p:nvPr>
-            <p:ph type="title"/>
-          </p:nvPr>
-        </p:nvSpPr>
-        <p:spPr/>
-        <p:txBody>
-          <a:bodyPr/>
-          <a:lstStyle/>
-          <a:p>
-            <a:r>
-              <a:rPr sz="3800" b="1">
-                <a:solidFill>
-                  <a:srgbClr val="1F2A37"/>
-                </a:solidFill>
-              </a:rPr>
-              <a:t>.lastChild</a:t>
-            </a:r>
-          </a:p>
-        </p:txBody>
-      </p:sp>
-      <p:sp>
-        <p:nvSpPr>
-          <p:cNvPr id="3" name="TextBox 2"/>
+          <p:cNvPr id="2" name="TextBox 1"/>
           <p:cNvSpPr txBox="1"/>
           <p:nvPr/>
         </p:nvSpPr>
         <p:spPr>
           <a:xfrm>
-            <a:off x="868680" y="502920"/>
-            <a:ext cx="5486400" cy="457200"/>
+            <a:off x="502920" y="274320"/>
+            <a:ext cx="11155680" cy="548640"/>
           </a:xfrm>
           <a:prstGeom prst="rect">
             <a:avLst/>
@@ -12122,26 +11708,26 @@
           <a:lstStyle/>
           <a:p>
             <a:r>
-              <a:rPr sz="1500" b="1">
+              <a:rPr sz="2200" b="1">
                 <a:solidFill>
                   <a:srgbClr val="01AEFD"/>
                 </a:solidFill>
               </a:rPr>
-              <a:t>JAVASCRIPT</a:t>
-            </a:r>
-          </a:p>
-        </p:txBody>
-      </p:sp>
-      <p:sp>
-        <p:nvSpPr>
-          <p:cNvPr id="4" name="TextBox 3"/>
+              <a:t>Type this into script.js   -   line 61</a:t>
+            </a:r>
+          </a:p>
+        </p:txBody>
+      </p:sp>
+      <p:sp>
+        <p:nvSpPr>
+          <p:cNvPr id="3" name="TextBox 2"/>
           <p:cNvSpPr txBox="1"/>
           <p:nvPr/>
         </p:nvSpPr>
         <p:spPr>
           <a:xfrm>
-            <a:off x="822960" y="1828800"/>
-            <a:ext cx="10515600" cy="4206240"/>
+            <a:off x="502920" y="960120"/>
+            <a:ext cx="11155680" cy="4297680"/>
           </a:xfrm>
           <a:prstGeom prst="rect">
             <a:avLst/>
@@ -12149,38 +11735,116 @@
           <a:noFill/>
         </p:spPr>
         <p:txBody>
+          <a:bodyPr wrap="none">
+            <a:spAutoFit/>
+          </a:bodyPr>
+          <a:lstStyle/>
+          <a:p>
+            <a:pPr>
+              <a:spcAft>
+                <a:spcPts val="0"/>
+              </a:spcAft>
+            </a:pPr>
+            <a:r>
+              <a:rPr sz="1800">
+                <a:solidFill>
+                  <a:srgbClr val="6D8C97"/>
+                </a:solidFill>
+                <a:latin typeface="Consolas"/>
+              </a:rPr>
+              <a:t>  59  </a:t>
+            </a:r>
+            <a:r>
+              <a:rPr sz="1800">
+                <a:solidFill>
+                  <a:srgbClr val="6D8C97"/>
+                </a:solidFill>
+                <a:latin typeface="Consolas"/>
+              </a:rPr>
+              <a:t> </a:t>
+            </a:r>
+          </a:p>
+          <a:p>
+            <a:pPr>
+              <a:spcAft>
+                <a:spcPts val="0"/>
+              </a:spcAft>
+            </a:pPr>
+            <a:r>
+              <a:rPr sz="1800">
+                <a:solidFill>
+                  <a:srgbClr val="6D8C97"/>
+                </a:solidFill>
+                <a:latin typeface="Consolas"/>
+              </a:rPr>
+              <a:t>  60  </a:t>
+            </a:r>
+            <a:r>
+              <a:rPr sz="1800">
+                <a:solidFill>
+                  <a:srgbClr val="6D8C97"/>
+                </a:solidFill>
+                <a:latin typeface="Consolas"/>
+              </a:rPr>
+              <a:t>// The browser calls this when the form is submitted.</a:t>
+            </a:r>
+          </a:p>
+          <a:p>
+            <a:pPr>
+              <a:spcAft>
+                <a:spcPts val="0"/>
+              </a:spcAft>
+            </a:pPr>
+            <a:r>
+              <a:rPr sz="1800">
+                <a:solidFill>
+                  <a:srgbClr val="6D8C97"/>
+                </a:solidFill>
+                <a:latin typeface="Consolas"/>
+              </a:rPr>
+              <a:t>  61  </a:t>
+            </a:r>
+            <a:r>
+              <a:rPr sz="1800">
+                <a:solidFill>
+                  <a:srgbClr val="7FE0A0"/>
+                </a:solidFill>
+                <a:latin typeface="Consolas"/>
+              </a:rPr>
+              <a:t>composer.addEventListener('submit', async function (event) {</a:t>
+            </a:r>
+          </a:p>
+        </p:txBody>
+      </p:sp>
+      <p:sp>
+        <p:nvSpPr>
+          <p:cNvPr id="4" name="TextBox 3"/>
+          <p:cNvSpPr txBox="1"/>
+          <p:nvPr/>
+        </p:nvSpPr>
+        <p:spPr>
+          <a:xfrm>
+            <a:off x="548640" y="5623560"/>
+            <a:ext cx="11064240" cy="1051560"/>
+          </a:xfrm>
+          <a:prstGeom prst="rect">
+            <a:avLst/>
+          </a:prstGeom>
+          <a:noFill/>
+        </p:spPr>
+        <p:txBody>
           <a:bodyPr wrap="square">
             <a:spAutoFit/>
           </a:bodyPr>
           <a:lstStyle/>
           <a:p>
-            <a:pPr>
-              <a:spcAft>
-                <a:spcPts val="1400"/>
-              </a:spcAft>
-            </a:pPr>
-            <a:r>
-              <a:rPr sz="2400">
-                <a:solidFill>
-                  <a:srgbClr val="1F2A37"/>
-                </a:solidFill>
-              </a:rPr>
-              <a:t>• A box's LAST child - the newest thing added inside it.</a:t>
-            </a:r>
-          </a:p>
-          <a:p>
-            <a:pPr>
-              <a:spcAft>
-                <a:spcPts val="1400"/>
-              </a:spcAft>
-            </a:pPr>
-            <a:r>
-              <a:rPr sz="2400">
-                <a:solidFill>
-                  <a:srgbClr val="1F2A37"/>
-                </a:solidFill>
-              </a:rPr>
-              <a:t>• chat.lastChild is the message you just put in.</a:t>
+            <a:r>
+              <a:rPr sz="2000">
+                <a:solidFill>
+                  <a:srgbClr val="DCECEF"/>
+                </a:solidFill>
+              </a:rPr>
+              <a:t>Add async so we are allowed to await the slow AI call inside.</a:t>
             </a:r>
           </a:p>
         </p:txBody>
@@ -12196,6 +11860,14 @@
 <file path=ppt/slides/slide35.xml><?xml version="1.0" encoding="utf-8"?>
 <p:sld xmlns:a="http://schemas.openxmlformats.org/drawingml/2006/main" xmlns:p="http://schemas.openxmlformats.org/presentationml/2006/main" xmlns:r="http://schemas.openxmlformats.org/officeDocument/2006/relationships">
   <p:cSld>
+    <p:bg>
+      <p:bgPr>
+        <a:solidFill>
+          <a:srgbClr val="102127"/>
+        </a:solidFill>
+        <a:effectLst/>
+      </p:bgPr>
+    </p:bg>
     <p:spTree>
       <p:nvGrpSpPr>
         <p:cNvPr id="1" name=""/>
@@ -12205,40 +11877,14 @@
       <p:grpSpPr/>
       <p:sp>
         <p:nvSpPr>
-          <p:cNvPr id="2" name="Title 1"/>
-          <p:cNvSpPr>
-            <a:spLocks noGrp="1"/>
-          </p:cNvSpPr>
-          <p:nvPr>
-            <p:ph type="title"/>
-          </p:nvPr>
-        </p:nvSpPr>
-        <p:spPr/>
-        <p:txBody>
-          <a:bodyPr/>
-          <a:lstStyle/>
-          <a:p>
-            <a:r>
-              <a:rPr sz="3800" b="1">
-                <a:solidFill>
-                  <a:srgbClr val="1F2A37"/>
-                </a:solidFill>
-              </a:rPr>
-              <a:t>.remove()</a:t>
-            </a:r>
-          </a:p>
-        </p:txBody>
-      </p:sp>
-      <p:sp>
-        <p:nvSpPr>
-          <p:cNvPr id="3" name="TextBox 2"/>
+          <p:cNvPr id="2" name="TextBox 1"/>
           <p:cNvSpPr txBox="1"/>
           <p:nvPr/>
         </p:nvSpPr>
         <p:spPr>
           <a:xfrm>
-            <a:off x="868680" y="502920"/>
-            <a:ext cx="5486400" cy="457200"/>
+            <a:off x="502920" y="274320"/>
+            <a:ext cx="11155680" cy="548640"/>
           </a:xfrm>
           <a:prstGeom prst="rect">
             <a:avLst/>
@@ -12252,26 +11898,26 @@
           <a:lstStyle/>
           <a:p>
             <a:r>
-              <a:rPr sz="1500" b="1">
+              <a:rPr sz="2200" b="1">
                 <a:solidFill>
                   <a:srgbClr val="01AEFD"/>
                 </a:solidFill>
               </a:rPr>
-              <a:t>JAVASCRIPT</a:t>
-            </a:r>
-          </a:p>
-        </p:txBody>
-      </p:sp>
-      <p:sp>
-        <p:nvSpPr>
-          <p:cNvPr id="4" name="TextBox 3"/>
+              <a:t>In script.js   -   replace a line</a:t>
+            </a:r>
+          </a:p>
+        </p:txBody>
+      </p:sp>
+      <p:sp>
+        <p:nvSpPr>
+          <p:cNvPr id="3" name="TextBox 2"/>
           <p:cNvSpPr txBox="1"/>
           <p:nvPr/>
         </p:nvSpPr>
         <p:spPr>
           <a:xfrm>
-            <a:off x="822960" y="1828800"/>
-            <a:ext cx="10515600" cy="4206240"/>
+            <a:off x="502920" y="960120"/>
+            <a:ext cx="11155680" cy="4297680"/>
           </a:xfrm>
           <a:prstGeom prst="rect">
             <a:avLst/>
@@ -12279,38 +11925,266 @@
           <a:noFill/>
         </p:spPr>
         <p:txBody>
+          <a:bodyPr wrap="none">
+            <a:spAutoFit/>
+          </a:bodyPr>
+          <a:lstStyle/>
+          <a:p>
+            <a:pPr>
+              <a:spcAft>
+                <a:spcPts val="0"/>
+              </a:spcAft>
+            </a:pPr>
+            <a:r>
+              <a:rPr sz="1800">
+                <a:solidFill>
+                  <a:srgbClr val="6D8C97"/>
+                </a:solidFill>
+                <a:latin typeface="Consolas"/>
+              </a:rPr>
+              <a:t>  59  </a:t>
+            </a:r>
+            <a:r>
+              <a:rPr sz="1800">
+                <a:solidFill>
+                  <a:srgbClr val="6D8C97"/>
+                </a:solidFill>
+                <a:latin typeface="Consolas"/>
+              </a:rPr>
+              <a:t> </a:t>
+            </a:r>
+          </a:p>
+          <a:p>
+            <a:pPr>
+              <a:spcAft>
+                <a:spcPts val="0"/>
+              </a:spcAft>
+            </a:pPr>
+            <a:r>
+              <a:rPr sz="1800">
+                <a:solidFill>
+                  <a:srgbClr val="6D8C97"/>
+                </a:solidFill>
+                <a:latin typeface="Consolas"/>
+              </a:rPr>
+              <a:t>  60  </a:t>
+            </a:r>
+            <a:r>
+              <a:rPr sz="1800">
+                <a:solidFill>
+                  <a:srgbClr val="6D8C97"/>
+                </a:solidFill>
+                <a:latin typeface="Consolas"/>
+              </a:rPr>
+              <a:t>// The browser calls this when the form is submitted.</a:t>
+            </a:r>
+          </a:p>
+          <a:p>
+            <a:pPr>
+              <a:spcAft>
+                <a:spcPts val="0"/>
+              </a:spcAft>
+            </a:pPr>
+            <a:r>
+              <a:rPr sz="1800">
+                <a:solidFill>
+                  <a:srgbClr val="6D8C97"/>
+                </a:solidFill>
+                <a:latin typeface="Consolas"/>
+              </a:rPr>
+              <a:t>  61  </a:t>
+            </a:r>
+            <a:r>
+              <a:rPr sz="1800">
+                <a:solidFill>
+                  <a:srgbClr val="6D8C97"/>
+                </a:solidFill>
+                <a:latin typeface="Consolas"/>
+              </a:rPr>
+              <a:t>composer.addEventListener('submit', async function (event) {</a:t>
+            </a:r>
+          </a:p>
+          <a:p>
+            <a:pPr>
+              <a:spcAft>
+                <a:spcPts val="0"/>
+              </a:spcAft>
+            </a:pPr>
+            <a:r>
+              <a:rPr sz="1800">
+                <a:solidFill>
+                  <a:srgbClr val="6D8C97"/>
+                </a:solidFill>
+                <a:latin typeface="Consolas"/>
+              </a:rPr>
+              <a:t>  62  </a:t>
+            </a:r>
+            <a:r>
+              <a:rPr sz="1800">
+                <a:solidFill>
+                  <a:srgbClr val="6D8C97"/>
+                </a:solidFill>
+                <a:latin typeface="Consolas"/>
+              </a:rPr>
+              <a:t>  event.preventDefault();</a:t>
+            </a:r>
+          </a:p>
+          <a:p>
+            <a:pPr>
+              <a:spcAft>
+                <a:spcPts val="0"/>
+              </a:spcAft>
+            </a:pPr>
+            <a:r>
+              <a:rPr sz="1800">
+                <a:solidFill>
+                  <a:srgbClr val="6D8C97"/>
+                </a:solidFill>
+                <a:latin typeface="Consolas"/>
+              </a:rPr>
+              <a:t>  63  </a:t>
+            </a:r>
+            <a:r>
+              <a:rPr sz="1800">
+                <a:solidFill>
+                  <a:srgbClr val="6D8C97"/>
+                </a:solidFill>
+                <a:latin typeface="Consolas"/>
+              </a:rPr>
+              <a:t>  const text = promptBox.value.trim();</a:t>
+            </a:r>
+          </a:p>
+          <a:p>
+            <a:pPr>
+              <a:spcAft>
+                <a:spcPts val="0"/>
+              </a:spcAft>
+            </a:pPr>
+            <a:r>
+              <a:rPr sz="1800">
+                <a:solidFill>
+                  <a:srgbClr val="6D8C97"/>
+                </a:solidFill>
+                <a:latin typeface="Consolas"/>
+              </a:rPr>
+              <a:t>  64  </a:t>
+            </a:r>
+            <a:r>
+              <a:rPr sz="1800">
+                <a:solidFill>
+                  <a:srgbClr val="6D8C97"/>
+                </a:solidFill>
+                <a:latin typeface="Consolas"/>
+              </a:rPr>
+              <a:t>  if (text === '') { return; }</a:t>
+            </a:r>
+          </a:p>
+          <a:p>
+            <a:pPr>
+              <a:spcAft>
+                <a:spcPts val="0"/>
+              </a:spcAft>
+            </a:pPr>
+            <a:r>
+              <a:rPr sz="1800">
+                <a:solidFill>
+                  <a:srgbClr val="6D8C97"/>
+                </a:solidFill>
+                <a:latin typeface="Consolas"/>
+              </a:rPr>
+              <a:t>  65  </a:t>
+            </a:r>
+            <a:r>
+              <a:rPr sz="1800">
+                <a:solidFill>
+                  <a:srgbClr val="6D8C97"/>
+                </a:solidFill>
+                <a:latin typeface="Consolas"/>
+              </a:rPr>
+              <a:t>  promptBox.value = '';</a:t>
+            </a:r>
+          </a:p>
+          <a:p>
+            <a:pPr>
+              <a:spcAft>
+                <a:spcPts val="0"/>
+              </a:spcAft>
+            </a:pPr>
+            <a:r>
+              <a:rPr sz="1800">
+                <a:solidFill>
+                  <a:srgbClr val="6D8C97"/>
+                </a:solidFill>
+                <a:latin typeface="Consolas"/>
+              </a:rPr>
+              <a:t>  66  </a:t>
+            </a:r>
+            <a:r>
+              <a:rPr sz="1800">
+                <a:solidFill>
+                  <a:srgbClr val="6D8C97"/>
+                </a:solidFill>
+                <a:latin typeface="Consolas"/>
+              </a:rPr>
+              <a:t>  addLine('You', text);</a:t>
+            </a:r>
+          </a:p>
+          <a:p>
+            <a:pPr>
+              <a:spcAft>
+                <a:spcPts val="0"/>
+              </a:spcAft>
+            </a:pPr>
+            <a:r>
+              <a:rPr sz="1800">
+                <a:solidFill>
+                  <a:srgbClr val="6D8C97"/>
+                </a:solidFill>
+                <a:latin typeface="Consolas"/>
+              </a:rPr>
+              <a:t>   -  </a:t>
+            </a:r>
+            <a:r>
+              <a:rPr sz="1800" strike="sngStrike">
+                <a:solidFill>
+                  <a:srgbClr val="F3928B"/>
+                </a:solidFill>
+                <a:latin typeface="Consolas"/>
+              </a:rPr>
+              <a:t>  addLine('Companion', 'You said: ' + text);   // a pretend answer, for now</a:t>
+            </a:r>
+          </a:p>
+        </p:txBody>
+      </p:sp>
+      <p:sp>
+        <p:nvSpPr>
+          <p:cNvPr id="4" name="TextBox 3"/>
+          <p:cNvSpPr txBox="1"/>
+          <p:nvPr/>
+        </p:nvSpPr>
+        <p:spPr>
+          <a:xfrm>
+            <a:off x="548640" y="5623560"/>
+            <a:ext cx="11064240" cy="1051560"/>
+          </a:xfrm>
+          <a:prstGeom prst="rect">
+            <a:avLst/>
+          </a:prstGeom>
+          <a:noFill/>
+        </p:spPr>
+        <p:txBody>
           <a:bodyPr wrap="square">
             <a:spAutoFit/>
           </a:bodyPr>
           <a:lstStyle/>
           <a:p>
-            <a:pPr>
-              <a:spcAft>
-                <a:spcPts val="1400"/>
-              </a:spcAft>
-            </a:pPr>
-            <a:r>
-              <a:rPr sz="2400">
-                <a:solidFill>
-                  <a:srgbClr val="1F2A37"/>
-                </a:solidFill>
-              </a:rPr>
-              <a:t>• Deletes an element from the page.</a:t>
-            </a:r>
-          </a:p>
-          <a:p>
-            <a:pPr>
-              <a:spcAft>
-                <a:spcPts val="1400"/>
-              </a:spcAft>
-            </a:pPr>
-            <a:r>
-              <a:rPr sz="2400">
-                <a:solidFill>
-                  <a:srgbClr val="1F2A37"/>
-                </a:solidFill>
-              </a:rPr>
-              <a:t>• chat.lastChild.remove() takes the last message back off.</a:t>
+            <a:r>
+              <a:rPr sz="2000">
+                <a:solidFill>
+                  <a:srgbClr val="DCECEF"/>
+                </a:solidFill>
+              </a:rPr>
+              <a:t>This line changes - take the old one out; the new version is next.</a:t>
             </a:r>
           </a:p>
         </p:txBody>
@@ -12369,7 +12243,7 @@
                   <a:srgbClr val="01AEFD"/>
                 </a:solidFill>
               </a:rPr>
-              <a:t>Type this into script.js   -   line 69</a:t>
+              <a:t>Type this into script.js   -   line 67</a:t>
             </a:r>
           </a:p>
         </p:txBody>
@@ -12402,7 +12276,7 @@
               </a:spcAft>
             </a:pPr>
             <a:r>
-              <a:rPr sz="1300">
+              <a:rPr sz="1800">
                 <a:solidFill>
                   <a:srgbClr val="6D8C97"/>
                 </a:solidFill>
@@ -12411,7 +12285,7 @@
               <a:t>  59  </a:t>
             </a:r>
             <a:r>
-              <a:rPr sz="1300">
+              <a:rPr sz="1800">
                 <a:solidFill>
                   <a:srgbClr val="6D8C97"/>
                 </a:solidFill>
@@ -12427,7 +12301,7 @@
               </a:spcAft>
             </a:pPr>
             <a:r>
-              <a:rPr sz="1300">
+              <a:rPr sz="1800">
                 <a:solidFill>
                   <a:srgbClr val="6D8C97"/>
                 </a:solidFill>
@@ -12436,7 +12310,7 @@
               <a:t>  60  </a:t>
             </a:r>
             <a:r>
-              <a:rPr sz="1300">
+              <a:rPr sz="1800">
                 <a:solidFill>
                   <a:srgbClr val="6D8C97"/>
                 </a:solidFill>
@@ -12452,7 +12326,7 @@
               </a:spcAft>
             </a:pPr>
             <a:r>
-              <a:rPr sz="1300">
+              <a:rPr sz="1800">
                 <a:solidFill>
                   <a:srgbClr val="6D8C97"/>
                 </a:solidFill>
@@ -12461,7 +12335,7 @@
               <a:t>  61  </a:t>
             </a:r>
             <a:r>
-              <a:rPr sz="1300">
+              <a:rPr sz="1800">
                 <a:solidFill>
                   <a:srgbClr val="6D8C97"/>
                 </a:solidFill>
@@ -12477,7 +12351,7 @@
               </a:spcAft>
             </a:pPr>
             <a:r>
-              <a:rPr sz="1300">
+              <a:rPr sz="1800">
                 <a:solidFill>
                   <a:srgbClr val="6D8C97"/>
                 </a:solidFill>
@@ -12486,7 +12360,7 @@
               <a:t>  62  </a:t>
             </a:r>
             <a:r>
-              <a:rPr sz="1300">
+              <a:rPr sz="1800">
                 <a:solidFill>
                   <a:srgbClr val="6D8C97"/>
                 </a:solidFill>
@@ -12502,7 +12376,7 @@
               </a:spcAft>
             </a:pPr>
             <a:r>
-              <a:rPr sz="1300">
+              <a:rPr sz="1800">
                 <a:solidFill>
                   <a:srgbClr val="6D8C97"/>
                 </a:solidFill>
@@ -12511,7 +12385,7 @@
               <a:t>  63  </a:t>
             </a:r>
             <a:r>
-              <a:rPr sz="1300">
+              <a:rPr sz="1800">
                 <a:solidFill>
                   <a:srgbClr val="6D8C97"/>
                 </a:solidFill>
@@ -12527,7 +12401,7 @@
               </a:spcAft>
             </a:pPr>
             <a:r>
-              <a:rPr sz="1300">
+              <a:rPr sz="1800">
                 <a:solidFill>
                   <a:srgbClr val="6D8C97"/>
                 </a:solidFill>
@@ -12536,7 +12410,7 @@
               <a:t>  64  </a:t>
             </a:r>
             <a:r>
-              <a:rPr sz="1300">
+              <a:rPr sz="1800">
                 <a:solidFill>
                   <a:srgbClr val="6D8C97"/>
                 </a:solidFill>
@@ -12552,7 +12426,7 @@
               </a:spcAft>
             </a:pPr>
             <a:r>
-              <a:rPr sz="1300">
+              <a:rPr sz="1800">
                 <a:solidFill>
                   <a:srgbClr val="6D8C97"/>
                 </a:solidFill>
@@ -12561,7 +12435,7 @@
               <a:t>  65  </a:t>
             </a:r>
             <a:r>
-              <a:rPr sz="1300">
+              <a:rPr sz="1800">
                 <a:solidFill>
                   <a:srgbClr val="6D8C97"/>
                 </a:solidFill>
@@ -12577,7 +12451,7 @@
               </a:spcAft>
             </a:pPr>
             <a:r>
-              <a:rPr sz="1300">
+              <a:rPr sz="1800">
                 <a:solidFill>
                   <a:srgbClr val="6D8C97"/>
                 </a:solidFill>
@@ -12586,7 +12460,7 @@
               <a:t>  66  </a:t>
             </a:r>
             <a:r>
-              <a:rPr sz="1300">
+              <a:rPr sz="1800">
                 <a:solidFill>
                   <a:srgbClr val="6D8C97"/>
                 </a:solidFill>
@@ -12602,7 +12476,7 @@
               </a:spcAft>
             </a:pPr>
             <a:r>
-              <a:rPr sz="1300">
+              <a:rPr sz="1800">
                 <a:solidFill>
                   <a:srgbClr val="6D8C97"/>
                 </a:solidFill>
@@ -12611,63 +12485,13 @@
               <a:t>  67  </a:t>
             </a:r>
             <a:r>
-              <a:rPr sz="1300">
-                <a:solidFill>
-                  <a:srgbClr val="6D8C97"/>
+              <a:rPr sz="1800">
+                <a:solidFill>
+                  <a:srgbClr val="7FE0A0"/>
                 </a:solidFill>
                 <a:latin typeface="Consolas"/>
               </a:rPr>
               <a:t>  addLine('Companion', 'thinking...');</a:t>
-            </a:r>
-          </a:p>
-          <a:p>
-            <a:pPr>
-              <a:spcAft>
-                <a:spcPts val="0"/>
-              </a:spcAft>
-            </a:pPr>
-            <a:r>
-              <a:rPr sz="1300">
-                <a:solidFill>
-                  <a:srgbClr val="6D8C97"/>
-                </a:solidFill>
-                <a:latin typeface="Consolas"/>
-              </a:rPr>
-              <a:t>  68  </a:t>
-            </a:r>
-            <a:r>
-              <a:rPr sz="1300">
-                <a:solidFill>
-                  <a:srgbClr val="6D8C97"/>
-                </a:solidFill>
-                <a:latin typeface="Consolas"/>
-              </a:rPr>
-              <a:t>  const reply = await askAI(text);       // this is the slow bit</a:t>
-            </a:r>
-          </a:p>
-          <a:p>
-            <a:pPr>
-              <a:spcAft>
-                <a:spcPts val="0"/>
-              </a:spcAft>
-            </a:pPr>
-            <a:r>
-              <a:rPr sz="1300">
-                <a:solidFill>
-                  <a:srgbClr val="6D8C97"/>
-                </a:solidFill>
-                <a:latin typeface="Consolas"/>
-              </a:rPr>
-              <a:t>  69  </a:t>
-            </a:r>
-            <a:r>
-              <a:rPr sz="1300">
-                <a:solidFill>
-                  <a:srgbClr val="7FE0A0"/>
-                </a:solidFill>
-                <a:latin typeface="Consolas"/>
-              </a:rPr>
-              <a:t>  chat.lastChild.remove();               // take the 'thinking' line away</a:t>
             </a:r>
           </a:p>
         </p:txBody>
@@ -12700,7 +12524,7 @@
                   <a:srgbClr val="DCECEF"/>
                 </a:solidFill>
               </a:rPr>
-              <a:t>Remove the 'thinking...' line now the real answer is here.</a:t>
+              <a:t>Change the pretend reply to a 'thinking...' line while we wait.</a:t>
             </a:r>
           </a:p>
         </p:txBody>
@@ -12759,7 +12583,7 @@
                   <a:srgbClr val="01AEFD"/>
                 </a:solidFill>
               </a:rPr>
-              <a:t>Type this into script.js   -   line 70</a:t>
+              <a:t>Type this into script.js   -   line 68</a:t>
             </a:r>
           </a:p>
         </p:txBody>
@@ -12792,7 +12616,7 @@
               </a:spcAft>
             </a:pPr>
             <a:r>
-              <a:rPr sz="1300">
+              <a:rPr sz="1800">
                 <a:solidFill>
                   <a:srgbClr val="6D8C97"/>
                 </a:solidFill>
@@ -12801,7 +12625,7 @@
               <a:t>  59  </a:t>
             </a:r>
             <a:r>
-              <a:rPr sz="1300">
+              <a:rPr sz="1800">
                 <a:solidFill>
                   <a:srgbClr val="6D8C97"/>
                 </a:solidFill>
@@ -12817,7 +12641,7 @@
               </a:spcAft>
             </a:pPr>
             <a:r>
-              <a:rPr sz="1300">
+              <a:rPr sz="1800">
                 <a:solidFill>
                   <a:srgbClr val="6D8C97"/>
                 </a:solidFill>
@@ -12826,7 +12650,7 @@
               <a:t>  60  </a:t>
             </a:r>
             <a:r>
-              <a:rPr sz="1300">
+              <a:rPr sz="1800">
                 <a:solidFill>
                   <a:srgbClr val="6D8C97"/>
                 </a:solidFill>
@@ -12842,7 +12666,7 @@
               </a:spcAft>
             </a:pPr>
             <a:r>
-              <a:rPr sz="1300">
+              <a:rPr sz="1800">
                 <a:solidFill>
                   <a:srgbClr val="6D8C97"/>
                 </a:solidFill>
@@ -12851,7 +12675,7 @@
               <a:t>  61  </a:t>
             </a:r>
             <a:r>
-              <a:rPr sz="1300">
+              <a:rPr sz="1800">
                 <a:solidFill>
                   <a:srgbClr val="6D8C97"/>
                 </a:solidFill>
@@ -12867,7 +12691,7 @@
               </a:spcAft>
             </a:pPr>
             <a:r>
-              <a:rPr sz="1300">
+              <a:rPr sz="1800">
                 <a:solidFill>
                   <a:srgbClr val="6D8C97"/>
                 </a:solidFill>
@@ -12876,7 +12700,7 @@
               <a:t>  62  </a:t>
             </a:r>
             <a:r>
-              <a:rPr sz="1300">
+              <a:rPr sz="1800">
                 <a:solidFill>
                   <a:srgbClr val="6D8C97"/>
                 </a:solidFill>
@@ -12892,7 +12716,7 @@
               </a:spcAft>
             </a:pPr>
             <a:r>
-              <a:rPr sz="1300">
+              <a:rPr sz="1800">
                 <a:solidFill>
                   <a:srgbClr val="6D8C97"/>
                 </a:solidFill>
@@ -12901,7 +12725,7 @@
               <a:t>  63  </a:t>
             </a:r>
             <a:r>
-              <a:rPr sz="1300">
+              <a:rPr sz="1800">
                 <a:solidFill>
                   <a:srgbClr val="6D8C97"/>
                 </a:solidFill>
@@ -12917,7 +12741,7 @@
               </a:spcAft>
             </a:pPr>
             <a:r>
-              <a:rPr sz="1300">
+              <a:rPr sz="1800">
                 <a:solidFill>
                   <a:srgbClr val="6D8C97"/>
                 </a:solidFill>
@@ -12926,7 +12750,7 @@
               <a:t>  64  </a:t>
             </a:r>
             <a:r>
-              <a:rPr sz="1300">
+              <a:rPr sz="1800">
                 <a:solidFill>
                   <a:srgbClr val="6D8C97"/>
                 </a:solidFill>
@@ -12942,7 +12766,7 @@
               </a:spcAft>
             </a:pPr>
             <a:r>
-              <a:rPr sz="1300">
+              <a:rPr sz="1800">
                 <a:solidFill>
                   <a:srgbClr val="6D8C97"/>
                 </a:solidFill>
@@ -12951,7 +12775,7 @@
               <a:t>  65  </a:t>
             </a:r>
             <a:r>
-              <a:rPr sz="1300">
+              <a:rPr sz="1800">
                 <a:solidFill>
                   <a:srgbClr val="6D8C97"/>
                 </a:solidFill>
@@ -12967,7 +12791,7 @@
               </a:spcAft>
             </a:pPr>
             <a:r>
-              <a:rPr sz="1300">
+              <a:rPr sz="1800">
                 <a:solidFill>
                   <a:srgbClr val="6D8C97"/>
                 </a:solidFill>
@@ -12976,7 +12800,7 @@
               <a:t>  66  </a:t>
             </a:r>
             <a:r>
-              <a:rPr sz="1300">
+              <a:rPr sz="1800">
                 <a:solidFill>
                   <a:srgbClr val="6D8C97"/>
                 </a:solidFill>
@@ -12992,7 +12816,7 @@
               </a:spcAft>
             </a:pPr>
             <a:r>
-              <a:rPr sz="1300">
+              <a:rPr sz="1800">
                 <a:solidFill>
                   <a:srgbClr val="6D8C97"/>
                 </a:solidFill>
@@ -13001,7 +12825,7 @@
               <a:t>  67  </a:t>
             </a:r>
             <a:r>
-              <a:rPr sz="1300">
+              <a:rPr sz="1800">
                 <a:solidFill>
                   <a:srgbClr val="6D8C97"/>
                 </a:solidFill>
@@ -13017,7 +12841,7 @@
               </a:spcAft>
             </a:pPr>
             <a:r>
-              <a:rPr sz="1300">
+              <a:rPr sz="1800">
                 <a:solidFill>
                   <a:srgbClr val="6D8C97"/>
                 </a:solidFill>
@@ -13026,63 +12850,13 @@
               <a:t>  68  </a:t>
             </a:r>
             <a:r>
-              <a:rPr sz="1300">
-                <a:solidFill>
-                  <a:srgbClr val="6D8C97"/>
+              <a:rPr sz="1800">
+                <a:solidFill>
+                  <a:srgbClr val="7FE0A0"/>
                 </a:solidFill>
                 <a:latin typeface="Consolas"/>
               </a:rPr>
               <a:t>  const reply = await askAI(text);       // this is the slow bit</a:t>
-            </a:r>
-          </a:p>
-          <a:p>
-            <a:pPr>
-              <a:spcAft>
-                <a:spcPts val="0"/>
-              </a:spcAft>
-            </a:pPr>
-            <a:r>
-              <a:rPr sz="1300">
-                <a:solidFill>
-                  <a:srgbClr val="6D8C97"/>
-                </a:solidFill>
-                <a:latin typeface="Consolas"/>
-              </a:rPr>
-              <a:t>  69  </a:t>
-            </a:r>
-            <a:r>
-              <a:rPr sz="1300">
-                <a:solidFill>
-                  <a:srgbClr val="6D8C97"/>
-                </a:solidFill>
-                <a:latin typeface="Consolas"/>
-              </a:rPr>
-              <a:t>  chat.lastChild.remove();               // take the 'thinking' line away</a:t>
-            </a:r>
-          </a:p>
-          <a:p>
-            <a:pPr>
-              <a:spcAft>
-                <a:spcPts val="0"/>
-              </a:spcAft>
-            </a:pPr>
-            <a:r>
-              <a:rPr sz="1300">
-                <a:solidFill>
-                  <a:srgbClr val="6D8C97"/>
-                </a:solidFill>
-                <a:latin typeface="Consolas"/>
-              </a:rPr>
-              <a:t>  70  </a:t>
-            </a:r>
-            <a:r>
-              <a:rPr sz="1300">
-                <a:solidFill>
-                  <a:srgbClr val="7FE0A0"/>
-                </a:solidFill>
-                <a:latin typeface="Consolas"/>
-              </a:rPr>
-              <a:t>  addLine('Companion', reply);</a:t>
             </a:r>
           </a:p>
         </p:txBody>
@@ -13115,7 +12889,7 @@
                   <a:srgbClr val="DCECEF"/>
                 </a:solidFill>
               </a:rPr>
-              <a:t>Show the real reply in the chat.</a:t>
+              <a:t>await askAI(text): the slow bit - ask the AI and wait for the answer.</a:t>
             </a:r>
           </a:p>
         </p:txBody>
@@ -13131,14 +12905,6 @@
 <file path=ppt/slides/slide38.xml><?xml version="1.0" encoding="utf-8"?>
 <p:sld xmlns:a="http://schemas.openxmlformats.org/drawingml/2006/main" xmlns:p="http://schemas.openxmlformats.org/presentationml/2006/main" xmlns:r="http://schemas.openxmlformats.org/officeDocument/2006/relationships">
   <p:cSld>
-    <p:bg>
-      <p:bgPr>
-        <a:solidFill>
-          <a:srgbClr val="102127"/>
-        </a:solidFill>
-        <a:effectLst/>
-      </p:bgPr>
-    </p:bg>
     <p:spTree>
       <p:nvGrpSpPr>
         <p:cNvPr id="1" name=""/>
@@ -13148,14 +12914,40 @@
       <p:grpSpPr/>
       <p:sp>
         <p:nvSpPr>
-          <p:cNvPr id="2" name="TextBox 1"/>
+          <p:cNvPr id="2" name="Title 1"/>
+          <p:cNvSpPr>
+            <a:spLocks noGrp="1"/>
+          </p:cNvSpPr>
+          <p:nvPr>
+            <p:ph type="title"/>
+          </p:nvPr>
+        </p:nvSpPr>
+        <p:spPr/>
+        <p:txBody>
+          <a:bodyPr/>
+          <a:lstStyle/>
+          <a:p>
+            <a:r>
+              <a:rPr sz="3800" b="1">
+                <a:solidFill>
+                  <a:srgbClr val="1F2A37"/>
+                </a:solidFill>
+              </a:rPr>
+              <a:t>.lastChild</a:t>
+            </a:r>
+          </a:p>
+        </p:txBody>
+      </p:sp>
+      <p:sp>
+        <p:nvSpPr>
+          <p:cNvPr id="3" name="TextBox 2"/>
           <p:cNvSpPr txBox="1"/>
           <p:nvPr/>
         </p:nvSpPr>
         <p:spPr>
           <a:xfrm>
-            <a:off x="502920" y="274320"/>
-            <a:ext cx="11155680" cy="548640"/>
+            <a:off x="868680" y="502920"/>
+            <a:ext cx="5486400" cy="457200"/>
           </a:xfrm>
           <a:prstGeom prst="rect">
             <a:avLst/>
@@ -13169,26 +12961,26 @@
           <a:lstStyle/>
           <a:p>
             <a:r>
-              <a:rPr sz="2200" b="1">
+              <a:rPr sz="1500" b="1">
                 <a:solidFill>
                   <a:srgbClr val="01AEFD"/>
                 </a:solidFill>
               </a:rPr>
-              <a:t>All together in script.js</a:t>
-            </a:r>
-          </a:p>
-        </p:txBody>
-      </p:sp>
-      <p:sp>
-        <p:nvSpPr>
-          <p:cNvPr id="3" name="TextBox 2"/>
+              <a:t>JAVASCRIPT</a:t>
+            </a:r>
+          </a:p>
+        </p:txBody>
+      </p:sp>
+      <p:sp>
+        <p:nvSpPr>
+          <p:cNvPr id="4" name="TextBox 3"/>
           <p:cNvSpPr txBox="1"/>
           <p:nvPr/>
         </p:nvSpPr>
         <p:spPr>
           <a:xfrm>
-            <a:off x="502920" y="960120"/>
-            <a:ext cx="11155680" cy="4297680"/>
+            <a:off x="822960" y="1828800"/>
+            <a:ext cx="10515600" cy="4206240"/>
           </a:xfrm>
           <a:prstGeom prst="rect">
             <a:avLst/>
@@ -13196,366 +12988,38 @@
           <a:noFill/>
         </p:spPr>
         <p:txBody>
-          <a:bodyPr wrap="none">
-            <a:spAutoFit/>
-          </a:bodyPr>
-          <a:lstStyle/>
-          <a:p>
-            <a:pPr>
-              <a:spcAft>
-                <a:spcPts val="0"/>
-              </a:spcAft>
-            </a:pPr>
-            <a:r>
-              <a:rPr sz="1300">
-                <a:solidFill>
-                  <a:srgbClr val="6D8C97"/>
-                </a:solidFill>
-                <a:latin typeface="Consolas"/>
-              </a:rPr>
-              <a:t>  59  </a:t>
-            </a:r>
-            <a:r>
-              <a:rPr sz="1300">
-                <a:solidFill>
-                  <a:srgbClr val="7FE0A0"/>
-                </a:solidFill>
-                <a:latin typeface="Consolas"/>
-              </a:rPr>
-              <a:t> </a:t>
-            </a:r>
-          </a:p>
-          <a:p>
-            <a:pPr>
-              <a:spcAft>
-                <a:spcPts val="0"/>
-              </a:spcAft>
-            </a:pPr>
-            <a:r>
-              <a:rPr sz="1300">
-                <a:solidFill>
-                  <a:srgbClr val="6D8C97"/>
-                </a:solidFill>
-                <a:latin typeface="Consolas"/>
-              </a:rPr>
-              <a:t>  60  </a:t>
-            </a:r>
-            <a:r>
-              <a:rPr sz="1300">
-                <a:solidFill>
-                  <a:srgbClr val="7FE0A0"/>
-                </a:solidFill>
-                <a:latin typeface="Consolas"/>
-              </a:rPr>
-              <a:t>// The browser calls this when the form is submitted.</a:t>
-            </a:r>
-          </a:p>
-          <a:p>
-            <a:pPr>
-              <a:spcAft>
-                <a:spcPts val="0"/>
-              </a:spcAft>
-            </a:pPr>
-            <a:r>
-              <a:rPr sz="1300">
-                <a:solidFill>
-                  <a:srgbClr val="6D8C97"/>
-                </a:solidFill>
-                <a:latin typeface="Consolas"/>
-              </a:rPr>
-              <a:t>  61  </a:t>
-            </a:r>
-            <a:r>
-              <a:rPr sz="1300">
-                <a:solidFill>
-                  <a:srgbClr val="7FE0A0"/>
-                </a:solidFill>
-                <a:latin typeface="Consolas"/>
-              </a:rPr>
-              <a:t>composer.addEventListener('submit', async function (event) {</a:t>
-            </a:r>
-          </a:p>
-          <a:p>
-            <a:pPr>
-              <a:spcAft>
-                <a:spcPts val="0"/>
-              </a:spcAft>
-            </a:pPr>
-            <a:r>
-              <a:rPr sz="1300">
-                <a:solidFill>
-                  <a:srgbClr val="6D8C97"/>
-                </a:solidFill>
-                <a:latin typeface="Consolas"/>
-              </a:rPr>
-              <a:t>  62  </a:t>
-            </a:r>
-            <a:r>
-              <a:rPr sz="1300">
-                <a:solidFill>
-                  <a:srgbClr val="7FE0A0"/>
-                </a:solidFill>
-                <a:latin typeface="Consolas"/>
-              </a:rPr>
-              <a:t>  event.preventDefault();</a:t>
-            </a:r>
-          </a:p>
-          <a:p>
-            <a:pPr>
-              <a:spcAft>
-                <a:spcPts val="0"/>
-              </a:spcAft>
-            </a:pPr>
-            <a:r>
-              <a:rPr sz="1300">
-                <a:solidFill>
-                  <a:srgbClr val="6D8C97"/>
-                </a:solidFill>
-                <a:latin typeface="Consolas"/>
-              </a:rPr>
-              <a:t>  63  </a:t>
-            </a:r>
-            <a:r>
-              <a:rPr sz="1300">
-                <a:solidFill>
-                  <a:srgbClr val="7FE0A0"/>
-                </a:solidFill>
-                <a:latin typeface="Consolas"/>
-              </a:rPr>
-              <a:t>  const text = promptBox.value.trim();</a:t>
-            </a:r>
-          </a:p>
-          <a:p>
-            <a:pPr>
-              <a:spcAft>
-                <a:spcPts val="0"/>
-              </a:spcAft>
-            </a:pPr>
-            <a:r>
-              <a:rPr sz="1300">
-                <a:solidFill>
-                  <a:srgbClr val="6D8C97"/>
-                </a:solidFill>
-                <a:latin typeface="Consolas"/>
-              </a:rPr>
-              <a:t>  64  </a:t>
-            </a:r>
-            <a:r>
-              <a:rPr sz="1300">
-                <a:solidFill>
-                  <a:srgbClr val="7FE0A0"/>
-                </a:solidFill>
-                <a:latin typeface="Consolas"/>
-              </a:rPr>
-              <a:t>  if (text === '') { return; }</a:t>
-            </a:r>
-          </a:p>
-          <a:p>
-            <a:pPr>
-              <a:spcAft>
-                <a:spcPts val="0"/>
-              </a:spcAft>
-            </a:pPr>
-            <a:r>
-              <a:rPr sz="1300">
-                <a:solidFill>
-                  <a:srgbClr val="6D8C97"/>
-                </a:solidFill>
-                <a:latin typeface="Consolas"/>
-              </a:rPr>
-              <a:t>  65  </a:t>
-            </a:r>
-            <a:r>
-              <a:rPr sz="1300">
-                <a:solidFill>
-                  <a:srgbClr val="7FE0A0"/>
-                </a:solidFill>
-                <a:latin typeface="Consolas"/>
-              </a:rPr>
-              <a:t>  promptBox.value = '';</a:t>
-            </a:r>
-          </a:p>
-          <a:p>
-            <a:pPr>
-              <a:spcAft>
-                <a:spcPts val="0"/>
-              </a:spcAft>
-            </a:pPr>
-            <a:r>
-              <a:rPr sz="1300">
-                <a:solidFill>
-                  <a:srgbClr val="6D8C97"/>
-                </a:solidFill>
-                <a:latin typeface="Consolas"/>
-              </a:rPr>
-              <a:t>  66  </a:t>
-            </a:r>
-            <a:r>
-              <a:rPr sz="1300">
-                <a:solidFill>
-                  <a:srgbClr val="7FE0A0"/>
-                </a:solidFill>
-                <a:latin typeface="Consolas"/>
-              </a:rPr>
-              <a:t>  addLine('You', text);</a:t>
-            </a:r>
-          </a:p>
-          <a:p>
-            <a:pPr>
-              <a:spcAft>
-                <a:spcPts val="0"/>
-              </a:spcAft>
-            </a:pPr>
-            <a:r>
-              <a:rPr sz="1300">
-                <a:solidFill>
-                  <a:srgbClr val="6D8C97"/>
-                </a:solidFill>
-                <a:latin typeface="Consolas"/>
-              </a:rPr>
-              <a:t>  67  </a:t>
-            </a:r>
-            <a:r>
-              <a:rPr sz="1300">
-                <a:solidFill>
-                  <a:srgbClr val="7FE0A0"/>
-                </a:solidFill>
-                <a:latin typeface="Consolas"/>
-              </a:rPr>
-              <a:t>  addLine('Companion', 'thinking...');</a:t>
-            </a:r>
-          </a:p>
-          <a:p>
-            <a:pPr>
-              <a:spcAft>
-                <a:spcPts val="0"/>
-              </a:spcAft>
-            </a:pPr>
-            <a:r>
-              <a:rPr sz="1300">
-                <a:solidFill>
-                  <a:srgbClr val="6D8C97"/>
-                </a:solidFill>
-                <a:latin typeface="Consolas"/>
-              </a:rPr>
-              <a:t>  68  </a:t>
-            </a:r>
-            <a:r>
-              <a:rPr sz="1300">
-                <a:solidFill>
-                  <a:srgbClr val="7FE0A0"/>
-                </a:solidFill>
-                <a:latin typeface="Consolas"/>
-              </a:rPr>
-              <a:t>  const reply = await askAI(text);       // this is the slow bit</a:t>
-            </a:r>
-          </a:p>
-          <a:p>
-            <a:pPr>
-              <a:spcAft>
-                <a:spcPts val="0"/>
-              </a:spcAft>
-            </a:pPr>
-            <a:r>
-              <a:rPr sz="1300">
-                <a:solidFill>
-                  <a:srgbClr val="6D8C97"/>
-                </a:solidFill>
-                <a:latin typeface="Consolas"/>
-              </a:rPr>
-              <a:t>  69  </a:t>
-            </a:r>
-            <a:r>
-              <a:rPr sz="1300">
-                <a:solidFill>
-                  <a:srgbClr val="7FE0A0"/>
-                </a:solidFill>
-                <a:latin typeface="Consolas"/>
-              </a:rPr>
-              <a:t>  chat.lastChild.remove();               // take the 'thinking' line away</a:t>
-            </a:r>
-          </a:p>
-          <a:p>
-            <a:pPr>
-              <a:spcAft>
-                <a:spcPts val="0"/>
-              </a:spcAft>
-            </a:pPr>
-            <a:r>
-              <a:rPr sz="1300">
-                <a:solidFill>
-                  <a:srgbClr val="6D8C97"/>
-                </a:solidFill>
-                <a:latin typeface="Consolas"/>
-              </a:rPr>
-              <a:t>  70  </a:t>
-            </a:r>
-            <a:r>
-              <a:rPr sz="1300">
-                <a:solidFill>
-                  <a:srgbClr val="7FE0A0"/>
-                </a:solidFill>
-                <a:latin typeface="Consolas"/>
-              </a:rPr>
-              <a:t>  addLine('Companion', reply);</a:t>
-            </a:r>
-          </a:p>
-          <a:p>
-            <a:pPr>
-              <a:spcAft>
-                <a:spcPts val="0"/>
-              </a:spcAft>
-            </a:pPr>
-            <a:r>
-              <a:rPr sz="1300">
-                <a:solidFill>
-                  <a:srgbClr val="6D8C97"/>
-                </a:solidFill>
-                <a:latin typeface="Consolas"/>
-              </a:rPr>
-              <a:t>  71  </a:t>
-            </a:r>
-            <a:r>
-              <a:rPr sz="1300">
-                <a:solidFill>
-                  <a:srgbClr val="7FE0A0"/>
-                </a:solidFill>
-                <a:latin typeface="Consolas"/>
-              </a:rPr>
-              <a:t>});</a:t>
-            </a:r>
-          </a:p>
-        </p:txBody>
-      </p:sp>
-      <p:sp>
-        <p:nvSpPr>
-          <p:cNvPr id="4" name="TextBox 3"/>
-          <p:cNvSpPr txBox="1"/>
-          <p:nvPr/>
-        </p:nvSpPr>
-        <p:spPr>
-          <a:xfrm>
-            <a:off x="548640" y="5623560"/>
-            <a:ext cx="11064240" cy="1051560"/>
-          </a:xfrm>
-          <a:prstGeom prst="rect">
-            <a:avLst/>
-          </a:prstGeom>
-          <a:noFill/>
-        </p:spPr>
-        <p:txBody>
           <a:bodyPr wrap="square">
             <a:spAutoFit/>
           </a:bodyPr>
           <a:lstStyle/>
           <a:p>
-            <a:r>
-              <a:rPr sz="2000">
-                <a:solidFill>
-                  <a:srgbClr val="DCECEF"/>
-                </a:solidFill>
-              </a:rPr>
-              <a:t>That is the whole piece. Check yours looks the same before moving on.</a:t>
+            <a:pPr>
+              <a:spcAft>
+                <a:spcPts val="1400"/>
+              </a:spcAft>
+            </a:pPr>
+            <a:r>
+              <a:rPr sz="2400">
+                <a:solidFill>
+                  <a:srgbClr val="1F2A37"/>
+                </a:solidFill>
+              </a:rPr>
+              <a:t>• A box's LAST child - the newest thing added inside it.</a:t>
+            </a:r>
+          </a:p>
+          <a:p>
+            <a:pPr>
+              <a:spcAft>
+                <a:spcPts val="1400"/>
+              </a:spcAft>
+            </a:pPr>
+            <a:r>
+              <a:rPr sz="2400">
+                <a:solidFill>
+                  <a:srgbClr val="1F2A37"/>
+                </a:solidFill>
+              </a:rPr>
+              <a:t>• chat.lastChild is the message you just put in.</a:t>
             </a:r>
           </a:p>
         </p:txBody>
@@ -13571,14 +13035,6 @@
 <file path=ppt/slides/slide39.xml><?xml version="1.0" encoding="utf-8"?>
 <p:sld xmlns:a="http://schemas.openxmlformats.org/drawingml/2006/main" xmlns:p="http://schemas.openxmlformats.org/presentationml/2006/main" xmlns:r="http://schemas.openxmlformats.org/officeDocument/2006/relationships">
   <p:cSld>
-    <p:bg>
-      <p:bgPr>
-        <a:solidFill>
-          <a:srgbClr val="102127"/>
-        </a:solidFill>
-        <a:effectLst/>
-      </p:bgPr>
-    </p:bg>
     <p:spTree>
       <p:nvGrpSpPr>
         <p:cNvPr id="1" name=""/>
@@ -13588,14 +13044,40 @@
       <p:grpSpPr/>
       <p:sp>
         <p:nvSpPr>
-          <p:cNvPr id="2" name="TextBox 1"/>
+          <p:cNvPr id="2" name="Title 1"/>
+          <p:cNvSpPr>
+            <a:spLocks noGrp="1"/>
+          </p:cNvSpPr>
+          <p:nvPr>
+            <p:ph type="title"/>
+          </p:nvPr>
+        </p:nvSpPr>
+        <p:spPr/>
+        <p:txBody>
+          <a:bodyPr/>
+          <a:lstStyle/>
+          <a:p>
+            <a:r>
+              <a:rPr sz="3800" b="1">
+                <a:solidFill>
+                  <a:srgbClr val="1F2A37"/>
+                </a:solidFill>
+              </a:rPr>
+              <a:t>.remove()</a:t>
+            </a:r>
+          </a:p>
+        </p:txBody>
+      </p:sp>
+      <p:sp>
+        <p:nvSpPr>
+          <p:cNvPr id="3" name="TextBox 2"/>
           <p:cNvSpPr txBox="1"/>
           <p:nvPr/>
         </p:nvSpPr>
         <p:spPr>
           <a:xfrm>
-            <a:off x="502920" y="274320"/>
-            <a:ext cx="11155680" cy="548640"/>
+            <a:off x="868680" y="502920"/>
+            <a:ext cx="5486400" cy="457200"/>
           </a:xfrm>
           <a:prstGeom prst="rect">
             <a:avLst/>
@@ -13609,26 +13091,26 @@
           <a:lstStyle/>
           <a:p>
             <a:r>
-              <a:rPr sz="2200" b="1">
+              <a:rPr sz="1500" b="1">
                 <a:solidFill>
                   <a:srgbClr val="01AEFD"/>
                 </a:solidFill>
               </a:rPr>
-              <a:t>In script.js   -   delete a line</a:t>
-            </a:r>
-          </a:p>
-        </p:txBody>
-      </p:sp>
-      <p:sp>
-        <p:nvSpPr>
-          <p:cNvPr id="3" name="TextBox 2"/>
+              <a:t>JAVASCRIPT</a:t>
+            </a:r>
+          </a:p>
+        </p:txBody>
+      </p:sp>
+      <p:sp>
+        <p:nvSpPr>
+          <p:cNvPr id="4" name="TextBox 3"/>
           <p:cNvSpPr txBox="1"/>
           <p:nvPr/>
         </p:nvSpPr>
         <p:spPr>
           <a:xfrm>
-            <a:off x="502920" y="960120"/>
-            <a:ext cx="11155680" cy="4297680"/>
+            <a:off x="822960" y="1828800"/>
+            <a:ext cx="10515600" cy="4206240"/>
           </a:xfrm>
           <a:prstGeom prst="rect">
             <a:avLst/>
@@ -13636,316 +13118,38 @@
           <a:noFill/>
         </p:spPr>
         <p:txBody>
-          <a:bodyPr wrap="none">
-            <a:spAutoFit/>
-          </a:bodyPr>
-          <a:lstStyle/>
-          <a:p>
-            <a:pPr>
-              <a:spcAft>
-                <a:spcPts val="0"/>
-              </a:spcAft>
-            </a:pPr>
-            <a:r>
-              <a:rPr sz="1300">
-                <a:solidFill>
-                  <a:srgbClr val="6D8C97"/>
-                </a:solidFill>
-                <a:latin typeface="Consolas"/>
-              </a:rPr>
-              <a:t>  29  </a:t>
-            </a:r>
-            <a:r>
-              <a:rPr sz="1300">
-                <a:solidFill>
-                  <a:srgbClr val="6D8C97"/>
-                </a:solidFill>
-                <a:latin typeface="Consolas"/>
-              </a:rPr>
-              <a:t> </a:t>
-            </a:r>
-          </a:p>
-          <a:p>
-            <a:pPr>
-              <a:spcAft>
-                <a:spcPts val="0"/>
-              </a:spcAft>
-            </a:pPr>
-            <a:r>
-              <a:rPr sz="1300">
-                <a:solidFill>
-                  <a:srgbClr val="6D8C97"/>
-                </a:solidFill>
-                <a:latin typeface="Consolas"/>
-              </a:rPr>
-              <a:t>  30  </a:t>
-            </a:r>
-            <a:r>
-              <a:rPr sz="1300">
-                <a:solidFill>
-                  <a:srgbClr val="6D8C97"/>
-                </a:solidFill>
-                <a:latin typeface="Consolas"/>
-              </a:rPr>
-              <a:t>// The smallest useful request: what models does this server have?</a:t>
-            </a:r>
-          </a:p>
-          <a:p>
-            <a:pPr>
-              <a:spcAft>
-                <a:spcPts val="0"/>
-              </a:spcAft>
-            </a:pPr>
-            <a:r>
-              <a:rPr sz="1300">
-                <a:solidFill>
-                  <a:srgbClr val="6D8C97"/>
-                </a:solidFill>
-                <a:latin typeface="Consolas"/>
-              </a:rPr>
-              <a:t>  31  </a:t>
-            </a:r>
-            <a:r>
-              <a:rPr sz="1300">
-                <a:solidFill>
-                  <a:srgbClr val="6D8C97"/>
-                </a:solidFill>
-                <a:latin typeface="Consolas"/>
-              </a:rPr>
-              <a:t>// 'async' means this function does something slow and can be waited for.</a:t>
-            </a:r>
-          </a:p>
-          <a:p>
-            <a:pPr>
-              <a:spcAft>
-                <a:spcPts val="0"/>
-              </a:spcAft>
-            </a:pPr>
-            <a:r>
-              <a:rPr sz="1300">
-                <a:solidFill>
-                  <a:srgbClr val="6D8C97"/>
-                </a:solidFill>
-                <a:latin typeface="Consolas"/>
-              </a:rPr>
-              <a:t>  32  </a:t>
-            </a:r>
-            <a:r>
-              <a:rPr sz="1300">
-                <a:solidFill>
-                  <a:srgbClr val="6D8C97"/>
-                </a:solidFill>
-                <a:latin typeface="Consolas"/>
-              </a:rPr>
-              <a:t>async function listModels() {</a:t>
-            </a:r>
-          </a:p>
-          <a:p>
-            <a:pPr>
-              <a:spcAft>
-                <a:spcPts val="0"/>
-              </a:spcAft>
-            </a:pPr>
-            <a:r>
-              <a:rPr sz="1300">
-                <a:solidFill>
-                  <a:srgbClr val="6D8C97"/>
-                </a:solidFill>
-                <a:latin typeface="Consolas"/>
-              </a:rPr>
-              <a:t>  33  </a:t>
-            </a:r>
-            <a:r>
-              <a:rPr sz="1300">
-                <a:solidFill>
-                  <a:srgbClr val="6D8C97"/>
-                </a:solidFill>
-                <a:latin typeface="Consolas"/>
-              </a:rPr>
-              <a:t>  const res = await fetch(AI_BASE + '/v1/models', {</a:t>
-            </a:r>
-          </a:p>
-          <a:p>
-            <a:pPr>
-              <a:spcAft>
-                <a:spcPts val="0"/>
-              </a:spcAft>
-            </a:pPr>
-            <a:r>
-              <a:rPr sz="1300">
-                <a:solidFill>
-                  <a:srgbClr val="6D8C97"/>
-                </a:solidFill>
-                <a:latin typeface="Consolas"/>
-              </a:rPr>
-              <a:t>  34  </a:t>
-            </a:r>
-            <a:r>
-              <a:rPr sz="1300">
-                <a:solidFill>
-                  <a:srgbClr val="6D8C97"/>
-                </a:solidFill>
-                <a:latin typeface="Consolas"/>
-              </a:rPr>
-              <a:t>    headers: { 'Authorization': 'Bearer ' + API_KEY }</a:t>
-            </a:r>
-          </a:p>
-          <a:p>
-            <a:pPr>
-              <a:spcAft>
-                <a:spcPts val="0"/>
-              </a:spcAft>
-            </a:pPr>
-            <a:r>
-              <a:rPr sz="1300">
-                <a:solidFill>
-                  <a:srgbClr val="6D8C97"/>
-                </a:solidFill>
-                <a:latin typeface="Consolas"/>
-              </a:rPr>
-              <a:t>  35  </a:t>
-            </a:r>
-            <a:r>
-              <a:rPr sz="1300">
-                <a:solidFill>
-                  <a:srgbClr val="6D8C97"/>
-                </a:solidFill>
-                <a:latin typeface="Consolas"/>
-              </a:rPr>
-              <a:t>  });</a:t>
-            </a:r>
-          </a:p>
-          <a:p>
-            <a:pPr>
-              <a:spcAft>
-                <a:spcPts val="0"/>
-              </a:spcAft>
-            </a:pPr>
-            <a:r>
-              <a:rPr sz="1300">
-                <a:solidFill>
-                  <a:srgbClr val="6D8C97"/>
-                </a:solidFill>
-                <a:latin typeface="Consolas"/>
-              </a:rPr>
-              <a:t>  36  </a:t>
-            </a:r>
-            <a:r>
-              <a:rPr sz="1300">
-                <a:solidFill>
-                  <a:srgbClr val="6D8C97"/>
-                </a:solidFill>
-                <a:latin typeface="Consolas"/>
-              </a:rPr>
-              <a:t>  const data = await res.json();   // the answer arrives as text; this reads it</a:t>
-            </a:r>
-          </a:p>
-          <a:p>
-            <a:pPr>
-              <a:spcAft>
-                <a:spcPts val="0"/>
-              </a:spcAft>
-            </a:pPr>
-            <a:r>
-              <a:rPr sz="1300">
-                <a:solidFill>
-                  <a:srgbClr val="6D8C97"/>
-                </a:solidFill>
-                <a:latin typeface="Consolas"/>
-              </a:rPr>
-              <a:t>  37  </a:t>
-            </a:r>
-            <a:r>
-              <a:rPr sz="1300">
-                <a:solidFill>
-                  <a:srgbClr val="6D8C97"/>
-                </a:solidFill>
-                <a:latin typeface="Consolas"/>
-              </a:rPr>
-              <a:t>  console.log('The server offers:', data.data);</a:t>
-            </a:r>
-          </a:p>
-          <a:p>
-            <a:pPr>
-              <a:spcAft>
-                <a:spcPts val="0"/>
-              </a:spcAft>
-            </a:pPr>
-            <a:r>
-              <a:rPr sz="1300">
-                <a:solidFill>
-                  <a:srgbClr val="6D8C97"/>
-                </a:solidFill>
-                <a:latin typeface="Consolas"/>
-              </a:rPr>
-              <a:t>  38  </a:t>
-            </a:r>
-            <a:r>
-              <a:rPr sz="1300">
-                <a:solidFill>
-                  <a:srgbClr val="6D8C97"/>
-                </a:solidFill>
-                <a:latin typeface="Consolas"/>
-              </a:rPr>
-              <a:t>}</a:t>
-            </a:r>
-          </a:p>
-          <a:p>
-            <a:pPr>
-              <a:spcAft>
-                <a:spcPts val="0"/>
-              </a:spcAft>
-            </a:pPr>
-            <a:r>
-              <a:rPr sz="1300">
-                <a:solidFill>
-                  <a:srgbClr val="6D8C97"/>
-                </a:solidFill>
-                <a:latin typeface="Consolas"/>
-              </a:rPr>
-              <a:t>   -  </a:t>
-            </a:r>
-            <a:r>
-              <a:rPr sz="1300" strike="sngStrike">
-                <a:solidFill>
-                  <a:srgbClr val="F3928B"/>
-                </a:solidFill>
-                <a:latin typeface="Consolas"/>
-              </a:rPr>
-              <a:t>listModels();</a:t>
-            </a:r>
-          </a:p>
-        </p:txBody>
-      </p:sp>
-      <p:sp>
-        <p:nvSpPr>
-          <p:cNvPr id="4" name="TextBox 3"/>
-          <p:cNvSpPr txBox="1"/>
-          <p:nvPr/>
-        </p:nvSpPr>
-        <p:spPr>
-          <a:xfrm>
-            <a:off x="548640" y="5623560"/>
-            <a:ext cx="11064240" cy="1051560"/>
-          </a:xfrm>
-          <a:prstGeom prst="rect">
-            <a:avLst/>
-          </a:prstGeom>
-          <a:noFill/>
-        </p:spPr>
-        <p:txBody>
           <a:bodyPr wrap="square">
             <a:spAutoFit/>
           </a:bodyPr>
           <a:lstStyle/>
           <a:p>
-            <a:r>
-              <a:rPr sz="2000">
-                <a:solidFill>
-                  <a:srgbClr val="DCECEF"/>
-                </a:solidFill>
-              </a:rPr>
-              <a:t>Delete this line. askAI does the asking now, so the old test call is no longer needed - your file should have no listModels() call left.</a:t>
+            <a:pPr>
+              <a:spcAft>
+                <a:spcPts val="1400"/>
+              </a:spcAft>
+            </a:pPr>
+            <a:r>
+              <a:rPr sz="2400">
+                <a:solidFill>
+                  <a:srgbClr val="1F2A37"/>
+                </a:solidFill>
+              </a:rPr>
+              <a:t>• Deletes an element from the page.</a:t>
+            </a:r>
+          </a:p>
+          <a:p>
+            <a:pPr>
+              <a:spcAft>
+                <a:spcPts val="1400"/>
+              </a:spcAft>
+            </a:pPr>
+            <a:r>
+              <a:rPr sz="2400">
+                <a:solidFill>
+                  <a:srgbClr val="1F2A37"/>
+                </a:solidFill>
+              </a:rPr>
+              <a:t>• chat.lastChild.remove() takes the last message back off.</a:t>
             </a:r>
           </a:p>
         </p:txBody>
@@ -14088,6 +13292,1641 @@
 <file path=ppt/slides/slide40.xml><?xml version="1.0" encoding="utf-8"?>
 <p:sld xmlns:a="http://schemas.openxmlformats.org/drawingml/2006/main" xmlns:p="http://schemas.openxmlformats.org/presentationml/2006/main" xmlns:r="http://schemas.openxmlformats.org/officeDocument/2006/relationships">
   <p:cSld>
+    <p:bg>
+      <p:bgPr>
+        <a:solidFill>
+          <a:srgbClr val="102127"/>
+        </a:solidFill>
+        <a:effectLst/>
+      </p:bgPr>
+    </p:bg>
+    <p:spTree>
+      <p:nvGrpSpPr>
+        <p:cNvPr id="1" name=""/>
+        <p:cNvGrpSpPr/>
+        <p:nvPr/>
+      </p:nvGrpSpPr>
+      <p:grpSpPr/>
+      <p:sp>
+        <p:nvSpPr>
+          <p:cNvPr id="2" name="TextBox 1"/>
+          <p:cNvSpPr txBox="1"/>
+          <p:nvPr/>
+        </p:nvSpPr>
+        <p:spPr>
+          <a:xfrm>
+            <a:off x="502920" y="274320"/>
+            <a:ext cx="11155680" cy="548640"/>
+          </a:xfrm>
+          <a:prstGeom prst="rect">
+            <a:avLst/>
+          </a:prstGeom>
+          <a:noFill/>
+        </p:spPr>
+        <p:txBody>
+          <a:bodyPr wrap="none">
+            <a:spAutoFit/>
+          </a:bodyPr>
+          <a:lstStyle/>
+          <a:p>
+            <a:r>
+              <a:rPr sz="2200" b="1">
+                <a:solidFill>
+                  <a:srgbClr val="01AEFD"/>
+                </a:solidFill>
+              </a:rPr>
+              <a:t>Type this into script.js   -   line 69</a:t>
+            </a:r>
+          </a:p>
+        </p:txBody>
+      </p:sp>
+      <p:sp>
+        <p:nvSpPr>
+          <p:cNvPr id="3" name="TextBox 2"/>
+          <p:cNvSpPr txBox="1"/>
+          <p:nvPr/>
+        </p:nvSpPr>
+        <p:spPr>
+          <a:xfrm>
+            <a:off x="502920" y="960120"/>
+            <a:ext cx="11155680" cy="4297680"/>
+          </a:xfrm>
+          <a:prstGeom prst="rect">
+            <a:avLst/>
+          </a:prstGeom>
+          <a:noFill/>
+        </p:spPr>
+        <p:txBody>
+          <a:bodyPr wrap="none">
+            <a:spAutoFit/>
+          </a:bodyPr>
+          <a:lstStyle/>
+          <a:p>
+            <a:pPr>
+              <a:spcAft>
+                <a:spcPts val="0"/>
+              </a:spcAft>
+            </a:pPr>
+            <a:r>
+              <a:rPr sz="1300">
+                <a:solidFill>
+                  <a:srgbClr val="6D8C97"/>
+                </a:solidFill>
+                <a:latin typeface="Consolas"/>
+              </a:rPr>
+              <a:t>  59  </a:t>
+            </a:r>
+            <a:r>
+              <a:rPr sz="1300">
+                <a:solidFill>
+                  <a:srgbClr val="6D8C97"/>
+                </a:solidFill>
+                <a:latin typeface="Consolas"/>
+              </a:rPr>
+              <a:t> </a:t>
+            </a:r>
+          </a:p>
+          <a:p>
+            <a:pPr>
+              <a:spcAft>
+                <a:spcPts val="0"/>
+              </a:spcAft>
+            </a:pPr>
+            <a:r>
+              <a:rPr sz="1300">
+                <a:solidFill>
+                  <a:srgbClr val="6D8C97"/>
+                </a:solidFill>
+                <a:latin typeface="Consolas"/>
+              </a:rPr>
+              <a:t>  60  </a:t>
+            </a:r>
+            <a:r>
+              <a:rPr sz="1300">
+                <a:solidFill>
+                  <a:srgbClr val="6D8C97"/>
+                </a:solidFill>
+                <a:latin typeface="Consolas"/>
+              </a:rPr>
+              <a:t>// The browser calls this when the form is submitted.</a:t>
+            </a:r>
+          </a:p>
+          <a:p>
+            <a:pPr>
+              <a:spcAft>
+                <a:spcPts val="0"/>
+              </a:spcAft>
+            </a:pPr>
+            <a:r>
+              <a:rPr sz="1300">
+                <a:solidFill>
+                  <a:srgbClr val="6D8C97"/>
+                </a:solidFill>
+                <a:latin typeface="Consolas"/>
+              </a:rPr>
+              <a:t>  61  </a:t>
+            </a:r>
+            <a:r>
+              <a:rPr sz="1300">
+                <a:solidFill>
+                  <a:srgbClr val="6D8C97"/>
+                </a:solidFill>
+                <a:latin typeface="Consolas"/>
+              </a:rPr>
+              <a:t>composer.addEventListener('submit', async function (event) {</a:t>
+            </a:r>
+          </a:p>
+          <a:p>
+            <a:pPr>
+              <a:spcAft>
+                <a:spcPts val="0"/>
+              </a:spcAft>
+            </a:pPr>
+            <a:r>
+              <a:rPr sz="1300">
+                <a:solidFill>
+                  <a:srgbClr val="6D8C97"/>
+                </a:solidFill>
+                <a:latin typeface="Consolas"/>
+              </a:rPr>
+              <a:t>  62  </a:t>
+            </a:r>
+            <a:r>
+              <a:rPr sz="1300">
+                <a:solidFill>
+                  <a:srgbClr val="6D8C97"/>
+                </a:solidFill>
+                <a:latin typeface="Consolas"/>
+              </a:rPr>
+              <a:t>  event.preventDefault();</a:t>
+            </a:r>
+          </a:p>
+          <a:p>
+            <a:pPr>
+              <a:spcAft>
+                <a:spcPts val="0"/>
+              </a:spcAft>
+            </a:pPr>
+            <a:r>
+              <a:rPr sz="1300">
+                <a:solidFill>
+                  <a:srgbClr val="6D8C97"/>
+                </a:solidFill>
+                <a:latin typeface="Consolas"/>
+              </a:rPr>
+              <a:t>  63  </a:t>
+            </a:r>
+            <a:r>
+              <a:rPr sz="1300">
+                <a:solidFill>
+                  <a:srgbClr val="6D8C97"/>
+                </a:solidFill>
+                <a:latin typeface="Consolas"/>
+              </a:rPr>
+              <a:t>  const text = promptBox.value.trim();</a:t>
+            </a:r>
+          </a:p>
+          <a:p>
+            <a:pPr>
+              <a:spcAft>
+                <a:spcPts val="0"/>
+              </a:spcAft>
+            </a:pPr>
+            <a:r>
+              <a:rPr sz="1300">
+                <a:solidFill>
+                  <a:srgbClr val="6D8C97"/>
+                </a:solidFill>
+                <a:latin typeface="Consolas"/>
+              </a:rPr>
+              <a:t>  64  </a:t>
+            </a:r>
+            <a:r>
+              <a:rPr sz="1300">
+                <a:solidFill>
+                  <a:srgbClr val="6D8C97"/>
+                </a:solidFill>
+                <a:latin typeface="Consolas"/>
+              </a:rPr>
+              <a:t>  if (text === '') { return; }</a:t>
+            </a:r>
+          </a:p>
+          <a:p>
+            <a:pPr>
+              <a:spcAft>
+                <a:spcPts val="0"/>
+              </a:spcAft>
+            </a:pPr>
+            <a:r>
+              <a:rPr sz="1300">
+                <a:solidFill>
+                  <a:srgbClr val="6D8C97"/>
+                </a:solidFill>
+                <a:latin typeface="Consolas"/>
+              </a:rPr>
+              <a:t>  65  </a:t>
+            </a:r>
+            <a:r>
+              <a:rPr sz="1300">
+                <a:solidFill>
+                  <a:srgbClr val="6D8C97"/>
+                </a:solidFill>
+                <a:latin typeface="Consolas"/>
+              </a:rPr>
+              <a:t>  promptBox.value = '';</a:t>
+            </a:r>
+          </a:p>
+          <a:p>
+            <a:pPr>
+              <a:spcAft>
+                <a:spcPts val="0"/>
+              </a:spcAft>
+            </a:pPr>
+            <a:r>
+              <a:rPr sz="1300">
+                <a:solidFill>
+                  <a:srgbClr val="6D8C97"/>
+                </a:solidFill>
+                <a:latin typeface="Consolas"/>
+              </a:rPr>
+              <a:t>  66  </a:t>
+            </a:r>
+            <a:r>
+              <a:rPr sz="1300">
+                <a:solidFill>
+                  <a:srgbClr val="6D8C97"/>
+                </a:solidFill>
+                <a:latin typeface="Consolas"/>
+              </a:rPr>
+              <a:t>  addLine('You', text);</a:t>
+            </a:r>
+          </a:p>
+          <a:p>
+            <a:pPr>
+              <a:spcAft>
+                <a:spcPts val="0"/>
+              </a:spcAft>
+            </a:pPr>
+            <a:r>
+              <a:rPr sz="1300">
+                <a:solidFill>
+                  <a:srgbClr val="6D8C97"/>
+                </a:solidFill>
+                <a:latin typeface="Consolas"/>
+              </a:rPr>
+              <a:t>  67  </a:t>
+            </a:r>
+            <a:r>
+              <a:rPr sz="1300">
+                <a:solidFill>
+                  <a:srgbClr val="6D8C97"/>
+                </a:solidFill>
+                <a:latin typeface="Consolas"/>
+              </a:rPr>
+              <a:t>  addLine('Companion', 'thinking...');</a:t>
+            </a:r>
+          </a:p>
+          <a:p>
+            <a:pPr>
+              <a:spcAft>
+                <a:spcPts val="0"/>
+              </a:spcAft>
+            </a:pPr>
+            <a:r>
+              <a:rPr sz="1300">
+                <a:solidFill>
+                  <a:srgbClr val="6D8C97"/>
+                </a:solidFill>
+                <a:latin typeface="Consolas"/>
+              </a:rPr>
+              <a:t>  68  </a:t>
+            </a:r>
+            <a:r>
+              <a:rPr sz="1300">
+                <a:solidFill>
+                  <a:srgbClr val="6D8C97"/>
+                </a:solidFill>
+                <a:latin typeface="Consolas"/>
+              </a:rPr>
+              <a:t>  const reply = await askAI(text);       // this is the slow bit</a:t>
+            </a:r>
+          </a:p>
+          <a:p>
+            <a:pPr>
+              <a:spcAft>
+                <a:spcPts val="0"/>
+              </a:spcAft>
+            </a:pPr>
+            <a:r>
+              <a:rPr sz="1300">
+                <a:solidFill>
+                  <a:srgbClr val="6D8C97"/>
+                </a:solidFill>
+                <a:latin typeface="Consolas"/>
+              </a:rPr>
+              <a:t>  69  </a:t>
+            </a:r>
+            <a:r>
+              <a:rPr sz="1300">
+                <a:solidFill>
+                  <a:srgbClr val="7FE0A0"/>
+                </a:solidFill>
+                <a:latin typeface="Consolas"/>
+              </a:rPr>
+              <a:t>  chat.lastChild.remove();               // take the 'thinking' line away</a:t>
+            </a:r>
+          </a:p>
+        </p:txBody>
+      </p:sp>
+      <p:sp>
+        <p:nvSpPr>
+          <p:cNvPr id="4" name="TextBox 3"/>
+          <p:cNvSpPr txBox="1"/>
+          <p:nvPr/>
+        </p:nvSpPr>
+        <p:spPr>
+          <a:xfrm>
+            <a:off x="548640" y="5623560"/>
+            <a:ext cx="11064240" cy="1051560"/>
+          </a:xfrm>
+          <a:prstGeom prst="rect">
+            <a:avLst/>
+          </a:prstGeom>
+          <a:noFill/>
+        </p:spPr>
+        <p:txBody>
+          <a:bodyPr wrap="square">
+            <a:spAutoFit/>
+          </a:bodyPr>
+          <a:lstStyle/>
+          <a:p>
+            <a:r>
+              <a:rPr sz="2000">
+                <a:solidFill>
+                  <a:srgbClr val="DCECEF"/>
+                </a:solidFill>
+              </a:rPr>
+              <a:t>Remove the 'thinking...' line now the real answer is here.</a:t>
+            </a:r>
+          </a:p>
+        </p:txBody>
+      </p:sp>
+    </p:spTree>
+  </p:cSld>
+  <p:clrMapOvr>
+    <a:masterClrMapping/>
+  </p:clrMapOvr>
+</p:sld>
+</file>
+
+<file path=ppt/slides/slide41.xml><?xml version="1.0" encoding="utf-8"?>
+<p:sld xmlns:a="http://schemas.openxmlformats.org/drawingml/2006/main" xmlns:p="http://schemas.openxmlformats.org/presentationml/2006/main" xmlns:r="http://schemas.openxmlformats.org/officeDocument/2006/relationships">
+  <p:cSld>
+    <p:bg>
+      <p:bgPr>
+        <a:solidFill>
+          <a:srgbClr val="102127"/>
+        </a:solidFill>
+        <a:effectLst/>
+      </p:bgPr>
+    </p:bg>
+    <p:spTree>
+      <p:nvGrpSpPr>
+        <p:cNvPr id="1" name=""/>
+        <p:cNvGrpSpPr/>
+        <p:nvPr/>
+      </p:nvGrpSpPr>
+      <p:grpSpPr/>
+      <p:sp>
+        <p:nvSpPr>
+          <p:cNvPr id="2" name="TextBox 1"/>
+          <p:cNvSpPr txBox="1"/>
+          <p:nvPr/>
+        </p:nvSpPr>
+        <p:spPr>
+          <a:xfrm>
+            <a:off x="502920" y="274320"/>
+            <a:ext cx="11155680" cy="548640"/>
+          </a:xfrm>
+          <a:prstGeom prst="rect">
+            <a:avLst/>
+          </a:prstGeom>
+          <a:noFill/>
+        </p:spPr>
+        <p:txBody>
+          <a:bodyPr wrap="none">
+            <a:spAutoFit/>
+          </a:bodyPr>
+          <a:lstStyle/>
+          <a:p>
+            <a:r>
+              <a:rPr sz="2200" b="1">
+                <a:solidFill>
+                  <a:srgbClr val="01AEFD"/>
+                </a:solidFill>
+              </a:rPr>
+              <a:t>Type this into script.js   -   line 70</a:t>
+            </a:r>
+          </a:p>
+        </p:txBody>
+      </p:sp>
+      <p:sp>
+        <p:nvSpPr>
+          <p:cNvPr id="3" name="TextBox 2"/>
+          <p:cNvSpPr txBox="1"/>
+          <p:nvPr/>
+        </p:nvSpPr>
+        <p:spPr>
+          <a:xfrm>
+            <a:off x="502920" y="960120"/>
+            <a:ext cx="11155680" cy="4297680"/>
+          </a:xfrm>
+          <a:prstGeom prst="rect">
+            <a:avLst/>
+          </a:prstGeom>
+          <a:noFill/>
+        </p:spPr>
+        <p:txBody>
+          <a:bodyPr wrap="none">
+            <a:spAutoFit/>
+          </a:bodyPr>
+          <a:lstStyle/>
+          <a:p>
+            <a:pPr>
+              <a:spcAft>
+                <a:spcPts val="0"/>
+              </a:spcAft>
+            </a:pPr>
+            <a:r>
+              <a:rPr sz="1300">
+                <a:solidFill>
+                  <a:srgbClr val="6D8C97"/>
+                </a:solidFill>
+                <a:latin typeface="Consolas"/>
+              </a:rPr>
+              <a:t>  59  </a:t>
+            </a:r>
+            <a:r>
+              <a:rPr sz="1300">
+                <a:solidFill>
+                  <a:srgbClr val="6D8C97"/>
+                </a:solidFill>
+                <a:latin typeface="Consolas"/>
+              </a:rPr>
+              <a:t> </a:t>
+            </a:r>
+          </a:p>
+          <a:p>
+            <a:pPr>
+              <a:spcAft>
+                <a:spcPts val="0"/>
+              </a:spcAft>
+            </a:pPr>
+            <a:r>
+              <a:rPr sz="1300">
+                <a:solidFill>
+                  <a:srgbClr val="6D8C97"/>
+                </a:solidFill>
+                <a:latin typeface="Consolas"/>
+              </a:rPr>
+              <a:t>  60  </a:t>
+            </a:r>
+            <a:r>
+              <a:rPr sz="1300">
+                <a:solidFill>
+                  <a:srgbClr val="6D8C97"/>
+                </a:solidFill>
+                <a:latin typeface="Consolas"/>
+              </a:rPr>
+              <a:t>// The browser calls this when the form is submitted.</a:t>
+            </a:r>
+          </a:p>
+          <a:p>
+            <a:pPr>
+              <a:spcAft>
+                <a:spcPts val="0"/>
+              </a:spcAft>
+            </a:pPr>
+            <a:r>
+              <a:rPr sz="1300">
+                <a:solidFill>
+                  <a:srgbClr val="6D8C97"/>
+                </a:solidFill>
+                <a:latin typeface="Consolas"/>
+              </a:rPr>
+              <a:t>  61  </a:t>
+            </a:r>
+            <a:r>
+              <a:rPr sz="1300">
+                <a:solidFill>
+                  <a:srgbClr val="6D8C97"/>
+                </a:solidFill>
+                <a:latin typeface="Consolas"/>
+              </a:rPr>
+              <a:t>composer.addEventListener('submit', async function (event) {</a:t>
+            </a:r>
+          </a:p>
+          <a:p>
+            <a:pPr>
+              <a:spcAft>
+                <a:spcPts val="0"/>
+              </a:spcAft>
+            </a:pPr>
+            <a:r>
+              <a:rPr sz="1300">
+                <a:solidFill>
+                  <a:srgbClr val="6D8C97"/>
+                </a:solidFill>
+                <a:latin typeface="Consolas"/>
+              </a:rPr>
+              <a:t>  62  </a:t>
+            </a:r>
+            <a:r>
+              <a:rPr sz="1300">
+                <a:solidFill>
+                  <a:srgbClr val="6D8C97"/>
+                </a:solidFill>
+                <a:latin typeface="Consolas"/>
+              </a:rPr>
+              <a:t>  event.preventDefault();</a:t>
+            </a:r>
+          </a:p>
+          <a:p>
+            <a:pPr>
+              <a:spcAft>
+                <a:spcPts val="0"/>
+              </a:spcAft>
+            </a:pPr>
+            <a:r>
+              <a:rPr sz="1300">
+                <a:solidFill>
+                  <a:srgbClr val="6D8C97"/>
+                </a:solidFill>
+                <a:latin typeface="Consolas"/>
+              </a:rPr>
+              <a:t>  63  </a:t>
+            </a:r>
+            <a:r>
+              <a:rPr sz="1300">
+                <a:solidFill>
+                  <a:srgbClr val="6D8C97"/>
+                </a:solidFill>
+                <a:latin typeface="Consolas"/>
+              </a:rPr>
+              <a:t>  const text = promptBox.value.trim();</a:t>
+            </a:r>
+          </a:p>
+          <a:p>
+            <a:pPr>
+              <a:spcAft>
+                <a:spcPts val="0"/>
+              </a:spcAft>
+            </a:pPr>
+            <a:r>
+              <a:rPr sz="1300">
+                <a:solidFill>
+                  <a:srgbClr val="6D8C97"/>
+                </a:solidFill>
+                <a:latin typeface="Consolas"/>
+              </a:rPr>
+              <a:t>  64  </a:t>
+            </a:r>
+            <a:r>
+              <a:rPr sz="1300">
+                <a:solidFill>
+                  <a:srgbClr val="6D8C97"/>
+                </a:solidFill>
+                <a:latin typeface="Consolas"/>
+              </a:rPr>
+              <a:t>  if (text === '') { return; }</a:t>
+            </a:r>
+          </a:p>
+          <a:p>
+            <a:pPr>
+              <a:spcAft>
+                <a:spcPts val="0"/>
+              </a:spcAft>
+            </a:pPr>
+            <a:r>
+              <a:rPr sz="1300">
+                <a:solidFill>
+                  <a:srgbClr val="6D8C97"/>
+                </a:solidFill>
+                <a:latin typeface="Consolas"/>
+              </a:rPr>
+              <a:t>  65  </a:t>
+            </a:r>
+            <a:r>
+              <a:rPr sz="1300">
+                <a:solidFill>
+                  <a:srgbClr val="6D8C97"/>
+                </a:solidFill>
+                <a:latin typeface="Consolas"/>
+              </a:rPr>
+              <a:t>  promptBox.value = '';</a:t>
+            </a:r>
+          </a:p>
+          <a:p>
+            <a:pPr>
+              <a:spcAft>
+                <a:spcPts val="0"/>
+              </a:spcAft>
+            </a:pPr>
+            <a:r>
+              <a:rPr sz="1300">
+                <a:solidFill>
+                  <a:srgbClr val="6D8C97"/>
+                </a:solidFill>
+                <a:latin typeface="Consolas"/>
+              </a:rPr>
+              <a:t>  66  </a:t>
+            </a:r>
+            <a:r>
+              <a:rPr sz="1300">
+                <a:solidFill>
+                  <a:srgbClr val="6D8C97"/>
+                </a:solidFill>
+                <a:latin typeface="Consolas"/>
+              </a:rPr>
+              <a:t>  addLine('You', text);</a:t>
+            </a:r>
+          </a:p>
+          <a:p>
+            <a:pPr>
+              <a:spcAft>
+                <a:spcPts val="0"/>
+              </a:spcAft>
+            </a:pPr>
+            <a:r>
+              <a:rPr sz="1300">
+                <a:solidFill>
+                  <a:srgbClr val="6D8C97"/>
+                </a:solidFill>
+                <a:latin typeface="Consolas"/>
+              </a:rPr>
+              <a:t>  67  </a:t>
+            </a:r>
+            <a:r>
+              <a:rPr sz="1300">
+                <a:solidFill>
+                  <a:srgbClr val="6D8C97"/>
+                </a:solidFill>
+                <a:latin typeface="Consolas"/>
+              </a:rPr>
+              <a:t>  addLine('Companion', 'thinking...');</a:t>
+            </a:r>
+          </a:p>
+          <a:p>
+            <a:pPr>
+              <a:spcAft>
+                <a:spcPts val="0"/>
+              </a:spcAft>
+            </a:pPr>
+            <a:r>
+              <a:rPr sz="1300">
+                <a:solidFill>
+                  <a:srgbClr val="6D8C97"/>
+                </a:solidFill>
+                <a:latin typeface="Consolas"/>
+              </a:rPr>
+              <a:t>  68  </a:t>
+            </a:r>
+            <a:r>
+              <a:rPr sz="1300">
+                <a:solidFill>
+                  <a:srgbClr val="6D8C97"/>
+                </a:solidFill>
+                <a:latin typeface="Consolas"/>
+              </a:rPr>
+              <a:t>  const reply = await askAI(text);       // this is the slow bit</a:t>
+            </a:r>
+          </a:p>
+          <a:p>
+            <a:pPr>
+              <a:spcAft>
+                <a:spcPts val="0"/>
+              </a:spcAft>
+            </a:pPr>
+            <a:r>
+              <a:rPr sz="1300">
+                <a:solidFill>
+                  <a:srgbClr val="6D8C97"/>
+                </a:solidFill>
+                <a:latin typeface="Consolas"/>
+              </a:rPr>
+              <a:t>  69  </a:t>
+            </a:r>
+            <a:r>
+              <a:rPr sz="1300">
+                <a:solidFill>
+                  <a:srgbClr val="6D8C97"/>
+                </a:solidFill>
+                <a:latin typeface="Consolas"/>
+              </a:rPr>
+              <a:t>  chat.lastChild.remove();               // take the 'thinking' line away</a:t>
+            </a:r>
+          </a:p>
+          <a:p>
+            <a:pPr>
+              <a:spcAft>
+                <a:spcPts val="0"/>
+              </a:spcAft>
+            </a:pPr>
+            <a:r>
+              <a:rPr sz="1300">
+                <a:solidFill>
+                  <a:srgbClr val="6D8C97"/>
+                </a:solidFill>
+                <a:latin typeface="Consolas"/>
+              </a:rPr>
+              <a:t>  70  </a:t>
+            </a:r>
+            <a:r>
+              <a:rPr sz="1300">
+                <a:solidFill>
+                  <a:srgbClr val="7FE0A0"/>
+                </a:solidFill>
+                <a:latin typeface="Consolas"/>
+              </a:rPr>
+              <a:t>  addLine('Companion', reply);</a:t>
+            </a:r>
+          </a:p>
+        </p:txBody>
+      </p:sp>
+      <p:sp>
+        <p:nvSpPr>
+          <p:cNvPr id="4" name="TextBox 3"/>
+          <p:cNvSpPr txBox="1"/>
+          <p:nvPr/>
+        </p:nvSpPr>
+        <p:spPr>
+          <a:xfrm>
+            <a:off x="548640" y="5623560"/>
+            <a:ext cx="11064240" cy="1051560"/>
+          </a:xfrm>
+          <a:prstGeom prst="rect">
+            <a:avLst/>
+          </a:prstGeom>
+          <a:noFill/>
+        </p:spPr>
+        <p:txBody>
+          <a:bodyPr wrap="square">
+            <a:spAutoFit/>
+          </a:bodyPr>
+          <a:lstStyle/>
+          <a:p>
+            <a:r>
+              <a:rPr sz="2000">
+                <a:solidFill>
+                  <a:srgbClr val="DCECEF"/>
+                </a:solidFill>
+              </a:rPr>
+              <a:t>Show the real reply in the chat.</a:t>
+            </a:r>
+          </a:p>
+        </p:txBody>
+      </p:sp>
+    </p:spTree>
+  </p:cSld>
+  <p:clrMapOvr>
+    <a:masterClrMapping/>
+  </p:clrMapOvr>
+</p:sld>
+</file>
+
+<file path=ppt/slides/slide42.xml><?xml version="1.0" encoding="utf-8"?>
+<p:sld xmlns:a="http://schemas.openxmlformats.org/drawingml/2006/main" xmlns:p="http://schemas.openxmlformats.org/presentationml/2006/main" xmlns:r="http://schemas.openxmlformats.org/officeDocument/2006/relationships">
+  <p:cSld>
+    <p:bg>
+      <p:bgPr>
+        <a:solidFill>
+          <a:srgbClr val="102127"/>
+        </a:solidFill>
+        <a:effectLst/>
+      </p:bgPr>
+    </p:bg>
+    <p:spTree>
+      <p:nvGrpSpPr>
+        <p:cNvPr id="1" name=""/>
+        <p:cNvGrpSpPr/>
+        <p:nvPr/>
+      </p:nvGrpSpPr>
+      <p:grpSpPr/>
+      <p:sp>
+        <p:nvSpPr>
+          <p:cNvPr id="2" name="TextBox 1"/>
+          <p:cNvSpPr txBox="1"/>
+          <p:nvPr/>
+        </p:nvSpPr>
+        <p:spPr>
+          <a:xfrm>
+            <a:off x="502920" y="274320"/>
+            <a:ext cx="11155680" cy="548640"/>
+          </a:xfrm>
+          <a:prstGeom prst="rect">
+            <a:avLst/>
+          </a:prstGeom>
+          <a:noFill/>
+        </p:spPr>
+        <p:txBody>
+          <a:bodyPr wrap="none">
+            <a:spAutoFit/>
+          </a:bodyPr>
+          <a:lstStyle/>
+          <a:p>
+            <a:r>
+              <a:rPr sz="2200" b="1">
+                <a:solidFill>
+                  <a:srgbClr val="01AEFD"/>
+                </a:solidFill>
+              </a:rPr>
+              <a:t>All together in script.js</a:t>
+            </a:r>
+          </a:p>
+        </p:txBody>
+      </p:sp>
+      <p:sp>
+        <p:nvSpPr>
+          <p:cNvPr id="3" name="TextBox 2"/>
+          <p:cNvSpPr txBox="1"/>
+          <p:nvPr/>
+        </p:nvSpPr>
+        <p:spPr>
+          <a:xfrm>
+            <a:off x="502920" y="960120"/>
+            <a:ext cx="11155680" cy="4297680"/>
+          </a:xfrm>
+          <a:prstGeom prst="rect">
+            <a:avLst/>
+          </a:prstGeom>
+          <a:noFill/>
+        </p:spPr>
+        <p:txBody>
+          <a:bodyPr wrap="none">
+            <a:spAutoFit/>
+          </a:bodyPr>
+          <a:lstStyle/>
+          <a:p>
+            <a:pPr>
+              <a:spcAft>
+                <a:spcPts val="0"/>
+              </a:spcAft>
+            </a:pPr>
+            <a:r>
+              <a:rPr sz="1300">
+                <a:solidFill>
+                  <a:srgbClr val="6D8C97"/>
+                </a:solidFill>
+                <a:latin typeface="Consolas"/>
+              </a:rPr>
+              <a:t>  59  </a:t>
+            </a:r>
+            <a:r>
+              <a:rPr sz="1300">
+                <a:solidFill>
+                  <a:srgbClr val="7FE0A0"/>
+                </a:solidFill>
+                <a:latin typeface="Consolas"/>
+              </a:rPr>
+              <a:t> </a:t>
+            </a:r>
+          </a:p>
+          <a:p>
+            <a:pPr>
+              <a:spcAft>
+                <a:spcPts val="0"/>
+              </a:spcAft>
+            </a:pPr>
+            <a:r>
+              <a:rPr sz="1300">
+                <a:solidFill>
+                  <a:srgbClr val="6D8C97"/>
+                </a:solidFill>
+                <a:latin typeface="Consolas"/>
+              </a:rPr>
+              <a:t>  60  </a:t>
+            </a:r>
+            <a:r>
+              <a:rPr sz="1300">
+                <a:solidFill>
+                  <a:srgbClr val="7FE0A0"/>
+                </a:solidFill>
+                <a:latin typeface="Consolas"/>
+              </a:rPr>
+              <a:t>// The browser calls this when the form is submitted.</a:t>
+            </a:r>
+          </a:p>
+          <a:p>
+            <a:pPr>
+              <a:spcAft>
+                <a:spcPts val="0"/>
+              </a:spcAft>
+            </a:pPr>
+            <a:r>
+              <a:rPr sz="1300">
+                <a:solidFill>
+                  <a:srgbClr val="6D8C97"/>
+                </a:solidFill>
+                <a:latin typeface="Consolas"/>
+              </a:rPr>
+              <a:t>  61  </a:t>
+            </a:r>
+            <a:r>
+              <a:rPr sz="1300">
+                <a:solidFill>
+                  <a:srgbClr val="7FE0A0"/>
+                </a:solidFill>
+                <a:latin typeface="Consolas"/>
+              </a:rPr>
+              <a:t>composer.addEventListener('submit', async function (event) {</a:t>
+            </a:r>
+          </a:p>
+          <a:p>
+            <a:pPr>
+              <a:spcAft>
+                <a:spcPts val="0"/>
+              </a:spcAft>
+            </a:pPr>
+            <a:r>
+              <a:rPr sz="1300">
+                <a:solidFill>
+                  <a:srgbClr val="6D8C97"/>
+                </a:solidFill>
+                <a:latin typeface="Consolas"/>
+              </a:rPr>
+              <a:t>  62  </a:t>
+            </a:r>
+            <a:r>
+              <a:rPr sz="1300">
+                <a:solidFill>
+                  <a:srgbClr val="7FE0A0"/>
+                </a:solidFill>
+                <a:latin typeface="Consolas"/>
+              </a:rPr>
+              <a:t>  event.preventDefault();</a:t>
+            </a:r>
+          </a:p>
+          <a:p>
+            <a:pPr>
+              <a:spcAft>
+                <a:spcPts val="0"/>
+              </a:spcAft>
+            </a:pPr>
+            <a:r>
+              <a:rPr sz="1300">
+                <a:solidFill>
+                  <a:srgbClr val="6D8C97"/>
+                </a:solidFill>
+                <a:latin typeface="Consolas"/>
+              </a:rPr>
+              <a:t>  63  </a:t>
+            </a:r>
+            <a:r>
+              <a:rPr sz="1300">
+                <a:solidFill>
+                  <a:srgbClr val="7FE0A0"/>
+                </a:solidFill>
+                <a:latin typeface="Consolas"/>
+              </a:rPr>
+              <a:t>  const text = promptBox.value.trim();</a:t>
+            </a:r>
+          </a:p>
+          <a:p>
+            <a:pPr>
+              <a:spcAft>
+                <a:spcPts val="0"/>
+              </a:spcAft>
+            </a:pPr>
+            <a:r>
+              <a:rPr sz="1300">
+                <a:solidFill>
+                  <a:srgbClr val="6D8C97"/>
+                </a:solidFill>
+                <a:latin typeface="Consolas"/>
+              </a:rPr>
+              <a:t>  64  </a:t>
+            </a:r>
+            <a:r>
+              <a:rPr sz="1300">
+                <a:solidFill>
+                  <a:srgbClr val="7FE0A0"/>
+                </a:solidFill>
+                <a:latin typeface="Consolas"/>
+              </a:rPr>
+              <a:t>  if (text === '') { return; }</a:t>
+            </a:r>
+          </a:p>
+          <a:p>
+            <a:pPr>
+              <a:spcAft>
+                <a:spcPts val="0"/>
+              </a:spcAft>
+            </a:pPr>
+            <a:r>
+              <a:rPr sz="1300">
+                <a:solidFill>
+                  <a:srgbClr val="6D8C97"/>
+                </a:solidFill>
+                <a:latin typeface="Consolas"/>
+              </a:rPr>
+              <a:t>  65  </a:t>
+            </a:r>
+            <a:r>
+              <a:rPr sz="1300">
+                <a:solidFill>
+                  <a:srgbClr val="7FE0A0"/>
+                </a:solidFill>
+                <a:latin typeface="Consolas"/>
+              </a:rPr>
+              <a:t>  promptBox.value = '';</a:t>
+            </a:r>
+          </a:p>
+          <a:p>
+            <a:pPr>
+              <a:spcAft>
+                <a:spcPts val="0"/>
+              </a:spcAft>
+            </a:pPr>
+            <a:r>
+              <a:rPr sz="1300">
+                <a:solidFill>
+                  <a:srgbClr val="6D8C97"/>
+                </a:solidFill>
+                <a:latin typeface="Consolas"/>
+              </a:rPr>
+              <a:t>  66  </a:t>
+            </a:r>
+            <a:r>
+              <a:rPr sz="1300">
+                <a:solidFill>
+                  <a:srgbClr val="7FE0A0"/>
+                </a:solidFill>
+                <a:latin typeface="Consolas"/>
+              </a:rPr>
+              <a:t>  addLine('You', text);</a:t>
+            </a:r>
+          </a:p>
+          <a:p>
+            <a:pPr>
+              <a:spcAft>
+                <a:spcPts val="0"/>
+              </a:spcAft>
+            </a:pPr>
+            <a:r>
+              <a:rPr sz="1300">
+                <a:solidFill>
+                  <a:srgbClr val="6D8C97"/>
+                </a:solidFill>
+                <a:latin typeface="Consolas"/>
+              </a:rPr>
+              <a:t>  67  </a:t>
+            </a:r>
+            <a:r>
+              <a:rPr sz="1300">
+                <a:solidFill>
+                  <a:srgbClr val="7FE0A0"/>
+                </a:solidFill>
+                <a:latin typeface="Consolas"/>
+              </a:rPr>
+              <a:t>  addLine('Companion', 'thinking...');</a:t>
+            </a:r>
+          </a:p>
+          <a:p>
+            <a:pPr>
+              <a:spcAft>
+                <a:spcPts val="0"/>
+              </a:spcAft>
+            </a:pPr>
+            <a:r>
+              <a:rPr sz="1300">
+                <a:solidFill>
+                  <a:srgbClr val="6D8C97"/>
+                </a:solidFill>
+                <a:latin typeface="Consolas"/>
+              </a:rPr>
+              <a:t>  68  </a:t>
+            </a:r>
+            <a:r>
+              <a:rPr sz="1300">
+                <a:solidFill>
+                  <a:srgbClr val="7FE0A0"/>
+                </a:solidFill>
+                <a:latin typeface="Consolas"/>
+              </a:rPr>
+              <a:t>  const reply = await askAI(text);       // this is the slow bit</a:t>
+            </a:r>
+          </a:p>
+          <a:p>
+            <a:pPr>
+              <a:spcAft>
+                <a:spcPts val="0"/>
+              </a:spcAft>
+            </a:pPr>
+            <a:r>
+              <a:rPr sz="1300">
+                <a:solidFill>
+                  <a:srgbClr val="6D8C97"/>
+                </a:solidFill>
+                <a:latin typeface="Consolas"/>
+              </a:rPr>
+              <a:t>  69  </a:t>
+            </a:r>
+            <a:r>
+              <a:rPr sz="1300">
+                <a:solidFill>
+                  <a:srgbClr val="7FE0A0"/>
+                </a:solidFill>
+                <a:latin typeface="Consolas"/>
+              </a:rPr>
+              <a:t>  chat.lastChild.remove();               // take the 'thinking' line away</a:t>
+            </a:r>
+          </a:p>
+          <a:p>
+            <a:pPr>
+              <a:spcAft>
+                <a:spcPts val="0"/>
+              </a:spcAft>
+            </a:pPr>
+            <a:r>
+              <a:rPr sz="1300">
+                <a:solidFill>
+                  <a:srgbClr val="6D8C97"/>
+                </a:solidFill>
+                <a:latin typeface="Consolas"/>
+              </a:rPr>
+              <a:t>  70  </a:t>
+            </a:r>
+            <a:r>
+              <a:rPr sz="1300">
+                <a:solidFill>
+                  <a:srgbClr val="7FE0A0"/>
+                </a:solidFill>
+                <a:latin typeface="Consolas"/>
+              </a:rPr>
+              <a:t>  addLine('Companion', reply);</a:t>
+            </a:r>
+          </a:p>
+          <a:p>
+            <a:pPr>
+              <a:spcAft>
+                <a:spcPts val="0"/>
+              </a:spcAft>
+            </a:pPr>
+            <a:r>
+              <a:rPr sz="1300">
+                <a:solidFill>
+                  <a:srgbClr val="6D8C97"/>
+                </a:solidFill>
+                <a:latin typeface="Consolas"/>
+              </a:rPr>
+              <a:t>  71  </a:t>
+            </a:r>
+            <a:r>
+              <a:rPr sz="1300">
+                <a:solidFill>
+                  <a:srgbClr val="7FE0A0"/>
+                </a:solidFill>
+                <a:latin typeface="Consolas"/>
+              </a:rPr>
+              <a:t>});</a:t>
+            </a:r>
+          </a:p>
+        </p:txBody>
+      </p:sp>
+      <p:sp>
+        <p:nvSpPr>
+          <p:cNvPr id="4" name="TextBox 3"/>
+          <p:cNvSpPr txBox="1"/>
+          <p:nvPr/>
+        </p:nvSpPr>
+        <p:spPr>
+          <a:xfrm>
+            <a:off x="548640" y="5623560"/>
+            <a:ext cx="11064240" cy="1051560"/>
+          </a:xfrm>
+          <a:prstGeom prst="rect">
+            <a:avLst/>
+          </a:prstGeom>
+          <a:noFill/>
+        </p:spPr>
+        <p:txBody>
+          <a:bodyPr wrap="square">
+            <a:spAutoFit/>
+          </a:bodyPr>
+          <a:lstStyle/>
+          <a:p>
+            <a:r>
+              <a:rPr sz="2000">
+                <a:solidFill>
+                  <a:srgbClr val="DCECEF"/>
+                </a:solidFill>
+              </a:rPr>
+              <a:t>That is the whole piece. Check yours looks the same before moving on.</a:t>
+            </a:r>
+          </a:p>
+        </p:txBody>
+      </p:sp>
+    </p:spTree>
+  </p:cSld>
+  <p:clrMapOvr>
+    <a:masterClrMapping/>
+  </p:clrMapOvr>
+</p:sld>
+</file>
+
+<file path=ppt/slides/slide43.xml><?xml version="1.0" encoding="utf-8"?>
+<p:sld xmlns:a="http://schemas.openxmlformats.org/drawingml/2006/main" xmlns:p="http://schemas.openxmlformats.org/presentationml/2006/main" xmlns:r="http://schemas.openxmlformats.org/officeDocument/2006/relationships">
+  <p:cSld>
+    <p:bg>
+      <p:bgPr>
+        <a:solidFill>
+          <a:srgbClr val="102127"/>
+        </a:solidFill>
+        <a:effectLst/>
+      </p:bgPr>
+    </p:bg>
+    <p:spTree>
+      <p:nvGrpSpPr>
+        <p:cNvPr id="1" name=""/>
+        <p:cNvGrpSpPr/>
+        <p:nvPr/>
+      </p:nvGrpSpPr>
+      <p:grpSpPr/>
+      <p:sp>
+        <p:nvSpPr>
+          <p:cNvPr id="2" name="TextBox 1"/>
+          <p:cNvSpPr txBox="1"/>
+          <p:nvPr/>
+        </p:nvSpPr>
+        <p:spPr>
+          <a:xfrm>
+            <a:off x="502920" y="274320"/>
+            <a:ext cx="11155680" cy="548640"/>
+          </a:xfrm>
+          <a:prstGeom prst="rect">
+            <a:avLst/>
+          </a:prstGeom>
+          <a:noFill/>
+        </p:spPr>
+        <p:txBody>
+          <a:bodyPr wrap="none">
+            <a:spAutoFit/>
+          </a:bodyPr>
+          <a:lstStyle/>
+          <a:p>
+            <a:r>
+              <a:rPr sz="2200" b="1">
+                <a:solidFill>
+                  <a:srgbClr val="01AEFD"/>
+                </a:solidFill>
+              </a:rPr>
+              <a:t>In script.js   -   delete a line</a:t>
+            </a:r>
+          </a:p>
+        </p:txBody>
+      </p:sp>
+      <p:sp>
+        <p:nvSpPr>
+          <p:cNvPr id="3" name="TextBox 2"/>
+          <p:cNvSpPr txBox="1"/>
+          <p:nvPr/>
+        </p:nvSpPr>
+        <p:spPr>
+          <a:xfrm>
+            <a:off x="502920" y="960120"/>
+            <a:ext cx="11155680" cy="4297680"/>
+          </a:xfrm>
+          <a:prstGeom prst="rect">
+            <a:avLst/>
+          </a:prstGeom>
+          <a:noFill/>
+        </p:spPr>
+        <p:txBody>
+          <a:bodyPr wrap="none">
+            <a:spAutoFit/>
+          </a:bodyPr>
+          <a:lstStyle/>
+          <a:p>
+            <a:pPr>
+              <a:spcAft>
+                <a:spcPts val="0"/>
+              </a:spcAft>
+            </a:pPr>
+            <a:r>
+              <a:rPr sz="1300">
+                <a:solidFill>
+                  <a:srgbClr val="6D8C97"/>
+                </a:solidFill>
+                <a:latin typeface="Consolas"/>
+              </a:rPr>
+              <a:t>  29  </a:t>
+            </a:r>
+            <a:r>
+              <a:rPr sz="1300">
+                <a:solidFill>
+                  <a:srgbClr val="6D8C97"/>
+                </a:solidFill>
+                <a:latin typeface="Consolas"/>
+              </a:rPr>
+              <a:t> </a:t>
+            </a:r>
+          </a:p>
+          <a:p>
+            <a:pPr>
+              <a:spcAft>
+                <a:spcPts val="0"/>
+              </a:spcAft>
+            </a:pPr>
+            <a:r>
+              <a:rPr sz="1300">
+                <a:solidFill>
+                  <a:srgbClr val="6D8C97"/>
+                </a:solidFill>
+                <a:latin typeface="Consolas"/>
+              </a:rPr>
+              <a:t>  30  </a:t>
+            </a:r>
+            <a:r>
+              <a:rPr sz="1300">
+                <a:solidFill>
+                  <a:srgbClr val="6D8C97"/>
+                </a:solidFill>
+                <a:latin typeface="Consolas"/>
+              </a:rPr>
+              <a:t>// The smallest useful request: what models does this server have?</a:t>
+            </a:r>
+          </a:p>
+          <a:p>
+            <a:pPr>
+              <a:spcAft>
+                <a:spcPts val="0"/>
+              </a:spcAft>
+            </a:pPr>
+            <a:r>
+              <a:rPr sz="1300">
+                <a:solidFill>
+                  <a:srgbClr val="6D8C97"/>
+                </a:solidFill>
+                <a:latin typeface="Consolas"/>
+              </a:rPr>
+              <a:t>  31  </a:t>
+            </a:r>
+            <a:r>
+              <a:rPr sz="1300">
+                <a:solidFill>
+                  <a:srgbClr val="6D8C97"/>
+                </a:solidFill>
+                <a:latin typeface="Consolas"/>
+              </a:rPr>
+              <a:t>// 'async' means this function does something slow and can be waited for.</a:t>
+            </a:r>
+          </a:p>
+          <a:p>
+            <a:pPr>
+              <a:spcAft>
+                <a:spcPts val="0"/>
+              </a:spcAft>
+            </a:pPr>
+            <a:r>
+              <a:rPr sz="1300">
+                <a:solidFill>
+                  <a:srgbClr val="6D8C97"/>
+                </a:solidFill>
+                <a:latin typeface="Consolas"/>
+              </a:rPr>
+              <a:t>  32  </a:t>
+            </a:r>
+            <a:r>
+              <a:rPr sz="1300">
+                <a:solidFill>
+                  <a:srgbClr val="6D8C97"/>
+                </a:solidFill>
+                <a:latin typeface="Consolas"/>
+              </a:rPr>
+              <a:t>async function listModels() {</a:t>
+            </a:r>
+          </a:p>
+          <a:p>
+            <a:pPr>
+              <a:spcAft>
+                <a:spcPts val="0"/>
+              </a:spcAft>
+            </a:pPr>
+            <a:r>
+              <a:rPr sz="1300">
+                <a:solidFill>
+                  <a:srgbClr val="6D8C97"/>
+                </a:solidFill>
+                <a:latin typeface="Consolas"/>
+              </a:rPr>
+              <a:t>  33  </a:t>
+            </a:r>
+            <a:r>
+              <a:rPr sz="1300">
+                <a:solidFill>
+                  <a:srgbClr val="6D8C97"/>
+                </a:solidFill>
+                <a:latin typeface="Consolas"/>
+              </a:rPr>
+              <a:t>  const res = await fetch(AI_BASE + '/v1/models', {</a:t>
+            </a:r>
+          </a:p>
+          <a:p>
+            <a:pPr>
+              <a:spcAft>
+                <a:spcPts val="0"/>
+              </a:spcAft>
+            </a:pPr>
+            <a:r>
+              <a:rPr sz="1300">
+                <a:solidFill>
+                  <a:srgbClr val="6D8C97"/>
+                </a:solidFill>
+                <a:latin typeface="Consolas"/>
+              </a:rPr>
+              <a:t>  34  </a:t>
+            </a:r>
+            <a:r>
+              <a:rPr sz="1300">
+                <a:solidFill>
+                  <a:srgbClr val="6D8C97"/>
+                </a:solidFill>
+                <a:latin typeface="Consolas"/>
+              </a:rPr>
+              <a:t>    headers: { 'Authorization': 'Bearer ' + API_KEY }</a:t>
+            </a:r>
+          </a:p>
+          <a:p>
+            <a:pPr>
+              <a:spcAft>
+                <a:spcPts val="0"/>
+              </a:spcAft>
+            </a:pPr>
+            <a:r>
+              <a:rPr sz="1300">
+                <a:solidFill>
+                  <a:srgbClr val="6D8C97"/>
+                </a:solidFill>
+                <a:latin typeface="Consolas"/>
+              </a:rPr>
+              <a:t>  35  </a:t>
+            </a:r>
+            <a:r>
+              <a:rPr sz="1300">
+                <a:solidFill>
+                  <a:srgbClr val="6D8C97"/>
+                </a:solidFill>
+                <a:latin typeface="Consolas"/>
+              </a:rPr>
+              <a:t>  });</a:t>
+            </a:r>
+          </a:p>
+          <a:p>
+            <a:pPr>
+              <a:spcAft>
+                <a:spcPts val="0"/>
+              </a:spcAft>
+            </a:pPr>
+            <a:r>
+              <a:rPr sz="1300">
+                <a:solidFill>
+                  <a:srgbClr val="6D8C97"/>
+                </a:solidFill>
+                <a:latin typeface="Consolas"/>
+              </a:rPr>
+              <a:t>  36  </a:t>
+            </a:r>
+            <a:r>
+              <a:rPr sz="1300">
+                <a:solidFill>
+                  <a:srgbClr val="6D8C97"/>
+                </a:solidFill>
+                <a:latin typeface="Consolas"/>
+              </a:rPr>
+              <a:t>  const data = await res.json();   // the answer arrives as text; this reads it</a:t>
+            </a:r>
+          </a:p>
+          <a:p>
+            <a:pPr>
+              <a:spcAft>
+                <a:spcPts val="0"/>
+              </a:spcAft>
+            </a:pPr>
+            <a:r>
+              <a:rPr sz="1300">
+                <a:solidFill>
+                  <a:srgbClr val="6D8C97"/>
+                </a:solidFill>
+                <a:latin typeface="Consolas"/>
+              </a:rPr>
+              <a:t>  37  </a:t>
+            </a:r>
+            <a:r>
+              <a:rPr sz="1300">
+                <a:solidFill>
+                  <a:srgbClr val="6D8C97"/>
+                </a:solidFill>
+                <a:latin typeface="Consolas"/>
+              </a:rPr>
+              <a:t>  console.log('The server offers:', data.data);</a:t>
+            </a:r>
+          </a:p>
+          <a:p>
+            <a:pPr>
+              <a:spcAft>
+                <a:spcPts val="0"/>
+              </a:spcAft>
+            </a:pPr>
+            <a:r>
+              <a:rPr sz="1300">
+                <a:solidFill>
+                  <a:srgbClr val="6D8C97"/>
+                </a:solidFill>
+                <a:latin typeface="Consolas"/>
+              </a:rPr>
+              <a:t>  38  </a:t>
+            </a:r>
+            <a:r>
+              <a:rPr sz="1300">
+                <a:solidFill>
+                  <a:srgbClr val="6D8C97"/>
+                </a:solidFill>
+                <a:latin typeface="Consolas"/>
+              </a:rPr>
+              <a:t>}</a:t>
+            </a:r>
+          </a:p>
+          <a:p>
+            <a:pPr>
+              <a:spcAft>
+                <a:spcPts val="0"/>
+              </a:spcAft>
+            </a:pPr>
+            <a:r>
+              <a:rPr sz="1300">
+                <a:solidFill>
+                  <a:srgbClr val="6D8C97"/>
+                </a:solidFill>
+                <a:latin typeface="Consolas"/>
+              </a:rPr>
+              <a:t>   -  </a:t>
+            </a:r>
+            <a:r>
+              <a:rPr sz="1300" strike="sngStrike">
+                <a:solidFill>
+                  <a:srgbClr val="F3928B"/>
+                </a:solidFill>
+                <a:latin typeface="Consolas"/>
+              </a:rPr>
+              <a:t>listModels();</a:t>
+            </a:r>
+          </a:p>
+        </p:txBody>
+      </p:sp>
+      <p:sp>
+        <p:nvSpPr>
+          <p:cNvPr id="4" name="TextBox 3"/>
+          <p:cNvSpPr txBox="1"/>
+          <p:nvPr/>
+        </p:nvSpPr>
+        <p:spPr>
+          <a:xfrm>
+            <a:off x="548640" y="5623560"/>
+            <a:ext cx="11064240" cy="1051560"/>
+          </a:xfrm>
+          <a:prstGeom prst="rect">
+            <a:avLst/>
+          </a:prstGeom>
+          <a:noFill/>
+        </p:spPr>
+        <p:txBody>
+          <a:bodyPr wrap="square">
+            <a:spAutoFit/>
+          </a:bodyPr>
+          <a:lstStyle/>
+          <a:p>
+            <a:r>
+              <a:rPr sz="2000">
+                <a:solidFill>
+                  <a:srgbClr val="DCECEF"/>
+                </a:solidFill>
+              </a:rPr>
+              <a:t>Delete this line. askAI does the asking now, so the old test call is no longer needed - your file should have no listModels() call left.</a:t>
+            </a:r>
+          </a:p>
+        </p:txBody>
+      </p:sp>
+    </p:spTree>
+  </p:cSld>
+  <p:clrMapOvr>
+    <a:masterClrMapping/>
+  </p:clrMapOvr>
+</p:sld>
+</file>
+
+<file path=ppt/slides/slide44.xml><?xml version="1.0" encoding="utf-8"?>
+<p:sld xmlns:a="http://schemas.openxmlformats.org/drawingml/2006/main" xmlns:p="http://schemas.openxmlformats.org/presentationml/2006/main" xmlns:r="http://schemas.openxmlformats.org/officeDocument/2006/relationships">
+  <p:cSld>
     <p:spTree>
       <p:nvGrpSpPr>
         <p:cNvPr id="1" name=""/>
@@ -14230,7 +15069,7 @@
 </p:sld>
 </file>
 
-<file path=ppt/slides/slide41.xml><?xml version="1.0" encoding="utf-8"?>
+<file path=ppt/slides/slide45.xml><?xml version="1.0" encoding="utf-8"?>
 <p:sld xmlns:a="http://schemas.openxmlformats.org/drawingml/2006/main" xmlns:p="http://schemas.openxmlformats.org/presentationml/2006/main" xmlns:r="http://schemas.openxmlformats.org/officeDocument/2006/relationships">
   <p:cSld>
     <p:spTree>

</xml_diff>

<commit_message>
Show the real line number on delete and replace slides
The struck line showed a dash in the gutter, so a student could not tell which
line to remove. It now shows the line's actual number - the one they see in
their own editor - across the expanded delete/replace slides, the chunked-week
slides, the .pptx, and the teacher guide/workbook.

Co-Authored-By: Claude Opus 4.8 <noreply@anthropic.com>
</commit_message>
<xml_diff>
--- a/ai101/slides/week-04.pptx
+++ b/ai101/slides/week-04.pptx
@@ -11117,7 +11117,7 @@
                 </a:solidFill>
                 <a:latin typeface="Consolas"/>
               </a:rPr>
-              <a:t>   -  </a:t>
+              <a:t>  60  </a:t>
             </a:r>
             <a:r>
               <a:rPr sz="1800" strike="sngStrike">
@@ -11282,7 +11282,7 @@
                 </a:solidFill>
                 <a:latin typeface="Consolas"/>
               </a:rPr>
-              <a:t>   -  </a:t>
+              <a:t>  60  </a:t>
             </a:r>
             <a:r>
               <a:rPr sz="1800" strike="sngStrike">
@@ -11447,7 +11447,7 @@
                 </a:solidFill>
                 <a:latin typeface="Consolas"/>
               </a:rPr>
-              <a:t>   -  </a:t>
+              <a:t>  60  </a:t>
             </a:r>
             <a:r>
               <a:rPr sz="1800" strike="sngStrike">
@@ -12142,7 +12142,7 @@
                 </a:solidFill>
                 <a:latin typeface="Consolas"/>
               </a:rPr>
-              <a:t>   -  </a:t>
+              <a:t>  67  </a:t>
             </a:r>
             <a:r>
               <a:rPr sz="1800" strike="sngStrike">
@@ -14869,7 +14869,7 @@
                 </a:solidFill>
                 <a:latin typeface="Consolas"/>
               </a:rPr>
-              <a:t>   -  </a:t>
+              <a:t>  39  </a:t>
             </a:r>
             <a:r>
               <a:rPr sz="1300" strike="sngStrike">

</xml_diff>

<commit_message>
Group a consecutive run of deletions onto one slide
Removing five lines from one spot produced five near-identical slides: the
same block, the same context, one more line struck each time. It is also not
what a student does - they select the run and delete it once.

Everything dropped at one position now goes on a single slide, struck through
together, numbered with the real line numbers, headed "replace 4 lines". The
"type this" slides for the replacement follow as before.

39 delete slides -> 22, covering the same 39 lines. Deck 905 -> 888.

Co-Authored-By: Claude Opus 4.8 <noreply@anthropic.com>
</commit_message>
<xml_diff>
--- a/ai101/slides/week-04.pptx
+++ b/ai101/slides/week-04.pptx
@@ -56,8 +56,6 @@
     <p:sldId id="304" r:id="rId55"/>
     <p:sldId id="305" r:id="rId56"/>
     <p:sldId id="306" r:id="rId57"/>
-    <p:sldId id="307" r:id="rId58"/>
-    <p:sldId id="308" r:id="rId59"/>
   </p:sldIdLst>
   <p:sldSz cx="12191695" cy="6858000" type="screen4x3"/>
   <p:notesSz cx="6858000" cy="9144000"/>
@@ -12461,7 +12459,7 @@
                   <a:srgbClr val="01AEFD"/>
                 </a:solidFill>
               </a:rPr>
-              <a:t>In script.js   -   replace a line</a:t>
+              <a:t>In script.js   -   replace 3 lines</a:t>
             </a:r>
           </a:p>
         </p:txBody>
@@ -12537,6 +12535,56 @@
               <a:t>// In PixelPad your loop() checked 'was a key pressed?' every frame. Here you</a:t>
             </a:r>
           </a:p>
+          <a:p>
+            <a:pPr>
+              <a:spcAft>
+                <a:spcPts val="0"/>
+              </a:spcAft>
+            </a:pPr>
+            <a:r>
+              <a:rPr sz="1800">
+                <a:solidFill>
+                  <a:srgbClr val="6D8C97"/>
+                </a:solidFill>
+                <a:latin typeface="Consolas"/>
+              </a:rPr>
+              <a:t>  61  </a:t>
+            </a:r>
+            <a:r>
+              <a:rPr sz="1800" strike="sngStrike">
+                <a:solidFill>
+                  <a:srgbClr val="F3928B"/>
+                </a:solidFill>
+                <a:latin typeface="Consolas"/>
+              </a:rPr>
+              <a:t>// leave a note: when this form is submitted, run this. The browser waits.</a:t>
+            </a:r>
+          </a:p>
+          <a:p>
+            <a:pPr>
+              <a:spcAft>
+                <a:spcPts val="0"/>
+              </a:spcAft>
+            </a:pPr>
+            <a:r>
+              <a:rPr sz="1800">
+                <a:solidFill>
+                  <a:srgbClr val="6D8C97"/>
+                </a:solidFill>
+                <a:latin typeface="Consolas"/>
+              </a:rPr>
+              <a:t>  62  </a:t>
+            </a:r>
+            <a:r>
+              <a:rPr sz="1800" strike="sngStrike">
+                <a:solidFill>
+                  <a:srgbClr val="F3928B"/>
+                </a:solidFill>
+                <a:latin typeface="Consolas"/>
+              </a:rPr>
+              <a:t>composer.addEventListener('submit', function (event) {</a:t>
+            </a:r>
+          </a:p>
         </p:txBody>
       </p:sp>
       <p:sp>
@@ -12567,7 +12615,7 @@
                   <a:srgbClr val="DCECEF"/>
                 </a:solidFill>
               </a:rPr>
-              <a:t>This line changes - take the old one out; the new version is next.</a:t>
+              <a:t>These lines change - take the old ones out; the new version is next.</a:t>
             </a:r>
           </a:p>
         </p:txBody>
@@ -12626,7 +12674,7 @@
                   <a:srgbClr val="01AEFD"/>
                 </a:solidFill>
               </a:rPr>
-              <a:t>In script.js   -   replace a line</a:t>
+              <a:t>Type this into script.js   -   line 60</a:t>
             </a:r>
           </a:p>
         </p:txBody>
@@ -12693,13 +12741,13 @@
               <a:t>  60  </a:t>
             </a:r>
             <a:r>
-              <a:rPr sz="1800" strike="sngStrike">
-                <a:solidFill>
-                  <a:srgbClr val="F3928B"/>
-                </a:solidFill>
-                <a:latin typeface="Consolas"/>
-              </a:rPr>
-              <a:t>// leave a note: when this form is submitted, run this. The browser waits.</a:t>
+              <a:rPr sz="1800">
+                <a:solidFill>
+                  <a:srgbClr val="7FE0A0"/>
+                </a:solidFill>
+                <a:latin typeface="Consolas"/>
+              </a:rPr>
+              <a:t>// The browser calls this when the form is submitted.</a:t>
             </a:r>
           </a:p>
         </p:txBody>
@@ -12732,7 +12780,7 @@
                   <a:srgbClr val="DCECEF"/>
                 </a:solidFill>
               </a:rPr>
-              <a:t>This line changes - take the old one out; the new version is next.</a:t>
+              <a:t>A comment: the browser calls this when the form is submitted.</a:t>
             </a:r>
           </a:p>
         </p:txBody>
@@ -12918,7 +12966,7 @@
                   <a:srgbClr val="01AEFD"/>
                 </a:solidFill>
               </a:rPr>
-              <a:t>In script.js   -   replace a line</a:t>
+              <a:t>Type this into script.js   -   line 61</a:t>
             </a:r>
           </a:p>
         </p:txBody>
@@ -12985,13 +13033,38 @@
               <a:t>  60  </a:t>
             </a:r>
             <a:r>
-              <a:rPr sz="1800" strike="sngStrike">
-                <a:solidFill>
-                  <a:srgbClr val="F3928B"/>
-                </a:solidFill>
-                <a:latin typeface="Consolas"/>
-              </a:rPr>
-              <a:t>composer.addEventListener('submit', function (event) {</a:t>
+              <a:rPr sz="1800">
+                <a:solidFill>
+                  <a:srgbClr val="6D8C97"/>
+                </a:solidFill>
+                <a:latin typeface="Consolas"/>
+              </a:rPr>
+              <a:t>// The browser calls this when the form is submitted.</a:t>
+            </a:r>
+          </a:p>
+          <a:p>
+            <a:pPr>
+              <a:spcAft>
+                <a:spcPts val="0"/>
+              </a:spcAft>
+            </a:pPr>
+            <a:r>
+              <a:rPr sz="1800">
+                <a:solidFill>
+                  <a:srgbClr val="6D8C97"/>
+                </a:solidFill>
+                <a:latin typeface="Consolas"/>
+              </a:rPr>
+              <a:t>  61  </a:t>
+            </a:r>
+            <a:r>
+              <a:rPr sz="1800">
+                <a:solidFill>
+                  <a:srgbClr val="7FE0A0"/>
+                </a:solidFill>
+                <a:latin typeface="Consolas"/>
+              </a:rPr>
+              <a:t>composer.addEventListener('submit', async function (event) {</a:t>
             </a:r>
           </a:p>
         </p:txBody>
@@ -13024,7 +13097,7 @@
                   <a:srgbClr val="DCECEF"/>
                 </a:solidFill>
               </a:rPr>
-              <a:t>This line changes - take the old one out; the new version is next.</a:t>
+              <a:t>Add async so we are allowed to await the slow AI call inside.</a:t>
             </a:r>
           </a:p>
         </p:txBody>
@@ -13083,7 +13156,7 @@
                   <a:srgbClr val="01AEFD"/>
                 </a:solidFill>
               </a:rPr>
-              <a:t>Type this into script.js   -   line 60</a:t>
+              <a:t>In script.js   -   replace a line</a:t>
             </a:r>
           </a:p>
         </p:txBody>
@@ -13152,11 +13225,186 @@
             <a:r>
               <a:rPr sz="1800">
                 <a:solidFill>
-                  <a:srgbClr val="7FE0A0"/>
+                  <a:srgbClr val="6D8C97"/>
                 </a:solidFill>
                 <a:latin typeface="Consolas"/>
               </a:rPr>
               <a:t>// The browser calls this when the form is submitted.</a:t>
+            </a:r>
+          </a:p>
+          <a:p>
+            <a:pPr>
+              <a:spcAft>
+                <a:spcPts val="0"/>
+              </a:spcAft>
+            </a:pPr>
+            <a:r>
+              <a:rPr sz="1800">
+                <a:solidFill>
+                  <a:srgbClr val="6D8C97"/>
+                </a:solidFill>
+                <a:latin typeface="Consolas"/>
+              </a:rPr>
+              <a:t>  61  </a:t>
+            </a:r>
+            <a:r>
+              <a:rPr sz="1800">
+                <a:solidFill>
+                  <a:srgbClr val="6D8C97"/>
+                </a:solidFill>
+                <a:latin typeface="Consolas"/>
+              </a:rPr>
+              <a:t>composer.addEventListener('submit', async function (event) {</a:t>
+            </a:r>
+          </a:p>
+          <a:p>
+            <a:pPr>
+              <a:spcAft>
+                <a:spcPts val="0"/>
+              </a:spcAft>
+            </a:pPr>
+            <a:r>
+              <a:rPr sz="1800">
+                <a:solidFill>
+                  <a:srgbClr val="6D8C97"/>
+                </a:solidFill>
+                <a:latin typeface="Consolas"/>
+              </a:rPr>
+              <a:t>  62  </a:t>
+            </a:r>
+            <a:r>
+              <a:rPr sz="1800">
+                <a:solidFill>
+                  <a:srgbClr val="6D8C97"/>
+                </a:solidFill>
+                <a:latin typeface="Consolas"/>
+              </a:rPr>
+              <a:t>  event.preventDefault();</a:t>
+            </a:r>
+          </a:p>
+          <a:p>
+            <a:pPr>
+              <a:spcAft>
+                <a:spcPts val="0"/>
+              </a:spcAft>
+            </a:pPr>
+            <a:r>
+              <a:rPr sz="1800">
+                <a:solidFill>
+                  <a:srgbClr val="6D8C97"/>
+                </a:solidFill>
+                <a:latin typeface="Consolas"/>
+              </a:rPr>
+              <a:t>  63  </a:t>
+            </a:r>
+            <a:r>
+              <a:rPr sz="1800">
+                <a:solidFill>
+                  <a:srgbClr val="6D8C97"/>
+                </a:solidFill>
+                <a:latin typeface="Consolas"/>
+              </a:rPr>
+              <a:t>  const text = promptBox.value.trim();</a:t>
+            </a:r>
+          </a:p>
+          <a:p>
+            <a:pPr>
+              <a:spcAft>
+                <a:spcPts val="0"/>
+              </a:spcAft>
+            </a:pPr>
+            <a:r>
+              <a:rPr sz="1800">
+                <a:solidFill>
+                  <a:srgbClr val="6D8C97"/>
+                </a:solidFill>
+                <a:latin typeface="Consolas"/>
+              </a:rPr>
+              <a:t>  64  </a:t>
+            </a:r>
+            <a:r>
+              <a:rPr sz="1800">
+                <a:solidFill>
+                  <a:srgbClr val="6D8C97"/>
+                </a:solidFill>
+                <a:latin typeface="Consolas"/>
+              </a:rPr>
+              <a:t>  if (text === '') { return; }</a:t>
+            </a:r>
+          </a:p>
+          <a:p>
+            <a:pPr>
+              <a:spcAft>
+                <a:spcPts val="0"/>
+              </a:spcAft>
+            </a:pPr>
+            <a:r>
+              <a:rPr sz="1800">
+                <a:solidFill>
+                  <a:srgbClr val="6D8C97"/>
+                </a:solidFill>
+                <a:latin typeface="Consolas"/>
+              </a:rPr>
+              <a:t>  65  </a:t>
+            </a:r>
+            <a:r>
+              <a:rPr sz="1800">
+                <a:solidFill>
+                  <a:srgbClr val="6D8C97"/>
+                </a:solidFill>
+                <a:latin typeface="Consolas"/>
+              </a:rPr>
+              <a:t>  promptBox.value = '';</a:t>
+            </a:r>
+          </a:p>
+          <a:p>
+            <a:pPr>
+              <a:spcAft>
+                <a:spcPts val="0"/>
+              </a:spcAft>
+            </a:pPr>
+            <a:r>
+              <a:rPr sz="1800">
+                <a:solidFill>
+                  <a:srgbClr val="6D8C97"/>
+                </a:solidFill>
+                <a:latin typeface="Consolas"/>
+              </a:rPr>
+              <a:t>  66  </a:t>
+            </a:r>
+            <a:r>
+              <a:rPr sz="1800">
+                <a:solidFill>
+                  <a:srgbClr val="6D8C97"/>
+                </a:solidFill>
+                <a:latin typeface="Consolas"/>
+              </a:rPr>
+              <a:t>  addLine('You', text);</a:t>
+            </a:r>
+          </a:p>
+          <a:p>
+            <a:pPr>
+              <a:spcAft>
+                <a:spcPts val="0"/>
+              </a:spcAft>
+            </a:pPr>
+            <a:r>
+              <a:rPr sz="1800">
+                <a:solidFill>
+                  <a:srgbClr val="6D8C97"/>
+                </a:solidFill>
+                <a:latin typeface="Consolas"/>
+              </a:rPr>
+              <a:t>  67  </a:t>
+            </a:r>
+            <a:r>
+              <a:rPr sz="1800" strike="sngStrike">
+                <a:solidFill>
+                  <a:srgbClr val="F3928B"/>
+                </a:solidFill>
+                <a:latin typeface="Consolas"/>
+              </a:rPr>
+              <a:t>  addLine('Companion', 'You said: ' + text);   // a pretend answer, for now</a:t>
             </a:r>
           </a:p>
         </p:txBody>
@@ -13189,7 +13437,7 @@
                   <a:srgbClr val="DCECEF"/>
                 </a:solidFill>
               </a:rPr>
-              <a:t>A comment: the browser calls this when the form is submitted.</a:t>
+              <a:t>This line changes - take the old one out; the new version is next.</a:t>
             </a:r>
           </a:p>
         </p:txBody>
@@ -13248,7 +13496,7 @@
                   <a:srgbClr val="01AEFD"/>
                 </a:solidFill>
               </a:rPr>
-              <a:t>Type this into script.js   -   line 61</a:t>
+              <a:t>Type this into script.js   -   line 67</a:t>
             </a:r>
           </a:p>
         </p:txBody>
@@ -13342,11 +13590,161 @@
             <a:r>
               <a:rPr sz="1800">
                 <a:solidFill>
+                  <a:srgbClr val="6D8C97"/>
+                </a:solidFill>
+                <a:latin typeface="Consolas"/>
+              </a:rPr>
+              <a:t>composer.addEventListener('submit', async function (event) {</a:t>
+            </a:r>
+          </a:p>
+          <a:p>
+            <a:pPr>
+              <a:spcAft>
+                <a:spcPts val="0"/>
+              </a:spcAft>
+            </a:pPr>
+            <a:r>
+              <a:rPr sz="1800">
+                <a:solidFill>
+                  <a:srgbClr val="6D8C97"/>
+                </a:solidFill>
+                <a:latin typeface="Consolas"/>
+              </a:rPr>
+              <a:t>  62  </a:t>
+            </a:r>
+            <a:r>
+              <a:rPr sz="1800">
+                <a:solidFill>
+                  <a:srgbClr val="6D8C97"/>
+                </a:solidFill>
+                <a:latin typeface="Consolas"/>
+              </a:rPr>
+              <a:t>  event.preventDefault();</a:t>
+            </a:r>
+          </a:p>
+          <a:p>
+            <a:pPr>
+              <a:spcAft>
+                <a:spcPts val="0"/>
+              </a:spcAft>
+            </a:pPr>
+            <a:r>
+              <a:rPr sz="1800">
+                <a:solidFill>
+                  <a:srgbClr val="6D8C97"/>
+                </a:solidFill>
+                <a:latin typeface="Consolas"/>
+              </a:rPr>
+              <a:t>  63  </a:t>
+            </a:r>
+            <a:r>
+              <a:rPr sz="1800">
+                <a:solidFill>
+                  <a:srgbClr val="6D8C97"/>
+                </a:solidFill>
+                <a:latin typeface="Consolas"/>
+              </a:rPr>
+              <a:t>  const text = promptBox.value.trim();</a:t>
+            </a:r>
+          </a:p>
+          <a:p>
+            <a:pPr>
+              <a:spcAft>
+                <a:spcPts val="0"/>
+              </a:spcAft>
+            </a:pPr>
+            <a:r>
+              <a:rPr sz="1800">
+                <a:solidFill>
+                  <a:srgbClr val="6D8C97"/>
+                </a:solidFill>
+                <a:latin typeface="Consolas"/>
+              </a:rPr>
+              <a:t>  64  </a:t>
+            </a:r>
+            <a:r>
+              <a:rPr sz="1800">
+                <a:solidFill>
+                  <a:srgbClr val="6D8C97"/>
+                </a:solidFill>
+                <a:latin typeface="Consolas"/>
+              </a:rPr>
+              <a:t>  if (text === '') { return; }</a:t>
+            </a:r>
+          </a:p>
+          <a:p>
+            <a:pPr>
+              <a:spcAft>
+                <a:spcPts val="0"/>
+              </a:spcAft>
+            </a:pPr>
+            <a:r>
+              <a:rPr sz="1800">
+                <a:solidFill>
+                  <a:srgbClr val="6D8C97"/>
+                </a:solidFill>
+                <a:latin typeface="Consolas"/>
+              </a:rPr>
+              <a:t>  65  </a:t>
+            </a:r>
+            <a:r>
+              <a:rPr sz="1800">
+                <a:solidFill>
+                  <a:srgbClr val="6D8C97"/>
+                </a:solidFill>
+                <a:latin typeface="Consolas"/>
+              </a:rPr>
+              <a:t>  promptBox.value = '';</a:t>
+            </a:r>
+          </a:p>
+          <a:p>
+            <a:pPr>
+              <a:spcAft>
+                <a:spcPts val="0"/>
+              </a:spcAft>
+            </a:pPr>
+            <a:r>
+              <a:rPr sz="1800">
+                <a:solidFill>
+                  <a:srgbClr val="6D8C97"/>
+                </a:solidFill>
+                <a:latin typeface="Consolas"/>
+              </a:rPr>
+              <a:t>  66  </a:t>
+            </a:r>
+            <a:r>
+              <a:rPr sz="1800">
+                <a:solidFill>
+                  <a:srgbClr val="6D8C97"/>
+                </a:solidFill>
+                <a:latin typeface="Consolas"/>
+              </a:rPr>
+              <a:t>  addLine('You', text);</a:t>
+            </a:r>
+          </a:p>
+          <a:p>
+            <a:pPr>
+              <a:spcAft>
+                <a:spcPts val="0"/>
+              </a:spcAft>
+            </a:pPr>
+            <a:r>
+              <a:rPr sz="1800">
+                <a:solidFill>
+                  <a:srgbClr val="6D8C97"/>
+                </a:solidFill>
+                <a:latin typeface="Consolas"/>
+              </a:rPr>
+              <a:t>  67  </a:t>
+            </a:r>
+            <a:r>
+              <a:rPr sz="1800">
+                <a:solidFill>
                   <a:srgbClr val="7FE0A0"/>
                 </a:solidFill>
                 <a:latin typeface="Consolas"/>
               </a:rPr>
-              <a:t>composer.addEventListener('submit', async function (event) {</a:t>
+              <a:t>  addLine('Companion', 'thinking...');</a:t>
             </a:r>
           </a:p>
         </p:txBody>
@@ -13379,7 +13777,7 @@
                   <a:srgbClr val="DCECEF"/>
                 </a:solidFill>
               </a:rPr>
-              <a:t>Add async so we are allowed to await the slow AI call inside.</a:t>
+              <a:t>Change the pretend reply to a 'thinking...' line while we wait.</a:t>
             </a:r>
           </a:p>
         </p:txBody>
@@ -13438,7 +13836,7 @@
                   <a:srgbClr val="01AEFD"/>
                 </a:solidFill>
               </a:rPr>
-              <a:t>In script.js   -   replace a line</a:t>
+              <a:t>Type this into script.js   -   line 68</a:t>
             </a:r>
           </a:p>
         </p:txBody>
@@ -13680,13 +14078,38 @@
               <a:t>  67  </a:t>
             </a:r>
             <a:r>
-              <a:rPr sz="1800" strike="sngStrike">
-                <a:solidFill>
-                  <a:srgbClr val="F3928B"/>
-                </a:solidFill>
-                <a:latin typeface="Consolas"/>
-              </a:rPr>
-              <a:t>  addLine('Companion', 'You said: ' + text);   // a pretend answer, for now</a:t>
+              <a:rPr sz="1800">
+                <a:solidFill>
+                  <a:srgbClr val="6D8C97"/>
+                </a:solidFill>
+                <a:latin typeface="Consolas"/>
+              </a:rPr>
+              <a:t>  addLine('Companion', 'thinking...');</a:t>
+            </a:r>
+          </a:p>
+          <a:p>
+            <a:pPr>
+              <a:spcAft>
+                <a:spcPts val="0"/>
+              </a:spcAft>
+            </a:pPr>
+            <a:r>
+              <a:rPr sz="1800">
+                <a:solidFill>
+                  <a:srgbClr val="6D8C97"/>
+                </a:solidFill>
+                <a:latin typeface="Consolas"/>
+              </a:rPr>
+              <a:t>  68  </a:t>
+            </a:r>
+            <a:r>
+              <a:rPr sz="1800">
+                <a:solidFill>
+                  <a:srgbClr val="7FE0A0"/>
+                </a:solidFill>
+                <a:latin typeface="Consolas"/>
+              </a:rPr>
+              <a:t>  const reply = await askAI(text);       // this is the slow bit</a:t>
             </a:r>
           </a:p>
         </p:txBody>
@@ -13719,7 +14142,7 @@
                   <a:srgbClr val="DCECEF"/>
                 </a:solidFill>
               </a:rPr>
-              <a:t>This line changes - take the old one out; the new version is next.</a:t>
+              <a:t>await askAI(text): the slow bit - ask the AI and wait for the answer.</a:t>
             </a:r>
           </a:p>
         </p:txBody>
@@ -13733,6 +14156,266 @@
 </file>
 
 <file path=ppt/slides/slide44.xml><?xml version="1.0" encoding="utf-8"?>
+<p:sld xmlns:a="http://schemas.openxmlformats.org/drawingml/2006/main" xmlns:p="http://schemas.openxmlformats.org/presentationml/2006/main" xmlns:r="http://schemas.openxmlformats.org/officeDocument/2006/relationships">
+  <p:cSld>
+    <p:spTree>
+      <p:nvGrpSpPr>
+        <p:cNvPr id="1" name=""/>
+        <p:cNvGrpSpPr/>
+        <p:nvPr/>
+      </p:nvGrpSpPr>
+      <p:grpSpPr/>
+      <p:sp>
+        <p:nvSpPr>
+          <p:cNvPr id="2" name="Title 1"/>
+          <p:cNvSpPr>
+            <a:spLocks noGrp="1"/>
+          </p:cNvSpPr>
+          <p:nvPr>
+            <p:ph type="title"/>
+          </p:nvPr>
+        </p:nvSpPr>
+        <p:spPr/>
+        <p:txBody>
+          <a:bodyPr/>
+          <a:lstStyle/>
+          <a:p>
+            <a:r>
+              <a:rPr sz="3800" b="1">
+                <a:solidFill>
+                  <a:srgbClr val="1F2A37"/>
+                </a:solidFill>
+              </a:rPr>
+              <a:t>.lastChild</a:t>
+            </a:r>
+          </a:p>
+        </p:txBody>
+      </p:sp>
+      <p:sp>
+        <p:nvSpPr>
+          <p:cNvPr id="3" name="TextBox 2"/>
+          <p:cNvSpPr txBox="1"/>
+          <p:nvPr/>
+        </p:nvSpPr>
+        <p:spPr>
+          <a:xfrm>
+            <a:off x="868680" y="502920"/>
+            <a:ext cx="5486400" cy="457200"/>
+          </a:xfrm>
+          <a:prstGeom prst="rect">
+            <a:avLst/>
+          </a:prstGeom>
+          <a:noFill/>
+        </p:spPr>
+        <p:txBody>
+          <a:bodyPr wrap="none">
+            <a:spAutoFit/>
+          </a:bodyPr>
+          <a:lstStyle/>
+          <a:p>
+            <a:r>
+              <a:rPr sz="1500" b="1">
+                <a:solidFill>
+                  <a:srgbClr val="01AEFD"/>
+                </a:solidFill>
+              </a:rPr>
+              <a:t>JAVASCRIPT</a:t>
+            </a:r>
+          </a:p>
+        </p:txBody>
+      </p:sp>
+      <p:sp>
+        <p:nvSpPr>
+          <p:cNvPr id="4" name="TextBox 3"/>
+          <p:cNvSpPr txBox="1"/>
+          <p:nvPr/>
+        </p:nvSpPr>
+        <p:spPr>
+          <a:xfrm>
+            <a:off x="822960" y="1828800"/>
+            <a:ext cx="10515600" cy="4206240"/>
+          </a:xfrm>
+          <a:prstGeom prst="rect">
+            <a:avLst/>
+          </a:prstGeom>
+          <a:noFill/>
+        </p:spPr>
+        <p:txBody>
+          <a:bodyPr wrap="square">
+            <a:spAutoFit/>
+          </a:bodyPr>
+          <a:lstStyle/>
+          <a:p>
+            <a:pPr>
+              <a:spcAft>
+                <a:spcPts val="1400"/>
+              </a:spcAft>
+            </a:pPr>
+            <a:r>
+              <a:rPr sz="2400">
+                <a:solidFill>
+                  <a:srgbClr val="1F2A37"/>
+                </a:solidFill>
+              </a:rPr>
+              <a:t>• A box's LAST child - the newest thing added inside it.</a:t>
+            </a:r>
+          </a:p>
+          <a:p>
+            <a:pPr>
+              <a:spcAft>
+                <a:spcPts val="1400"/>
+              </a:spcAft>
+            </a:pPr>
+            <a:r>
+              <a:rPr sz="2400">
+                <a:solidFill>
+                  <a:srgbClr val="1F2A37"/>
+                </a:solidFill>
+              </a:rPr>
+              <a:t>• chat.lastChild is the message you just put in.</a:t>
+            </a:r>
+          </a:p>
+        </p:txBody>
+      </p:sp>
+    </p:spTree>
+  </p:cSld>
+  <p:clrMapOvr>
+    <a:masterClrMapping/>
+  </p:clrMapOvr>
+</p:sld>
+</file>
+
+<file path=ppt/slides/slide45.xml><?xml version="1.0" encoding="utf-8"?>
+<p:sld xmlns:a="http://schemas.openxmlformats.org/drawingml/2006/main" xmlns:p="http://schemas.openxmlformats.org/presentationml/2006/main" xmlns:r="http://schemas.openxmlformats.org/officeDocument/2006/relationships">
+  <p:cSld>
+    <p:spTree>
+      <p:nvGrpSpPr>
+        <p:cNvPr id="1" name=""/>
+        <p:cNvGrpSpPr/>
+        <p:nvPr/>
+      </p:nvGrpSpPr>
+      <p:grpSpPr/>
+      <p:sp>
+        <p:nvSpPr>
+          <p:cNvPr id="2" name="Title 1"/>
+          <p:cNvSpPr>
+            <a:spLocks noGrp="1"/>
+          </p:cNvSpPr>
+          <p:nvPr>
+            <p:ph type="title"/>
+          </p:nvPr>
+        </p:nvSpPr>
+        <p:spPr/>
+        <p:txBody>
+          <a:bodyPr/>
+          <a:lstStyle/>
+          <a:p>
+            <a:r>
+              <a:rPr sz="3800" b="1">
+                <a:solidFill>
+                  <a:srgbClr val="1F2A37"/>
+                </a:solidFill>
+              </a:rPr>
+              <a:t>.remove()</a:t>
+            </a:r>
+          </a:p>
+        </p:txBody>
+      </p:sp>
+      <p:sp>
+        <p:nvSpPr>
+          <p:cNvPr id="3" name="TextBox 2"/>
+          <p:cNvSpPr txBox="1"/>
+          <p:nvPr/>
+        </p:nvSpPr>
+        <p:spPr>
+          <a:xfrm>
+            <a:off x="868680" y="502920"/>
+            <a:ext cx="5486400" cy="457200"/>
+          </a:xfrm>
+          <a:prstGeom prst="rect">
+            <a:avLst/>
+          </a:prstGeom>
+          <a:noFill/>
+        </p:spPr>
+        <p:txBody>
+          <a:bodyPr wrap="none">
+            <a:spAutoFit/>
+          </a:bodyPr>
+          <a:lstStyle/>
+          <a:p>
+            <a:r>
+              <a:rPr sz="1500" b="1">
+                <a:solidFill>
+                  <a:srgbClr val="01AEFD"/>
+                </a:solidFill>
+              </a:rPr>
+              <a:t>JAVASCRIPT</a:t>
+            </a:r>
+          </a:p>
+        </p:txBody>
+      </p:sp>
+      <p:sp>
+        <p:nvSpPr>
+          <p:cNvPr id="4" name="TextBox 3"/>
+          <p:cNvSpPr txBox="1"/>
+          <p:nvPr/>
+        </p:nvSpPr>
+        <p:spPr>
+          <a:xfrm>
+            <a:off x="822960" y="1828800"/>
+            <a:ext cx="10515600" cy="4206240"/>
+          </a:xfrm>
+          <a:prstGeom prst="rect">
+            <a:avLst/>
+          </a:prstGeom>
+          <a:noFill/>
+        </p:spPr>
+        <p:txBody>
+          <a:bodyPr wrap="square">
+            <a:spAutoFit/>
+          </a:bodyPr>
+          <a:lstStyle/>
+          <a:p>
+            <a:pPr>
+              <a:spcAft>
+                <a:spcPts val="1400"/>
+              </a:spcAft>
+            </a:pPr>
+            <a:r>
+              <a:rPr sz="2400">
+                <a:solidFill>
+                  <a:srgbClr val="1F2A37"/>
+                </a:solidFill>
+              </a:rPr>
+              <a:t>• Deletes an element from the page.</a:t>
+            </a:r>
+          </a:p>
+          <a:p>
+            <a:pPr>
+              <a:spcAft>
+                <a:spcPts val="1400"/>
+              </a:spcAft>
+            </a:pPr>
+            <a:r>
+              <a:rPr sz="2400">
+                <a:solidFill>
+                  <a:srgbClr val="1F2A37"/>
+                </a:solidFill>
+              </a:rPr>
+              <a:t>• chat.lastChild.remove() takes the last message back off.</a:t>
+            </a:r>
+          </a:p>
+        </p:txBody>
+      </p:sp>
+    </p:spTree>
+  </p:cSld>
+  <p:clrMapOvr>
+    <a:masterClrMapping/>
+  </p:clrMapOvr>
+</p:sld>
+</file>
+
+<file path=ppt/slides/slide46.xml><?xml version="1.0" encoding="utf-8"?>
 <p:sld xmlns:a="http://schemas.openxmlformats.org/drawingml/2006/main" xmlns:p="http://schemas.openxmlformats.org/presentationml/2006/main" xmlns:r="http://schemas.openxmlformats.org/officeDocument/2006/relationships">
   <p:cSld>
     <p:bg>
@@ -13778,7 +14461,7 @@
                   <a:srgbClr val="01AEFD"/>
                 </a:solidFill>
               </a:rPr>
-              <a:t>Type this into script.js   -   line 67</a:t>
+              <a:t>Type this into script.js   -   line 69</a:t>
             </a:r>
           </a:p>
         </p:txBody>
@@ -13811,7 +14494,7 @@
               </a:spcAft>
             </a:pPr>
             <a:r>
-              <a:rPr sz="1800">
+              <a:rPr sz="1300">
                 <a:solidFill>
                   <a:srgbClr val="6D8C97"/>
                 </a:solidFill>
@@ -13820,7 +14503,7 @@
               <a:t>  59  </a:t>
             </a:r>
             <a:r>
-              <a:rPr sz="1800">
+              <a:rPr sz="1300">
                 <a:solidFill>
                   <a:srgbClr val="6D8C97"/>
                 </a:solidFill>
@@ -13836,7 +14519,7 @@
               </a:spcAft>
             </a:pPr>
             <a:r>
-              <a:rPr sz="1800">
+              <a:rPr sz="1300">
                 <a:solidFill>
                   <a:srgbClr val="6D8C97"/>
                 </a:solidFill>
@@ -13845,7 +14528,7 @@
               <a:t>  60  </a:t>
             </a:r>
             <a:r>
-              <a:rPr sz="1800">
+              <a:rPr sz="1300">
                 <a:solidFill>
                   <a:srgbClr val="6D8C97"/>
                 </a:solidFill>
@@ -13861,7 +14544,7 @@
               </a:spcAft>
             </a:pPr>
             <a:r>
-              <a:rPr sz="1800">
+              <a:rPr sz="1300">
                 <a:solidFill>
                   <a:srgbClr val="6D8C97"/>
                 </a:solidFill>
@@ -13870,7 +14553,7 @@
               <a:t>  61  </a:t>
             </a:r>
             <a:r>
-              <a:rPr sz="1800">
+              <a:rPr sz="1300">
                 <a:solidFill>
                   <a:srgbClr val="6D8C97"/>
                 </a:solidFill>
@@ -13886,7 +14569,7 @@
               </a:spcAft>
             </a:pPr>
             <a:r>
-              <a:rPr sz="1800">
+              <a:rPr sz="1300">
                 <a:solidFill>
                   <a:srgbClr val="6D8C97"/>
                 </a:solidFill>
@@ -13895,7 +14578,7 @@
               <a:t>  62  </a:t>
             </a:r>
             <a:r>
-              <a:rPr sz="1800">
+              <a:rPr sz="1300">
                 <a:solidFill>
                   <a:srgbClr val="6D8C97"/>
                 </a:solidFill>
@@ -13911,7 +14594,7 @@
               </a:spcAft>
             </a:pPr>
             <a:r>
-              <a:rPr sz="1800">
+              <a:rPr sz="1300">
                 <a:solidFill>
                   <a:srgbClr val="6D8C97"/>
                 </a:solidFill>
@@ -13920,7 +14603,7 @@
               <a:t>  63  </a:t>
             </a:r>
             <a:r>
-              <a:rPr sz="1800">
+              <a:rPr sz="1300">
                 <a:solidFill>
                   <a:srgbClr val="6D8C97"/>
                 </a:solidFill>
@@ -13936,7 +14619,7 @@
               </a:spcAft>
             </a:pPr>
             <a:r>
-              <a:rPr sz="1800">
+              <a:rPr sz="1300">
                 <a:solidFill>
                   <a:srgbClr val="6D8C97"/>
                 </a:solidFill>
@@ -13945,7 +14628,7 @@
               <a:t>  64  </a:t>
             </a:r>
             <a:r>
-              <a:rPr sz="1800">
+              <a:rPr sz="1300">
                 <a:solidFill>
                   <a:srgbClr val="6D8C97"/>
                 </a:solidFill>
@@ -13961,7 +14644,7 @@
               </a:spcAft>
             </a:pPr>
             <a:r>
-              <a:rPr sz="1800">
+              <a:rPr sz="1300">
                 <a:solidFill>
                   <a:srgbClr val="6D8C97"/>
                 </a:solidFill>
@@ -13970,7 +14653,7 @@
               <a:t>  65  </a:t>
             </a:r>
             <a:r>
-              <a:rPr sz="1800">
+              <a:rPr sz="1300">
                 <a:solidFill>
                   <a:srgbClr val="6D8C97"/>
                 </a:solidFill>
@@ -13986,7 +14669,7 @@
               </a:spcAft>
             </a:pPr>
             <a:r>
-              <a:rPr sz="1800">
+              <a:rPr sz="1300">
                 <a:solidFill>
                   <a:srgbClr val="6D8C97"/>
                 </a:solidFill>
@@ -13995,7 +14678,7 @@
               <a:t>  66  </a:t>
             </a:r>
             <a:r>
-              <a:rPr sz="1800">
+              <a:rPr sz="1300">
                 <a:solidFill>
                   <a:srgbClr val="6D8C97"/>
                 </a:solidFill>
@@ -14011,7 +14694,7 @@
               </a:spcAft>
             </a:pPr>
             <a:r>
-              <a:rPr sz="1800">
+              <a:rPr sz="1300">
                 <a:solidFill>
                   <a:srgbClr val="6D8C97"/>
                 </a:solidFill>
@@ -14020,13 +14703,63 @@
               <a:t>  67  </a:t>
             </a:r>
             <a:r>
-              <a:rPr sz="1800">
+              <a:rPr sz="1300">
+                <a:solidFill>
+                  <a:srgbClr val="6D8C97"/>
+                </a:solidFill>
+                <a:latin typeface="Consolas"/>
+              </a:rPr>
+              <a:t>  addLine('Companion', 'thinking...');</a:t>
+            </a:r>
+          </a:p>
+          <a:p>
+            <a:pPr>
+              <a:spcAft>
+                <a:spcPts val="0"/>
+              </a:spcAft>
+            </a:pPr>
+            <a:r>
+              <a:rPr sz="1300">
+                <a:solidFill>
+                  <a:srgbClr val="6D8C97"/>
+                </a:solidFill>
+                <a:latin typeface="Consolas"/>
+              </a:rPr>
+              <a:t>  68  </a:t>
+            </a:r>
+            <a:r>
+              <a:rPr sz="1300">
+                <a:solidFill>
+                  <a:srgbClr val="6D8C97"/>
+                </a:solidFill>
+                <a:latin typeface="Consolas"/>
+              </a:rPr>
+              <a:t>  const reply = await askAI(text);       // this is the slow bit</a:t>
+            </a:r>
+          </a:p>
+          <a:p>
+            <a:pPr>
+              <a:spcAft>
+                <a:spcPts val="0"/>
+              </a:spcAft>
+            </a:pPr>
+            <a:r>
+              <a:rPr sz="1300">
+                <a:solidFill>
+                  <a:srgbClr val="6D8C97"/>
+                </a:solidFill>
+                <a:latin typeface="Consolas"/>
+              </a:rPr>
+              <a:t>  69  </a:t>
+            </a:r>
+            <a:r>
+              <a:rPr sz="1300">
                 <a:solidFill>
                   <a:srgbClr val="7FE0A0"/>
                 </a:solidFill>
                 <a:latin typeface="Consolas"/>
               </a:rPr>
-              <a:t>  addLine('Companion', 'thinking...');</a:t>
+              <a:t>  chat.lastChild.remove();               // take the 'thinking' line away</a:t>
             </a:r>
           </a:p>
         </p:txBody>
@@ -14059,7 +14792,7 @@
                   <a:srgbClr val="DCECEF"/>
                 </a:solidFill>
               </a:rPr>
-              <a:t>Change the pretend reply to a 'thinking...' line while we wait.</a:t>
+              <a:t>Remove the 'thinking...' line now the real answer is here.</a:t>
             </a:r>
           </a:p>
         </p:txBody>
@@ -14072,7 +14805,7 @@
 </p:sld>
 </file>
 
-<file path=ppt/slides/slide45.xml><?xml version="1.0" encoding="utf-8"?>
+<file path=ppt/slides/slide47.xml><?xml version="1.0" encoding="utf-8"?>
 <p:sld xmlns:a="http://schemas.openxmlformats.org/drawingml/2006/main" xmlns:p="http://schemas.openxmlformats.org/presentationml/2006/main" xmlns:r="http://schemas.openxmlformats.org/officeDocument/2006/relationships">
   <p:cSld>
     <p:bg>
@@ -14118,7 +14851,7 @@
                   <a:srgbClr val="01AEFD"/>
                 </a:solidFill>
               </a:rPr>
-              <a:t>Type this into script.js   -   line 68</a:t>
+              <a:t>Type this into script.js   -   line 70</a:t>
             </a:r>
           </a:p>
         </p:txBody>
@@ -14151,7 +14884,7 @@
               </a:spcAft>
             </a:pPr>
             <a:r>
-              <a:rPr sz="1800">
+              <a:rPr sz="1300">
                 <a:solidFill>
                   <a:srgbClr val="6D8C97"/>
                 </a:solidFill>
@@ -14160,7 +14893,7 @@
               <a:t>  59  </a:t>
             </a:r>
             <a:r>
-              <a:rPr sz="1800">
+              <a:rPr sz="1300">
                 <a:solidFill>
                   <a:srgbClr val="6D8C97"/>
                 </a:solidFill>
@@ -14176,7 +14909,7 @@
               </a:spcAft>
             </a:pPr>
             <a:r>
-              <a:rPr sz="1800">
+              <a:rPr sz="1300">
                 <a:solidFill>
                   <a:srgbClr val="6D8C97"/>
                 </a:solidFill>
@@ -14185,7 +14918,7 @@
               <a:t>  60  </a:t>
             </a:r>
             <a:r>
-              <a:rPr sz="1800">
+              <a:rPr sz="1300">
                 <a:solidFill>
                   <a:srgbClr val="6D8C97"/>
                 </a:solidFill>
@@ -14201,7 +14934,7 @@
               </a:spcAft>
             </a:pPr>
             <a:r>
-              <a:rPr sz="1800">
+              <a:rPr sz="1300">
                 <a:solidFill>
                   <a:srgbClr val="6D8C97"/>
                 </a:solidFill>
@@ -14210,7 +14943,7 @@
               <a:t>  61  </a:t>
             </a:r>
             <a:r>
-              <a:rPr sz="1800">
+              <a:rPr sz="1300">
                 <a:solidFill>
                   <a:srgbClr val="6D8C97"/>
                 </a:solidFill>
@@ -14226,7 +14959,7 @@
               </a:spcAft>
             </a:pPr>
             <a:r>
-              <a:rPr sz="1800">
+              <a:rPr sz="1300">
                 <a:solidFill>
                   <a:srgbClr val="6D8C97"/>
                 </a:solidFill>
@@ -14235,7 +14968,7 @@
               <a:t>  62  </a:t>
             </a:r>
             <a:r>
-              <a:rPr sz="1800">
+              <a:rPr sz="1300">
                 <a:solidFill>
                   <a:srgbClr val="6D8C97"/>
                 </a:solidFill>
@@ -14251,7 +14984,7 @@
               </a:spcAft>
             </a:pPr>
             <a:r>
-              <a:rPr sz="1800">
+              <a:rPr sz="1300">
                 <a:solidFill>
                   <a:srgbClr val="6D8C97"/>
                 </a:solidFill>
@@ -14260,7 +14993,7 @@
               <a:t>  63  </a:t>
             </a:r>
             <a:r>
-              <a:rPr sz="1800">
+              <a:rPr sz="1300">
                 <a:solidFill>
                   <a:srgbClr val="6D8C97"/>
                 </a:solidFill>
@@ -14276,7 +15009,7 @@
               </a:spcAft>
             </a:pPr>
             <a:r>
-              <a:rPr sz="1800">
+              <a:rPr sz="1300">
                 <a:solidFill>
                   <a:srgbClr val="6D8C97"/>
                 </a:solidFill>
@@ -14285,7 +15018,7 @@
               <a:t>  64  </a:t>
             </a:r>
             <a:r>
-              <a:rPr sz="1800">
+              <a:rPr sz="1300">
                 <a:solidFill>
                   <a:srgbClr val="6D8C97"/>
                 </a:solidFill>
@@ -14301,7 +15034,7 @@
               </a:spcAft>
             </a:pPr>
             <a:r>
-              <a:rPr sz="1800">
+              <a:rPr sz="1300">
                 <a:solidFill>
                   <a:srgbClr val="6D8C97"/>
                 </a:solidFill>
@@ -14310,7 +15043,7 @@
               <a:t>  65  </a:t>
             </a:r>
             <a:r>
-              <a:rPr sz="1800">
+              <a:rPr sz="1300">
                 <a:solidFill>
                   <a:srgbClr val="6D8C97"/>
                 </a:solidFill>
@@ -14326,7 +15059,7 @@
               </a:spcAft>
             </a:pPr>
             <a:r>
-              <a:rPr sz="1800">
+              <a:rPr sz="1300">
                 <a:solidFill>
                   <a:srgbClr val="6D8C97"/>
                 </a:solidFill>
@@ -14335,7 +15068,7 @@
               <a:t>  66  </a:t>
             </a:r>
             <a:r>
-              <a:rPr sz="1800">
+              <a:rPr sz="1300">
                 <a:solidFill>
                   <a:srgbClr val="6D8C97"/>
                 </a:solidFill>
@@ -14351,7 +15084,7 @@
               </a:spcAft>
             </a:pPr>
             <a:r>
-              <a:rPr sz="1800">
+              <a:rPr sz="1300">
                 <a:solidFill>
                   <a:srgbClr val="6D8C97"/>
                 </a:solidFill>
@@ -14360,7 +15093,7 @@
               <a:t>  67  </a:t>
             </a:r>
             <a:r>
-              <a:rPr sz="1800">
+              <a:rPr sz="1300">
                 <a:solidFill>
                   <a:srgbClr val="6D8C97"/>
                 </a:solidFill>
@@ -14376,7 +15109,7 @@
               </a:spcAft>
             </a:pPr>
             <a:r>
-              <a:rPr sz="1800">
+              <a:rPr sz="1300">
                 <a:solidFill>
                   <a:srgbClr val="6D8C97"/>
                 </a:solidFill>
@@ -14385,13 +15118,63 @@
               <a:t>  68  </a:t>
             </a:r>
             <a:r>
-              <a:rPr sz="1800">
+              <a:rPr sz="1300">
+                <a:solidFill>
+                  <a:srgbClr val="6D8C97"/>
+                </a:solidFill>
+                <a:latin typeface="Consolas"/>
+              </a:rPr>
+              <a:t>  const reply = await askAI(text);       // this is the slow bit</a:t>
+            </a:r>
+          </a:p>
+          <a:p>
+            <a:pPr>
+              <a:spcAft>
+                <a:spcPts val="0"/>
+              </a:spcAft>
+            </a:pPr>
+            <a:r>
+              <a:rPr sz="1300">
+                <a:solidFill>
+                  <a:srgbClr val="6D8C97"/>
+                </a:solidFill>
+                <a:latin typeface="Consolas"/>
+              </a:rPr>
+              <a:t>  69  </a:t>
+            </a:r>
+            <a:r>
+              <a:rPr sz="1300">
+                <a:solidFill>
+                  <a:srgbClr val="6D8C97"/>
+                </a:solidFill>
+                <a:latin typeface="Consolas"/>
+              </a:rPr>
+              <a:t>  chat.lastChild.remove();               // take the 'thinking' line away</a:t>
+            </a:r>
+          </a:p>
+          <a:p>
+            <a:pPr>
+              <a:spcAft>
+                <a:spcPts val="0"/>
+              </a:spcAft>
+            </a:pPr>
+            <a:r>
+              <a:rPr sz="1300">
+                <a:solidFill>
+                  <a:srgbClr val="6D8C97"/>
+                </a:solidFill>
+                <a:latin typeface="Consolas"/>
+              </a:rPr>
+              <a:t>  70  </a:t>
+            </a:r>
+            <a:r>
+              <a:rPr sz="1300">
                 <a:solidFill>
                   <a:srgbClr val="7FE0A0"/>
                 </a:solidFill>
                 <a:latin typeface="Consolas"/>
               </a:rPr>
-              <a:t>  const reply = await askAI(text);       // this is the slow bit</a:t>
+              <a:t>  addLine('Companion', reply);</a:t>
             </a:r>
           </a:p>
         </p:txBody>
@@ -14424,267 +15207,7 @@
                   <a:srgbClr val="DCECEF"/>
                 </a:solidFill>
               </a:rPr>
-              <a:t>await askAI(text): the slow bit - ask the AI and wait for the answer.</a:t>
-            </a:r>
-          </a:p>
-        </p:txBody>
-      </p:sp>
-    </p:spTree>
-  </p:cSld>
-  <p:clrMapOvr>
-    <a:masterClrMapping/>
-  </p:clrMapOvr>
-</p:sld>
-</file>
-
-<file path=ppt/slides/slide46.xml><?xml version="1.0" encoding="utf-8"?>
-<p:sld xmlns:a="http://schemas.openxmlformats.org/drawingml/2006/main" xmlns:p="http://schemas.openxmlformats.org/presentationml/2006/main" xmlns:r="http://schemas.openxmlformats.org/officeDocument/2006/relationships">
-  <p:cSld>
-    <p:spTree>
-      <p:nvGrpSpPr>
-        <p:cNvPr id="1" name=""/>
-        <p:cNvGrpSpPr/>
-        <p:nvPr/>
-      </p:nvGrpSpPr>
-      <p:grpSpPr/>
-      <p:sp>
-        <p:nvSpPr>
-          <p:cNvPr id="2" name="Title 1"/>
-          <p:cNvSpPr>
-            <a:spLocks noGrp="1"/>
-          </p:cNvSpPr>
-          <p:nvPr>
-            <p:ph type="title"/>
-          </p:nvPr>
-        </p:nvSpPr>
-        <p:spPr/>
-        <p:txBody>
-          <a:bodyPr/>
-          <a:lstStyle/>
-          <a:p>
-            <a:r>
-              <a:rPr sz="3800" b="1">
-                <a:solidFill>
-                  <a:srgbClr val="1F2A37"/>
-                </a:solidFill>
-              </a:rPr>
-              <a:t>.lastChild</a:t>
-            </a:r>
-          </a:p>
-        </p:txBody>
-      </p:sp>
-      <p:sp>
-        <p:nvSpPr>
-          <p:cNvPr id="3" name="TextBox 2"/>
-          <p:cNvSpPr txBox="1"/>
-          <p:nvPr/>
-        </p:nvSpPr>
-        <p:spPr>
-          <a:xfrm>
-            <a:off x="868680" y="502920"/>
-            <a:ext cx="5486400" cy="457200"/>
-          </a:xfrm>
-          <a:prstGeom prst="rect">
-            <a:avLst/>
-          </a:prstGeom>
-          <a:noFill/>
-        </p:spPr>
-        <p:txBody>
-          <a:bodyPr wrap="none">
-            <a:spAutoFit/>
-          </a:bodyPr>
-          <a:lstStyle/>
-          <a:p>
-            <a:r>
-              <a:rPr sz="1500" b="1">
-                <a:solidFill>
-                  <a:srgbClr val="01AEFD"/>
-                </a:solidFill>
-              </a:rPr>
-              <a:t>JAVASCRIPT</a:t>
-            </a:r>
-          </a:p>
-        </p:txBody>
-      </p:sp>
-      <p:sp>
-        <p:nvSpPr>
-          <p:cNvPr id="4" name="TextBox 3"/>
-          <p:cNvSpPr txBox="1"/>
-          <p:nvPr/>
-        </p:nvSpPr>
-        <p:spPr>
-          <a:xfrm>
-            <a:off x="822960" y="1828800"/>
-            <a:ext cx="10515600" cy="4206240"/>
-          </a:xfrm>
-          <a:prstGeom prst="rect">
-            <a:avLst/>
-          </a:prstGeom>
-          <a:noFill/>
-        </p:spPr>
-        <p:txBody>
-          <a:bodyPr wrap="square">
-            <a:spAutoFit/>
-          </a:bodyPr>
-          <a:lstStyle/>
-          <a:p>
-            <a:pPr>
-              <a:spcAft>
-                <a:spcPts val="1400"/>
-              </a:spcAft>
-            </a:pPr>
-            <a:r>
-              <a:rPr sz="2400">
-                <a:solidFill>
-                  <a:srgbClr val="1F2A37"/>
-                </a:solidFill>
-              </a:rPr>
-              <a:t>• A box's LAST child - the newest thing added inside it.</a:t>
-            </a:r>
-          </a:p>
-          <a:p>
-            <a:pPr>
-              <a:spcAft>
-                <a:spcPts val="1400"/>
-              </a:spcAft>
-            </a:pPr>
-            <a:r>
-              <a:rPr sz="2400">
-                <a:solidFill>
-                  <a:srgbClr val="1F2A37"/>
-                </a:solidFill>
-              </a:rPr>
-              <a:t>• chat.lastChild is the message you just put in.</a:t>
-            </a:r>
-          </a:p>
-        </p:txBody>
-      </p:sp>
-    </p:spTree>
-  </p:cSld>
-  <p:clrMapOvr>
-    <a:masterClrMapping/>
-  </p:clrMapOvr>
-</p:sld>
-</file>
-
-<file path=ppt/slides/slide47.xml><?xml version="1.0" encoding="utf-8"?>
-<p:sld xmlns:a="http://schemas.openxmlformats.org/drawingml/2006/main" xmlns:p="http://schemas.openxmlformats.org/presentationml/2006/main" xmlns:r="http://schemas.openxmlformats.org/officeDocument/2006/relationships">
-  <p:cSld>
-    <p:spTree>
-      <p:nvGrpSpPr>
-        <p:cNvPr id="1" name=""/>
-        <p:cNvGrpSpPr/>
-        <p:nvPr/>
-      </p:nvGrpSpPr>
-      <p:grpSpPr/>
-      <p:sp>
-        <p:nvSpPr>
-          <p:cNvPr id="2" name="Title 1"/>
-          <p:cNvSpPr>
-            <a:spLocks noGrp="1"/>
-          </p:cNvSpPr>
-          <p:nvPr>
-            <p:ph type="title"/>
-          </p:nvPr>
-        </p:nvSpPr>
-        <p:spPr/>
-        <p:txBody>
-          <a:bodyPr/>
-          <a:lstStyle/>
-          <a:p>
-            <a:r>
-              <a:rPr sz="3800" b="1">
-                <a:solidFill>
-                  <a:srgbClr val="1F2A37"/>
-                </a:solidFill>
-              </a:rPr>
-              <a:t>.remove()</a:t>
-            </a:r>
-          </a:p>
-        </p:txBody>
-      </p:sp>
-      <p:sp>
-        <p:nvSpPr>
-          <p:cNvPr id="3" name="TextBox 2"/>
-          <p:cNvSpPr txBox="1"/>
-          <p:nvPr/>
-        </p:nvSpPr>
-        <p:spPr>
-          <a:xfrm>
-            <a:off x="868680" y="502920"/>
-            <a:ext cx="5486400" cy="457200"/>
-          </a:xfrm>
-          <a:prstGeom prst="rect">
-            <a:avLst/>
-          </a:prstGeom>
-          <a:noFill/>
-        </p:spPr>
-        <p:txBody>
-          <a:bodyPr wrap="none">
-            <a:spAutoFit/>
-          </a:bodyPr>
-          <a:lstStyle/>
-          <a:p>
-            <a:r>
-              <a:rPr sz="1500" b="1">
-                <a:solidFill>
-                  <a:srgbClr val="01AEFD"/>
-                </a:solidFill>
-              </a:rPr>
-              <a:t>JAVASCRIPT</a:t>
-            </a:r>
-          </a:p>
-        </p:txBody>
-      </p:sp>
-      <p:sp>
-        <p:nvSpPr>
-          <p:cNvPr id="4" name="TextBox 3"/>
-          <p:cNvSpPr txBox="1"/>
-          <p:nvPr/>
-        </p:nvSpPr>
-        <p:spPr>
-          <a:xfrm>
-            <a:off x="822960" y="1828800"/>
-            <a:ext cx="10515600" cy="4206240"/>
-          </a:xfrm>
-          <a:prstGeom prst="rect">
-            <a:avLst/>
-          </a:prstGeom>
-          <a:noFill/>
-        </p:spPr>
-        <p:txBody>
-          <a:bodyPr wrap="square">
-            <a:spAutoFit/>
-          </a:bodyPr>
-          <a:lstStyle/>
-          <a:p>
-            <a:pPr>
-              <a:spcAft>
-                <a:spcPts val="1400"/>
-              </a:spcAft>
-            </a:pPr>
-            <a:r>
-              <a:rPr sz="2400">
-                <a:solidFill>
-                  <a:srgbClr val="1F2A37"/>
-                </a:solidFill>
-              </a:rPr>
-              <a:t>• Deletes an element from the page.</a:t>
-            </a:r>
-          </a:p>
-          <a:p>
-            <a:pPr>
-              <a:spcAft>
-                <a:spcPts val="1400"/>
-              </a:spcAft>
-            </a:pPr>
-            <a:r>
-              <a:rPr sz="2400">
-                <a:solidFill>
-                  <a:srgbClr val="1F2A37"/>
-                </a:solidFill>
-              </a:rPr>
-              <a:t>• chat.lastChild.remove() takes the last message back off.</a:t>
+              <a:t>Show the real reply in the chat.</a:t>
             </a:r>
           </a:p>
         </p:txBody>
@@ -14743,7 +15266,7 @@
                   <a:srgbClr val="01AEFD"/>
                 </a:solidFill>
               </a:rPr>
-              <a:t>Type this into script.js   -   line 69</a:t>
+              <a:t>All together in script.js</a:t>
             </a:r>
           </a:p>
         </p:txBody>
@@ -14787,7 +15310,7 @@
             <a:r>
               <a:rPr sz="1300">
                 <a:solidFill>
-                  <a:srgbClr val="6D8C97"/>
+                  <a:srgbClr val="7FE0A0"/>
                 </a:solidFill>
                 <a:latin typeface="Consolas"/>
               </a:rPr>
@@ -14812,7 +15335,7 @@
             <a:r>
               <a:rPr sz="1300">
                 <a:solidFill>
-                  <a:srgbClr val="6D8C97"/>
+                  <a:srgbClr val="7FE0A0"/>
                 </a:solidFill>
                 <a:latin typeface="Consolas"/>
               </a:rPr>
@@ -14837,7 +15360,7 @@
             <a:r>
               <a:rPr sz="1300">
                 <a:solidFill>
-                  <a:srgbClr val="6D8C97"/>
+                  <a:srgbClr val="7FE0A0"/>
                 </a:solidFill>
                 <a:latin typeface="Consolas"/>
               </a:rPr>
@@ -14862,7 +15385,7 @@
             <a:r>
               <a:rPr sz="1300">
                 <a:solidFill>
-                  <a:srgbClr val="6D8C97"/>
+                  <a:srgbClr val="7FE0A0"/>
                 </a:solidFill>
                 <a:latin typeface="Consolas"/>
               </a:rPr>
@@ -14887,7 +15410,7 @@
             <a:r>
               <a:rPr sz="1300">
                 <a:solidFill>
-                  <a:srgbClr val="6D8C97"/>
+                  <a:srgbClr val="7FE0A0"/>
                 </a:solidFill>
                 <a:latin typeface="Consolas"/>
               </a:rPr>
@@ -14912,7 +15435,7 @@
             <a:r>
               <a:rPr sz="1300">
                 <a:solidFill>
-                  <a:srgbClr val="6D8C97"/>
+                  <a:srgbClr val="7FE0A0"/>
                 </a:solidFill>
                 <a:latin typeface="Consolas"/>
               </a:rPr>
@@ -14937,7 +15460,7 @@
             <a:r>
               <a:rPr sz="1300">
                 <a:solidFill>
-                  <a:srgbClr val="6D8C97"/>
+                  <a:srgbClr val="7FE0A0"/>
                 </a:solidFill>
                 <a:latin typeface="Consolas"/>
               </a:rPr>
@@ -14962,7 +15485,7 @@
             <a:r>
               <a:rPr sz="1300">
                 <a:solidFill>
-                  <a:srgbClr val="6D8C97"/>
+                  <a:srgbClr val="7FE0A0"/>
                 </a:solidFill>
                 <a:latin typeface="Consolas"/>
               </a:rPr>
@@ -14987,7 +15510,7 @@
             <a:r>
               <a:rPr sz="1300">
                 <a:solidFill>
-                  <a:srgbClr val="6D8C97"/>
+                  <a:srgbClr val="7FE0A0"/>
                 </a:solidFill>
                 <a:latin typeface="Consolas"/>
               </a:rPr>
@@ -15012,7 +15535,7 @@
             <a:r>
               <a:rPr sz="1300">
                 <a:solidFill>
-                  <a:srgbClr val="6D8C97"/>
+                  <a:srgbClr val="7FE0A0"/>
                 </a:solidFill>
                 <a:latin typeface="Consolas"/>
               </a:rPr>
@@ -15042,6 +15565,56 @@
                 <a:latin typeface="Consolas"/>
               </a:rPr>
               <a:t>  chat.lastChild.remove();               // take the 'thinking' line away</a:t>
+            </a:r>
+          </a:p>
+          <a:p>
+            <a:pPr>
+              <a:spcAft>
+                <a:spcPts val="0"/>
+              </a:spcAft>
+            </a:pPr>
+            <a:r>
+              <a:rPr sz="1300">
+                <a:solidFill>
+                  <a:srgbClr val="6D8C97"/>
+                </a:solidFill>
+                <a:latin typeface="Consolas"/>
+              </a:rPr>
+              <a:t>  70  </a:t>
+            </a:r>
+            <a:r>
+              <a:rPr sz="1300">
+                <a:solidFill>
+                  <a:srgbClr val="7FE0A0"/>
+                </a:solidFill>
+                <a:latin typeface="Consolas"/>
+              </a:rPr>
+              <a:t>  addLine('Companion', reply);</a:t>
+            </a:r>
+          </a:p>
+          <a:p>
+            <a:pPr>
+              <a:spcAft>
+                <a:spcPts val="0"/>
+              </a:spcAft>
+            </a:pPr>
+            <a:r>
+              <a:rPr sz="1300">
+                <a:solidFill>
+                  <a:srgbClr val="6D8C97"/>
+                </a:solidFill>
+                <a:latin typeface="Consolas"/>
+              </a:rPr>
+              <a:t>  71  </a:t>
+            </a:r>
+            <a:r>
+              <a:rPr sz="1300">
+                <a:solidFill>
+                  <a:srgbClr val="7FE0A0"/>
+                </a:solidFill>
+                <a:latin typeface="Consolas"/>
+              </a:rPr>
+              <a:t>});</a:t>
             </a:r>
           </a:p>
         </p:txBody>
@@ -15074,7 +15647,7 @@
                   <a:srgbClr val="DCECEF"/>
                 </a:solidFill>
               </a:rPr>
-              <a:t>Remove the 'thinking...' line now the real answer is here.</a:t>
+              <a:t>That is the whole piece. Check yours looks the same before moving on.</a:t>
             </a:r>
           </a:p>
         </p:txBody>
@@ -15133,7 +15706,7 @@
                   <a:srgbClr val="01AEFD"/>
                 </a:solidFill>
               </a:rPr>
-              <a:t>Type this into script.js   -   line 70</a:t>
+              <a:t>In script.js   -   delete a line</a:t>
             </a:r>
           </a:p>
         </p:txBody>
@@ -15172,7 +15745,7 @@
                 </a:solidFill>
                 <a:latin typeface="Consolas"/>
               </a:rPr>
-              <a:t>  59  </a:t>
+              <a:t>  29  </a:t>
             </a:r>
             <a:r>
               <a:rPr sz="1300">
@@ -15197,266 +15770,241 @@
                 </a:solidFill>
                 <a:latin typeface="Consolas"/>
               </a:rPr>
-              <a:t>  60  </a:t>
-            </a:r>
-            <a:r>
-              <a:rPr sz="1300">
-                <a:solidFill>
-                  <a:srgbClr val="6D8C97"/>
-                </a:solidFill>
-                <a:latin typeface="Consolas"/>
-              </a:rPr>
-              <a:t>// The browser calls this when the form is submitted.</a:t>
-            </a:r>
-          </a:p>
-          <a:p>
-            <a:pPr>
-              <a:spcAft>
-                <a:spcPts val="0"/>
-              </a:spcAft>
-            </a:pPr>
-            <a:r>
-              <a:rPr sz="1300">
-                <a:solidFill>
-                  <a:srgbClr val="6D8C97"/>
-                </a:solidFill>
-                <a:latin typeface="Consolas"/>
-              </a:rPr>
-              <a:t>  61  </a:t>
-            </a:r>
-            <a:r>
-              <a:rPr sz="1300">
-                <a:solidFill>
-                  <a:srgbClr val="6D8C97"/>
-                </a:solidFill>
-                <a:latin typeface="Consolas"/>
-              </a:rPr>
-              <a:t>composer.addEventListener('submit', async function (event) {</a:t>
-            </a:r>
-          </a:p>
-          <a:p>
-            <a:pPr>
-              <a:spcAft>
-                <a:spcPts val="0"/>
-              </a:spcAft>
-            </a:pPr>
-            <a:r>
-              <a:rPr sz="1300">
-                <a:solidFill>
-                  <a:srgbClr val="6D8C97"/>
-                </a:solidFill>
-                <a:latin typeface="Consolas"/>
-              </a:rPr>
-              <a:t>  62  </a:t>
-            </a:r>
-            <a:r>
-              <a:rPr sz="1300">
-                <a:solidFill>
-                  <a:srgbClr val="6D8C97"/>
-                </a:solidFill>
-                <a:latin typeface="Consolas"/>
-              </a:rPr>
-              <a:t>  event.preventDefault();</a:t>
-            </a:r>
-          </a:p>
-          <a:p>
-            <a:pPr>
-              <a:spcAft>
-                <a:spcPts val="0"/>
-              </a:spcAft>
-            </a:pPr>
-            <a:r>
-              <a:rPr sz="1300">
-                <a:solidFill>
-                  <a:srgbClr val="6D8C97"/>
-                </a:solidFill>
-                <a:latin typeface="Consolas"/>
-              </a:rPr>
-              <a:t>  63  </a:t>
-            </a:r>
-            <a:r>
-              <a:rPr sz="1300">
-                <a:solidFill>
-                  <a:srgbClr val="6D8C97"/>
-                </a:solidFill>
-                <a:latin typeface="Consolas"/>
-              </a:rPr>
-              <a:t>  const text = promptBox.value.trim();</a:t>
-            </a:r>
-          </a:p>
-          <a:p>
-            <a:pPr>
-              <a:spcAft>
-                <a:spcPts val="0"/>
-              </a:spcAft>
-            </a:pPr>
-            <a:r>
-              <a:rPr sz="1300">
-                <a:solidFill>
-                  <a:srgbClr val="6D8C97"/>
-                </a:solidFill>
-                <a:latin typeface="Consolas"/>
-              </a:rPr>
-              <a:t>  64  </a:t>
-            </a:r>
-            <a:r>
-              <a:rPr sz="1300">
-                <a:solidFill>
-                  <a:srgbClr val="6D8C97"/>
-                </a:solidFill>
-                <a:latin typeface="Consolas"/>
-              </a:rPr>
-              <a:t>  if (text === '') { return; }</a:t>
-            </a:r>
-          </a:p>
-          <a:p>
-            <a:pPr>
-              <a:spcAft>
-                <a:spcPts val="0"/>
-              </a:spcAft>
-            </a:pPr>
-            <a:r>
-              <a:rPr sz="1300">
-                <a:solidFill>
-                  <a:srgbClr val="6D8C97"/>
-                </a:solidFill>
-                <a:latin typeface="Consolas"/>
-              </a:rPr>
-              <a:t>  65  </a:t>
-            </a:r>
-            <a:r>
-              <a:rPr sz="1300">
-                <a:solidFill>
-                  <a:srgbClr val="6D8C97"/>
-                </a:solidFill>
-                <a:latin typeface="Consolas"/>
-              </a:rPr>
-              <a:t>  promptBox.value = '';</a:t>
-            </a:r>
-          </a:p>
-          <a:p>
-            <a:pPr>
-              <a:spcAft>
-                <a:spcPts val="0"/>
-              </a:spcAft>
-            </a:pPr>
-            <a:r>
-              <a:rPr sz="1300">
-                <a:solidFill>
-                  <a:srgbClr val="6D8C97"/>
-                </a:solidFill>
-                <a:latin typeface="Consolas"/>
-              </a:rPr>
-              <a:t>  66  </a:t>
-            </a:r>
-            <a:r>
-              <a:rPr sz="1300">
-                <a:solidFill>
-                  <a:srgbClr val="6D8C97"/>
-                </a:solidFill>
-                <a:latin typeface="Consolas"/>
-              </a:rPr>
-              <a:t>  addLine('You', text);</a:t>
-            </a:r>
-          </a:p>
-          <a:p>
-            <a:pPr>
-              <a:spcAft>
-                <a:spcPts val="0"/>
-              </a:spcAft>
-            </a:pPr>
-            <a:r>
-              <a:rPr sz="1300">
-                <a:solidFill>
-                  <a:srgbClr val="6D8C97"/>
-                </a:solidFill>
-                <a:latin typeface="Consolas"/>
-              </a:rPr>
-              <a:t>  67  </a:t>
-            </a:r>
-            <a:r>
-              <a:rPr sz="1300">
-                <a:solidFill>
-                  <a:srgbClr val="6D8C97"/>
-                </a:solidFill>
-                <a:latin typeface="Consolas"/>
-              </a:rPr>
-              <a:t>  addLine('Companion', 'thinking...');</a:t>
-            </a:r>
-          </a:p>
-          <a:p>
-            <a:pPr>
-              <a:spcAft>
-                <a:spcPts val="0"/>
-              </a:spcAft>
-            </a:pPr>
-            <a:r>
-              <a:rPr sz="1300">
-                <a:solidFill>
-                  <a:srgbClr val="6D8C97"/>
-                </a:solidFill>
-                <a:latin typeface="Consolas"/>
-              </a:rPr>
-              <a:t>  68  </a:t>
-            </a:r>
-            <a:r>
-              <a:rPr sz="1300">
-                <a:solidFill>
-                  <a:srgbClr val="6D8C97"/>
-                </a:solidFill>
-                <a:latin typeface="Consolas"/>
-              </a:rPr>
-              <a:t>  const reply = await askAI(text);       // this is the slow bit</a:t>
-            </a:r>
-          </a:p>
-          <a:p>
-            <a:pPr>
-              <a:spcAft>
-                <a:spcPts val="0"/>
-              </a:spcAft>
-            </a:pPr>
-            <a:r>
-              <a:rPr sz="1300">
-                <a:solidFill>
-                  <a:srgbClr val="6D8C97"/>
-                </a:solidFill>
-                <a:latin typeface="Consolas"/>
-              </a:rPr>
-              <a:t>  69  </a:t>
-            </a:r>
-            <a:r>
-              <a:rPr sz="1300">
-                <a:solidFill>
-                  <a:srgbClr val="6D8C97"/>
-                </a:solidFill>
-                <a:latin typeface="Consolas"/>
-              </a:rPr>
-              <a:t>  chat.lastChild.remove();               // take the 'thinking' line away</a:t>
-            </a:r>
-          </a:p>
-          <a:p>
-            <a:pPr>
-              <a:spcAft>
-                <a:spcPts val="0"/>
-              </a:spcAft>
-            </a:pPr>
-            <a:r>
-              <a:rPr sz="1300">
-                <a:solidFill>
-                  <a:srgbClr val="6D8C97"/>
-                </a:solidFill>
-                <a:latin typeface="Consolas"/>
-              </a:rPr>
-              <a:t>  70  </a:t>
-            </a:r>
-            <a:r>
-              <a:rPr sz="1300">
-                <a:solidFill>
-                  <a:srgbClr val="7FE0A0"/>
-                </a:solidFill>
-                <a:latin typeface="Consolas"/>
-              </a:rPr>
-              <a:t>  addLine('Companion', reply);</a:t>
+              <a:t>  30  </a:t>
+            </a:r>
+            <a:r>
+              <a:rPr sz="1300">
+                <a:solidFill>
+                  <a:srgbClr val="6D8C97"/>
+                </a:solidFill>
+                <a:latin typeface="Consolas"/>
+              </a:rPr>
+              <a:t>// The smallest useful request: what models does this server have?</a:t>
+            </a:r>
+          </a:p>
+          <a:p>
+            <a:pPr>
+              <a:spcAft>
+                <a:spcPts val="0"/>
+              </a:spcAft>
+            </a:pPr>
+            <a:r>
+              <a:rPr sz="1300">
+                <a:solidFill>
+                  <a:srgbClr val="6D8C97"/>
+                </a:solidFill>
+                <a:latin typeface="Consolas"/>
+              </a:rPr>
+              <a:t>  31  </a:t>
+            </a:r>
+            <a:r>
+              <a:rPr sz="1300">
+                <a:solidFill>
+                  <a:srgbClr val="6D8C97"/>
+                </a:solidFill>
+                <a:latin typeface="Consolas"/>
+              </a:rPr>
+              <a:t>// 'async' means this function does something slow and can be waited for.</a:t>
+            </a:r>
+          </a:p>
+          <a:p>
+            <a:pPr>
+              <a:spcAft>
+                <a:spcPts val="0"/>
+              </a:spcAft>
+            </a:pPr>
+            <a:r>
+              <a:rPr sz="1300">
+                <a:solidFill>
+                  <a:srgbClr val="6D8C97"/>
+                </a:solidFill>
+                <a:latin typeface="Consolas"/>
+              </a:rPr>
+              <a:t>  32  </a:t>
+            </a:r>
+            <a:r>
+              <a:rPr sz="1300">
+                <a:solidFill>
+                  <a:srgbClr val="6D8C97"/>
+                </a:solidFill>
+                <a:latin typeface="Consolas"/>
+              </a:rPr>
+              <a:t>async function listModels() {</a:t>
+            </a:r>
+          </a:p>
+          <a:p>
+            <a:pPr>
+              <a:spcAft>
+                <a:spcPts val="0"/>
+              </a:spcAft>
+            </a:pPr>
+            <a:r>
+              <a:rPr sz="1300">
+                <a:solidFill>
+                  <a:srgbClr val="6D8C97"/>
+                </a:solidFill>
+                <a:latin typeface="Consolas"/>
+              </a:rPr>
+              <a:t>  33  </a:t>
+            </a:r>
+            <a:r>
+              <a:rPr sz="1300">
+                <a:solidFill>
+                  <a:srgbClr val="6D8C97"/>
+                </a:solidFill>
+                <a:latin typeface="Consolas"/>
+              </a:rPr>
+              <a:t>  const res = await fetch(AI_BASE + '/v1/models', {</a:t>
+            </a:r>
+          </a:p>
+          <a:p>
+            <a:pPr>
+              <a:spcAft>
+                <a:spcPts val="0"/>
+              </a:spcAft>
+            </a:pPr>
+            <a:r>
+              <a:rPr sz="1300">
+                <a:solidFill>
+                  <a:srgbClr val="6D8C97"/>
+                </a:solidFill>
+                <a:latin typeface="Consolas"/>
+              </a:rPr>
+              <a:t>  34  </a:t>
+            </a:r>
+            <a:r>
+              <a:rPr sz="1300">
+                <a:solidFill>
+                  <a:srgbClr val="6D8C97"/>
+                </a:solidFill>
+                <a:latin typeface="Consolas"/>
+              </a:rPr>
+              <a:t>    headers: { 'Authorization': 'Bearer ' + API_KEY }</a:t>
+            </a:r>
+          </a:p>
+          <a:p>
+            <a:pPr>
+              <a:spcAft>
+                <a:spcPts val="0"/>
+              </a:spcAft>
+            </a:pPr>
+            <a:r>
+              <a:rPr sz="1300">
+                <a:solidFill>
+                  <a:srgbClr val="6D8C97"/>
+                </a:solidFill>
+                <a:latin typeface="Consolas"/>
+              </a:rPr>
+              <a:t>  35  </a:t>
+            </a:r>
+            <a:r>
+              <a:rPr sz="1300">
+                <a:solidFill>
+                  <a:srgbClr val="6D8C97"/>
+                </a:solidFill>
+                <a:latin typeface="Consolas"/>
+              </a:rPr>
+              <a:t>  });</a:t>
+            </a:r>
+          </a:p>
+          <a:p>
+            <a:pPr>
+              <a:spcAft>
+                <a:spcPts val="0"/>
+              </a:spcAft>
+            </a:pPr>
+            <a:r>
+              <a:rPr sz="1300">
+                <a:solidFill>
+                  <a:srgbClr val="6D8C97"/>
+                </a:solidFill>
+                <a:latin typeface="Consolas"/>
+              </a:rPr>
+              <a:t>  36  </a:t>
+            </a:r>
+            <a:r>
+              <a:rPr sz="1300">
+                <a:solidFill>
+                  <a:srgbClr val="6D8C97"/>
+                </a:solidFill>
+                <a:latin typeface="Consolas"/>
+              </a:rPr>
+              <a:t>  const data = await res.json();   // the answer arrives as text; this reads it</a:t>
+            </a:r>
+          </a:p>
+          <a:p>
+            <a:pPr>
+              <a:spcAft>
+                <a:spcPts val="0"/>
+              </a:spcAft>
+            </a:pPr>
+            <a:r>
+              <a:rPr sz="1300">
+                <a:solidFill>
+                  <a:srgbClr val="6D8C97"/>
+                </a:solidFill>
+                <a:latin typeface="Consolas"/>
+              </a:rPr>
+              <a:t>  37  </a:t>
+            </a:r>
+            <a:r>
+              <a:rPr sz="1300">
+                <a:solidFill>
+                  <a:srgbClr val="6D8C97"/>
+                </a:solidFill>
+                <a:latin typeface="Consolas"/>
+              </a:rPr>
+              <a:t>  console.log('The server offers:', data.data);</a:t>
+            </a:r>
+          </a:p>
+          <a:p>
+            <a:pPr>
+              <a:spcAft>
+                <a:spcPts val="0"/>
+              </a:spcAft>
+            </a:pPr>
+            <a:r>
+              <a:rPr sz="1300">
+                <a:solidFill>
+                  <a:srgbClr val="6D8C97"/>
+                </a:solidFill>
+                <a:latin typeface="Consolas"/>
+              </a:rPr>
+              <a:t>  38  </a:t>
+            </a:r>
+            <a:r>
+              <a:rPr sz="1300">
+                <a:solidFill>
+                  <a:srgbClr val="6D8C97"/>
+                </a:solidFill>
+                <a:latin typeface="Consolas"/>
+              </a:rPr>
+              <a:t>}</a:t>
+            </a:r>
+          </a:p>
+          <a:p>
+            <a:pPr>
+              <a:spcAft>
+                <a:spcPts val="0"/>
+              </a:spcAft>
+            </a:pPr>
+            <a:r>
+              <a:rPr sz="1300">
+                <a:solidFill>
+                  <a:srgbClr val="6D8C97"/>
+                </a:solidFill>
+                <a:latin typeface="Consolas"/>
+              </a:rPr>
+              <a:t>  39  </a:t>
+            </a:r>
+            <a:r>
+              <a:rPr sz="1300" strike="sngStrike">
+                <a:solidFill>
+                  <a:srgbClr val="F3928B"/>
+                </a:solidFill>
+                <a:latin typeface="Consolas"/>
+              </a:rPr>
+              <a:t>listModels();</a:t>
             </a:r>
           </a:p>
         </p:txBody>
@@ -15489,7 +16037,7 @@
                   <a:srgbClr val="DCECEF"/>
                 </a:solidFill>
               </a:rPr>
-              <a:t>Show the real reply in the chat.</a:t>
+              <a:t>Delete this line. askAI does the asking now, so the old test call is no longer needed - your file should have no listModels() call left.</a:t>
             </a:r>
           </a:p>
         </p:txBody>
@@ -15670,836 +16218,6 @@
 <file path=ppt/slides/slide50.xml><?xml version="1.0" encoding="utf-8"?>
 <p:sld xmlns:a="http://schemas.openxmlformats.org/drawingml/2006/main" xmlns:p="http://schemas.openxmlformats.org/presentationml/2006/main" xmlns:r="http://schemas.openxmlformats.org/officeDocument/2006/relationships">
   <p:cSld>
-    <p:bg>
-      <p:bgPr>
-        <a:solidFill>
-          <a:srgbClr val="102127"/>
-        </a:solidFill>
-        <a:effectLst/>
-      </p:bgPr>
-    </p:bg>
-    <p:spTree>
-      <p:nvGrpSpPr>
-        <p:cNvPr id="1" name=""/>
-        <p:cNvGrpSpPr/>
-        <p:nvPr/>
-      </p:nvGrpSpPr>
-      <p:grpSpPr/>
-      <p:sp>
-        <p:nvSpPr>
-          <p:cNvPr id="2" name="TextBox 1"/>
-          <p:cNvSpPr txBox="1"/>
-          <p:nvPr/>
-        </p:nvSpPr>
-        <p:spPr>
-          <a:xfrm>
-            <a:off x="502920" y="274320"/>
-            <a:ext cx="11155680" cy="548640"/>
-          </a:xfrm>
-          <a:prstGeom prst="rect">
-            <a:avLst/>
-          </a:prstGeom>
-          <a:noFill/>
-        </p:spPr>
-        <p:txBody>
-          <a:bodyPr wrap="none">
-            <a:spAutoFit/>
-          </a:bodyPr>
-          <a:lstStyle/>
-          <a:p>
-            <a:r>
-              <a:rPr sz="2200" b="1">
-                <a:solidFill>
-                  <a:srgbClr val="01AEFD"/>
-                </a:solidFill>
-              </a:rPr>
-              <a:t>All together in script.js</a:t>
-            </a:r>
-          </a:p>
-        </p:txBody>
-      </p:sp>
-      <p:sp>
-        <p:nvSpPr>
-          <p:cNvPr id="3" name="TextBox 2"/>
-          <p:cNvSpPr txBox="1"/>
-          <p:nvPr/>
-        </p:nvSpPr>
-        <p:spPr>
-          <a:xfrm>
-            <a:off x="502920" y="960120"/>
-            <a:ext cx="11155680" cy="4297680"/>
-          </a:xfrm>
-          <a:prstGeom prst="rect">
-            <a:avLst/>
-          </a:prstGeom>
-          <a:noFill/>
-        </p:spPr>
-        <p:txBody>
-          <a:bodyPr wrap="none">
-            <a:spAutoFit/>
-          </a:bodyPr>
-          <a:lstStyle/>
-          <a:p>
-            <a:pPr>
-              <a:spcAft>
-                <a:spcPts val="0"/>
-              </a:spcAft>
-            </a:pPr>
-            <a:r>
-              <a:rPr sz="1300">
-                <a:solidFill>
-                  <a:srgbClr val="6D8C97"/>
-                </a:solidFill>
-                <a:latin typeface="Consolas"/>
-              </a:rPr>
-              <a:t>  59  </a:t>
-            </a:r>
-            <a:r>
-              <a:rPr sz="1300">
-                <a:solidFill>
-                  <a:srgbClr val="7FE0A0"/>
-                </a:solidFill>
-                <a:latin typeface="Consolas"/>
-              </a:rPr>
-              <a:t> </a:t>
-            </a:r>
-          </a:p>
-          <a:p>
-            <a:pPr>
-              <a:spcAft>
-                <a:spcPts val="0"/>
-              </a:spcAft>
-            </a:pPr>
-            <a:r>
-              <a:rPr sz="1300">
-                <a:solidFill>
-                  <a:srgbClr val="6D8C97"/>
-                </a:solidFill>
-                <a:latin typeface="Consolas"/>
-              </a:rPr>
-              <a:t>  60  </a:t>
-            </a:r>
-            <a:r>
-              <a:rPr sz="1300">
-                <a:solidFill>
-                  <a:srgbClr val="7FE0A0"/>
-                </a:solidFill>
-                <a:latin typeface="Consolas"/>
-              </a:rPr>
-              <a:t>// The browser calls this when the form is submitted.</a:t>
-            </a:r>
-          </a:p>
-          <a:p>
-            <a:pPr>
-              <a:spcAft>
-                <a:spcPts val="0"/>
-              </a:spcAft>
-            </a:pPr>
-            <a:r>
-              <a:rPr sz="1300">
-                <a:solidFill>
-                  <a:srgbClr val="6D8C97"/>
-                </a:solidFill>
-                <a:latin typeface="Consolas"/>
-              </a:rPr>
-              <a:t>  61  </a:t>
-            </a:r>
-            <a:r>
-              <a:rPr sz="1300">
-                <a:solidFill>
-                  <a:srgbClr val="7FE0A0"/>
-                </a:solidFill>
-                <a:latin typeface="Consolas"/>
-              </a:rPr>
-              <a:t>composer.addEventListener('submit', async function (event) {</a:t>
-            </a:r>
-          </a:p>
-          <a:p>
-            <a:pPr>
-              <a:spcAft>
-                <a:spcPts val="0"/>
-              </a:spcAft>
-            </a:pPr>
-            <a:r>
-              <a:rPr sz="1300">
-                <a:solidFill>
-                  <a:srgbClr val="6D8C97"/>
-                </a:solidFill>
-                <a:latin typeface="Consolas"/>
-              </a:rPr>
-              <a:t>  62  </a:t>
-            </a:r>
-            <a:r>
-              <a:rPr sz="1300">
-                <a:solidFill>
-                  <a:srgbClr val="7FE0A0"/>
-                </a:solidFill>
-                <a:latin typeface="Consolas"/>
-              </a:rPr>
-              <a:t>  event.preventDefault();</a:t>
-            </a:r>
-          </a:p>
-          <a:p>
-            <a:pPr>
-              <a:spcAft>
-                <a:spcPts val="0"/>
-              </a:spcAft>
-            </a:pPr>
-            <a:r>
-              <a:rPr sz="1300">
-                <a:solidFill>
-                  <a:srgbClr val="6D8C97"/>
-                </a:solidFill>
-                <a:latin typeface="Consolas"/>
-              </a:rPr>
-              <a:t>  63  </a:t>
-            </a:r>
-            <a:r>
-              <a:rPr sz="1300">
-                <a:solidFill>
-                  <a:srgbClr val="7FE0A0"/>
-                </a:solidFill>
-                <a:latin typeface="Consolas"/>
-              </a:rPr>
-              <a:t>  const text = promptBox.value.trim();</a:t>
-            </a:r>
-          </a:p>
-          <a:p>
-            <a:pPr>
-              <a:spcAft>
-                <a:spcPts val="0"/>
-              </a:spcAft>
-            </a:pPr>
-            <a:r>
-              <a:rPr sz="1300">
-                <a:solidFill>
-                  <a:srgbClr val="6D8C97"/>
-                </a:solidFill>
-                <a:latin typeface="Consolas"/>
-              </a:rPr>
-              <a:t>  64  </a:t>
-            </a:r>
-            <a:r>
-              <a:rPr sz="1300">
-                <a:solidFill>
-                  <a:srgbClr val="7FE0A0"/>
-                </a:solidFill>
-                <a:latin typeface="Consolas"/>
-              </a:rPr>
-              <a:t>  if (text === '') { return; }</a:t>
-            </a:r>
-          </a:p>
-          <a:p>
-            <a:pPr>
-              <a:spcAft>
-                <a:spcPts val="0"/>
-              </a:spcAft>
-            </a:pPr>
-            <a:r>
-              <a:rPr sz="1300">
-                <a:solidFill>
-                  <a:srgbClr val="6D8C97"/>
-                </a:solidFill>
-                <a:latin typeface="Consolas"/>
-              </a:rPr>
-              <a:t>  65  </a:t>
-            </a:r>
-            <a:r>
-              <a:rPr sz="1300">
-                <a:solidFill>
-                  <a:srgbClr val="7FE0A0"/>
-                </a:solidFill>
-                <a:latin typeface="Consolas"/>
-              </a:rPr>
-              <a:t>  promptBox.value = '';</a:t>
-            </a:r>
-          </a:p>
-          <a:p>
-            <a:pPr>
-              <a:spcAft>
-                <a:spcPts val="0"/>
-              </a:spcAft>
-            </a:pPr>
-            <a:r>
-              <a:rPr sz="1300">
-                <a:solidFill>
-                  <a:srgbClr val="6D8C97"/>
-                </a:solidFill>
-                <a:latin typeface="Consolas"/>
-              </a:rPr>
-              <a:t>  66  </a:t>
-            </a:r>
-            <a:r>
-              <a:rPr sz="1300">
-                <a:solidFill>
-                  <a:srgbClr val="7FE0A0"/>
-                </a:solidFill>
-                <a:latin typeface="Consolas"/>
-              </a:rPr>
-              <a:t>  addLine('You', text);</a:t>
-            </a:r>
-          </a:p>
-          <a:p>
-            <a:pPr>
-              <a:spcAft>
-                <a:spcPts val="0"/>
-              </a:spcAft>
-            </a:pPr>
-            <a:r>
-              <a:rPr sz="1300">
-                <a:solidFill>
-                  <a:srgbClr val="6D8C97"/>
-                </a:solidFill>
-                <a:latin typeface="Consolas"/>
-              </a:rPr>
-              <a:t>  67  </a:t>
-            </a:r>
-            <a:r>
-              <a:rPr sz="1300">
-                <a:solidFill>
-                  <a:srgbClr val="7FE0A0"/>
-                </a:solidFill>
-                <a:latin typeface="Consolas"/>
-              </a:rPr>
-              <a:t>  addLine('Companion', 'thinking...');</a:t>
-            </a:r>
-          </a:p>
-          <a:p>
-            <a:pPr>
-              <a:spcAft>
-                <a:spcPts val="0"/>
-              </a:spcAft>
-            </a:pPr>
-            <a:r>
-              <a:rPr sz="1300">
-                <a:solidFill>
-                  <a:srgbClr val="6D8C97"/>
-                </a:solidFill>
-                <a:latin typeface="Consolas"/>
-              </a:rPr>
-              <a:t>  68  </a:t>
-            </a:r>
-            <a:r>
-              <a:rPr sz="1300">
-                <a:solidFill>
-                  <a:srgbClr val="7FE0A0"/>
-                </a:solidFill>
-                <a:latin typeface="Consolas"/>
-              </a:rPr>
-              <a:t>  const reply = await askAI(text);       // this is the slow bit</a:t>
-            </a:r>
-          </a:p>
-          <a:p>
-            <a:pPr>
-              <a:spcAft>
-                <a:spcPts val="0"/>
-              </a:spcAft>
-            </a:pPr>
-            <a:r>
-              <a:rPr sz="1300">
-                <a:solidFill>
-                  <a:srgbClr val="6D8C97"/>
-                </a:solidFill>
-                <a:latin typeface="Consolas"/>
-              </a:rPr>
-              <a:t>  69  </a:t>
-            </a:r>
-            <a:r>
-              <a:rPr sz="1300">
-                <a:solidFill>
-                  <a:srgbClr val="7FE0A0"/>
-                </a:solidFill>
-                <a:latin typeface="Consolas"/>
-              </a:rPr>
-              <a:t>  chat.lastChild.remove();               // take the 'thinking' line away</a:t>
-            </a:r>
-          </a:p>
-          <a:p>
-            <a:pPr>
-              <a:spcAft>
-                <a:spcPts val="0"/>
-              </a:spcAft>
-            </a:pPr>
-            <a:r>
-              <a:rPr sz="1300">
-                <a:solidFill>
-                  <a:srgbClr val="6D8C97"/>
-                </a:solidFill>
-                <a:latin typeface="Consolas"/>
-              </a:rPr>
-              <a:t>  70  </a:t>
-            </a:r>
-            <a:r>
-              <a:rPr sz="1300">
-                <a:solidFill>
-                  <a:srgbClr val="7FE0A0"/>
-                </a:solidFill>
-                <a:latin typeface="Consolas"/>
-              </a:rPr>
-              <a:t>  addLine('Companion', reply);</a:t>
-            </a:r>
-          </a:p>
-          <a:p>
-            <a:pPr>
-              <a:spcAft>
-                <a:spcPts val="0"/>
-              </a:spcAft>
-            </a:pPr>
-            <a:r>
-              <a:rPr sz="1300">
-                <a:solidFill>
-                  <a:srgbClr val="6D8C97"/>
-                </a:solidFill>
-                <a:latin typeface="Consolas"/>
-              </a:rPr>
-              <a:t>  71  </a:t>
-            </a:r>
-            <a:r>
-              <a:rPr sz="1300">
-                <a:solidFill>
-                  <a:srgbClr val="7FE0A0"/>
-                </a:solidFill>
-                <a:latin typeface="Consolas"/>
-              </a:rPr>
-              <a:t>});</a:t>
-            </a:r>
-          </a:p>
-        </p:txBody>
-      </p:sp>
-      <p:sp>
-        <p:nvSpPr>
-          <p:cNvPr id="4" name="TextBox 3"/>
-          <p:cNvSpPr txBox="1"/>
-          <p:nvPr/>
-        </p:nvSpPr>
-        <p:spPr>
-          <a:xfrm>
-            <a:off x="548640" y="5623560"/>
-            <a:ext cx="11064240" cy="1051560"/>
-          </a:xfrm>
-          <a:prstGeom prst="rect">
-            <a:avLst/>
-          </a:prstGeom>
-          <a:noFill/>
-        </p:spPr>
-        <p:txBody>
-          <a:bodyPr wrap="square">
-            <a:spAutoFit/>
-          </a:bodyPr>
-          <a:lstStyle/>
-          <a:p>
-            <a:r>
-              <a:rPr sz="2000">
-                <a:solidFill>
-                  <a:srgbClr val="DCECEF"/>
-                </a:solidFill>
-              </a:rPr>
-              <a:t>That is the whole piece. Check yours looks the same before moving on.</a:t>
-            </a:r>
-          </a:p>
-        </p:txBody>
-      </p:sp>
-    </p:spTree>
-  </p:cSld>
-  <p:clrMapOvr>
-    <a:masterClrMapping/>
-  </p:clrMapOvr>
-</p:sld>
-</file>
-
-<file path=ppt/slides/slide51.xml><?xml version="1.0" encoding="utf-8"?>
-<p:sld xmlns:a="http://schemas.openxmlformats.org/drawingml/2006/main" xmlns:p="http://schemas.openxmlformats.org/presentationml/2006/main" xmlns:r="http://schemas.openxmlformats.org/officeDocument/2006/relationships">
-  <p:cSld>
-    <p:bg>
-      <p:bgPr>
-        <a:solidFill>
-          <a:srgbClr val="102127"/>
-        </a:solidFill>
-        <a:effectLst/>
-      </p:bgPr>
-    </p:bg>
-    <p:spTree>
-      <p:nvGrpSpPr>
-        <p:cNvPr id="1" name=""/>
-        <p:cNvGrpSpPr/>
-        <p:nvPr/>
-      </p:nvGrpSpPr>
-      <p:grpSpPr/>
-      <p:sp>
-        <p:nvSpPr>
-          <p:cNvPr id="2" name="TextBox 1"/>
-          <p:cNvSpPr txBox="1"/>
-          <p:nvPr/>
-        </p:nvSpPr>
-        <p:spPr>
-          <a:xfrm>
-            <a:off x="502920" y="274320"/>
-            <a:ext cx="11155680" cy="548640"/>
-          </a:xfrm>
-          <a:prstGeom prst="rect">
-            <a:avLst/>
-          </a:prstGeom>
-          <a:noFill/>
-        </p:spPr>
-        <p:txBody>
-          <a:bodyPr wrap="none">
-            <a:spAutoFit/>
-          </a:bodyPr>
-          <a:lstStyle/>
-          <a:p>
-            <a:r>
-              <a:rPr sz="2200" b="1">
-                <a:solidFill>
-                  <a:srgbClr val="01AEFD"/>
-                </a:solidFill>
-              </a:rPr>
-              <a:t>In script.js   -   delete a line</a:t>
-            </a:r>
-          </a:p>
-        </p:txBody>
-      </p:sp>
-      <p:sp>
-        <p:nvSpPr>
-          <p:cNvPr id="3" name="TextBox 2"/>
-          <p:cNvSpPr txBox="1"/>
-          <p:nvPr/>
-        </p:nvSpPr>
-        <p:spPr>
-          <a:xfrm>
-            <a:off x="502920" y="960120"/>
-            <a:ext cx="11155680" cy="4297680"/>
-          </a:xfrm>
-          <a:prstGeom prst="rect">
-            <a:avLst/>
-          </a:prstGeom>
-          <a:noFill/>
-        </p:spPr>
-        <p:txBody>
-          <a:bodyPr wrap="none">
-            <a:spAutoFit/>
-          </a:bodyPr>
-          <a:lstStyle/>
-          <a:p>
-            <a:pPr>
-              <a:spcAft>
-                <a:spcPts val="0"/>
-              </a:spcAft>
-            </a:pPr>
-            <a:r>
-              <a:rPr sz="1300">
-                <a:solidFill>
-                  <a:srgbClr val="6D8C97"/>
-                </a:solidFill>
-                <a:latin typeface="Consolas"/>
-              </a:rPr>
-              <a:t>  29  </a:t>
-            </a:r>
-            <a:r>
-              <a:rPr sz="1300">
-                <a:solidFill>
-                  <a:srgbClr val="6D8C97"/>
-                </a:solidFill>
-                <a:latin typeface="Consolas"/>
-              </a:rPr>
-              <a:t> </a:t>
-            </a:r>
-          </a:p>
-          <a:p>
-            <a:pPr>
-              <a:spcAft>
-                <a:spcPts val="0"/>
-              </a:spcAft>
-            </a:pPr>
-            <a:r>
-              <a:rPr sz="1300">
-                <a:solidFill>
-                  <a:srgbClr val="6D8C97"/>
-                </a:solidFill>
-                <a:latin typeface="Consolas"/>
-              </a:rPr>
-              <a:t>  30  </a:t>
-            </a:r>
-            <a:r>
-              <a:rPr sz="1300">
-                <a:solidFill>
-                  <a:srgbClr val="6D8C97"/>
-                </a:solidFill>
-                <a:latin typeface="Consolas"/>
-              </a:rPr>
-              <a:t>// The smallest useful request: what models does this server have?</a:t>
-            </a:r>
-          </a:p>
-          <a:p>
-            <a:pPr>
-              <a:spcAft>
-                <a:spcPts val="0"/>
-              </a:spcAft>
-            </a:pPr>
-            <a:r>
-              <a:rPr sz="1300">
-                <a:solidFill>
-                  <a:srgbClr val="6D8C97"/>
-                </a:solidFill>
-                <a:latin typeface="Consolas"/>
-              </a:rPr>
-              <a:t>  31  </a:t>
-            </a:r>
-            <a:r>
-              <a:rPr sz="1300">
-                <a:solidFill>
-                  <a:srgbClr val="6D8C97"/>
-                </a:solidFill>
-                <a:latin typeface="Consolas"/>
-              </a:rPr>
-              <a:t>// 'async' means this function does something slow and can be waited for.</a:t>
-            </a:r>
-          </a:p>
-          <a:p>
-            <a:pPr>
-              <a:spcAft>
-                <a:spcPts val="0"/>
-              </a:spcAft>
-            </a:pPr>
-            <a:r>
-              <a:rPr sz="1300">
-                <a:solidFill>
-                  <a:srgbClr val="6D8C97"/>
-                </a:solidFill>
-                <a:latin typeface="Consolas"/>
-              </a:rPr>
-              <a:t>  32  </a:t>
-            </a:r>
-            <a:r>
-              <a:rPr sz="1300">
-                <a:solidFill>
-                  <a:srgbClr val="6D8C97"/>
-                </a:solidFill>
-                <a:latin typeface="Consolas"/>
-              </a:rPr>
-              <a:t>async function listModels() {</a:t>
-            </a:r>
-          </a:p>
-          <a:p>
-            <a:pPr>
-              <a:spcAft>
-                <a:spcPts val="0"/>
-              </a:spcAft>
-            </a:pPr>
-            <a:r>
-              <a:rPr sz="1300">
-                <a:solidFill>
-                  <a:srgbClr val="6D8C97"/>
-                </a:solidFill>
-                <a:latin typeface="Consolas"/>
-              </a:rPr>
-              <a:t>  33  </a:t>
-            </a:r>
-            <a:r>
-              <a:rPr sz="1300">
-                <a:solidFill>
-                  <a:srgbClr val="6D8C97"/>
-                </a:solidFill>
-                <a:latin typeface="Consolas"/>
-              </a:rPr>
-              <a:t>  const res = await fetch(AI_BASE + '/v1/models', {</a:t>
-            </a:r>
-          </a:p>
-          <a:p>
-            <a:pPr>
-              <a:spcAft>
-                <a:spcPts val="0"/>
-              </a:spcAft>
-            </a:pPr>
-            <a:r>
-              <a:rPr sz="1300">
-                <a:solidFill>
-                  <a:srgbClr val="6D8C97"/>
-                </a:solidFill>
-                <a:latin typeface="Consolas"/>
-              </a:rPr>
-              <a:t>  34  </a:t>
-            </a:r>
-            <a:r>
-              <a:rPr sz="1300">
-                <a:solidFill>
-                  <a:srgbClr val="6D8C97"/>
-                </a:solidFill>
-                <a:latin typeface="Consolas"/>
-              </a:rPr>
-              <a:t>    headers: { 'Authorization': 'Bearer ' + API_KEY }</a:t>
-            </a:r>
-          </a:p>
-          <a:p>
-            <a:pPr>
-              <a:spcAft>
-                <a:spcPts val="0"/>
-              </a:spcAft>
-            </a:pPr>
-            <a:r>
-              <a:rPr sz="1300">
-                <a:solidFill>
-                  <a:srgbClr val="6D8C97"/>
-                </a:solidFill>
-                <a:latin typeface="Consolas"/>
-              </a:rPr>
-              <a:t>  35  </a:t>
-            </a:r>
-            <a:r>
-              <a:rPr sz="1300">
-                <a:solidFill>
-                  <a:srgbClr val="6D8C97"/>
-                </a:solidFill>
-                <a:latin typeface="Consolas"/>
-              </a:rPr>
-              <a:t>  });</a:t>
-            </a:r>
-          </a:p>
-          <a:p>
-            <a:pPr>
-              <a:spcAft>
-                <a:spcPts val="0"/>
-              </a:spcAft>
-            </a:pPr>
-            <a:r>
-              <a:rPr sz="1300">
-                <a:solidFill>
-                  <a:srgbClr val="6D8C97"/>
-                </a:solidFill>
-                <a:latin typeface="Consolas"/>
-              </a:rPr>
-              <a:t>  36  </a:t>
-            </a:r>
-            <a:r>
-              <a:rPr sz="1300">
-                <a:solidFill>
-                  <a:srgbClr val="6D8C97"/>
-                </a:solidFill>
-                <a:latin typeface="Consolas"/>
-              </a:rPr>
-              <a:t>  const data = await res.json();   // the answer arrives as text; this reads it</a:t>
-            </a:r>
-          </a:p>
-          <a:p>
-            <a:pPr>
-              <a:spcAft>
-                <a:spcPts val="0"/>
-              </a:spcAft>
-            </a:pPr>
-            <a:r>
-              <a:rPr sz="1300">
-                <a:solidFill>
-                  <a:srgbClr val="6D8C97"/>
-                </a:solidFill>
-                <a:latin typeface="Consolas"/>
-              </a:rPr>
-              <a:t>  37  </a:t>
-            </a:r>
-            <a:r>
-              <a:rPr sz="1300">
-                <a:solidFill>
-                  <a:srgbClr val="6D8C97"/>
-                </a:solidFill>
-                <a:latin typeface="Consolas"/>
-              </a:rPr>
-              <a:t>  console.log('The server offers:', data.data);</a:t>
-            </a:r>
-          </a:p>
-          <a:p>
-            <a:pPr>
-              <a:spcAft>
-                <a:spcPts val="0"/>
-              </a:spcAft>
-            </a:pPr>
-            <a:r>
-              <a:rPr sz="1300">
-                <a:solidFill>
-                  <a:srgbClr val="6D8C97"/>
-                </a:solidFill>
-                <a:latin typeface="Consolas"/>
-              </a:rPr>
-              <a:t>  38  </a:t>
-            </a:r>
-            <a:r>
-              <a:rPr sz="1300">
-                <a:solidFill>
-                  <a:srgbClr val="6D8C97"/>
-                </a:solidFill>
-                <a:latin typeface="Consolas"/>
-              </a:rPr>
-              <a:t>}</a:t>
-            </a:r>
-          </a:p>
-          <a:p>
-            <a:pPr>
-              <a:spcAft>
-                <a:spcPts val="0"/>
-              </a:spcAft>
-            </a:pPr>
-            <a:r>
-              <a:rPr sz="1300">
-                <a:solidFill>
-                  <a:srgbClr val="6D8C97"/>
-                </a:solidFill>
-                <a:latin typeface="Consolas"/>
-              </a:rPr>
-              <a:t>  39  </a:t>
-            </a:r>
-            <a:r>
-              <a:rPr sz="1300" strike="sngStrike">
-                <a:solidFill>
-                  <a:srgbClr val="F3928B"/>
-                </a:solidFill>
-                <a:latin typeface="Consolas"/>
-              </a:rPr>
-              <a:t>listModels();</a:t>
-            </a:r>
-          </a:p>
-        </p:txBody>
-      </p:sp>
-      <p:sp>
-        <p:nvSpPr>
-          <p:cNvPr id="4" name="TextBox 3"/>
-          <p:cNvSpPr txBox="1"/>
-          <p:nvPr/>
-        </p:nvSpPr>
-        <p:spPr>
-          <a:xfrm>
-            <a:off x="548640" y="5623560"/>
-            <a:ext cx="11064240" cy="1051560"/>
-          </a:xfrm>
-          <a:prstGeom prst="rect">
-            <a:avLst/>
-          </a:prstGeom>
-          <a:noFill/>
-        </p:spPr>
-        <p:txBody>
-          <a:bodyPr wrap="square">
-            <a:spAutoFit/>
-          </a:bodyPr>
-          <a:lstStyle/>
-          <a:p>
-            <a:r>
-              <a:rPr sz="2000">
-                <a:solidFill>
-                  <a:srgbClr val="DCECEF"/>
-                </a:solidFill>
-              </a:rPr>
-              <a:t>Delete this line. askAI does the asking now, so the old test call is no longer needed - your file should have no listModels() call left.</a:t>
-            </a:r>
-          </a:p>
-        </p:txBody>
-      </p:sp>
-    </p:spTree>
-  </p:cSld>
-  <p:clrMapOvr>
-    <a:masterClrMapping/>
-  </p:clrMapOvr>
-</p:sld>
-</file>
-
-<file path=ppt/slides/slide52.xml><?xml version="1.0" encoding="utf-8"?>
-<p:sld xmlns:a="http://schemas.openxmlformats.org/drawingml/2006/main" xmlns:p="http://schemas.openxmlformats.org/presentationml/2006/main" xmlns:r="http://schemas.openxmlformats.org/officeDocument/2006/relationships">
-  <p:cSld>
     <p:spTree>
       <p:nvGrpSpPr>
         <p:cNvPr id="1" name=""/>
@@ -16642,7 +16360,7 @@
 </p:sld>
 </file>
 
-<file path=ppt/slides/slide53.xml><?xml version="1.0" encoding="utf-8"?>
+<file path=ppt/slides/slide51.xml><?xml version="1.0" encoding="utf-8"?>
 <p:sld xmlns:a="http://schemas.openxmlformats.org/drawingml/2006/main" xmlns:p="http://schemas.openxmlformats.org/presentationml/2006/main" xmlns:r="http://schemas.openxmlformats.org/officeDocument/2006/relationships">
   <p:cSld>
     <p:spTree>

</xml_diff>